<commit_message>
slides: update metrics for run #9
- mdxDocs: 267 → 269 (reference/glossary.mdx + docs-vnext/glossary.mdx added)
- agenticWorkflows: 25 → 26 (reddit-community-monitor.md added)
- slashCommands: 5 → 6 (/check-reddit added)
- docSections: 14 → 15 (reference section now populated)
- Community workflow card: count 3 → 4, updated description to mention Reddit monitor
- Architecture slide: fix hardcoded '267 MDX pages' to use DATA.mdxDocs dynamically
- sections list: add Reference (1 page)

Co-authored-by: Copilot <223556219+Copilot@users.noreply.github.com>
</commit_message>
<xml_diff>
--- a/slides/foundry-docs-overview.pptx
+++ b/slides/foundry-docs-overview.pptx
@@ -177,50 +177,53 @@
           </c:dLbls>
           <c:cat>
             <c:multiLvlStrRef>
-              <c:f>Sheet1!$A$2:$A$15</c:f>
+              <c:f>Sheet1!$A$2:$A$16</c:f>
               <c:multiLvlStrCache>
-                <c:ptCount val="14"/>
+                <c:ptCount val="15"/>
                 <c:lvl>
                   <c:pt idx="0">
+                    <c:v>Reference</c:v>
+                  </c:pt>
+                  <c:pt idx="1">
                     <c:v>Overview</c:v>
                   </c:pt>
-                  <c:pt idx="1">
+                  <c:pt idx="2">
                     <c:v>Get Started</c:v>
                   </c:pt>
-                  <c:pt idx="2">
+                  <c:pt idx="3">
                     <c:v>Best Practices</c:v>
                   </c:pt>
-                  <c:pt idx="3">
+                  <c:pt idx="4">
                     <c:v>Operate</c:v>
                   </c:pt>
-                  <c:pt idx="4">
+                  <c:pt idx="5">
                     <c:v>Responsible AI</c:v>
                   </c:pt>
-                  <c:pt idx="5">
+                  <c:pt idx="6">
                     <c:v>Manage</c:v>
                   </c:pt>
-                  <c:pt idx="6">
+                  <c:pt idx="7">
                     <c:v>Dev Experience</c:v>
                   </c:pt>
-                  <c:pt idx="7">
+                  <c:pt idx="8">
                     <c:v>API &amp; SDK</c:v>
                   </c:pt>
-                  <c:pt idx="8">
+                  <c:pt idx="9">
                     <c:v>Guardrails</c:v>
                   </c:pt>
-                  <c:pt idx="9">
+                  <c:pt idx="10">
                     <c:v>Security</c:v>
                   </c:pt>
-                  <c:pt idx="10">
+                  <c:pt idx="11">
                     <c:v>Setup</c:v>
                   </c:pt>
-                  <c:pt idx="11">
+                  <c:pt idx="12">
                     <c:v>Observability</c:v>
                   </c:pt>
-                  <c:pt idx="12">
+                  <c:pt idx="13">
                     <c:v>Agents</c:v>
                   </c:pt>
-                  <c:pt idx="13">
+                  <c:pt idx="14">
                     <c:v>Models</c:v>
                   </c:pt>
                 </c:lvl>
@@ -229,50 +232,53 @@
           </c:cat>
           <c:val>
             <c:numRef>
-              <c:f>Sheet1!$B$2:$B$15</c:f>
+              <c:f>Sheet1!$B$2:$B$16</c:f>
               <c:numCache>
                 <c:formatCode>General</c:formatCode>
-                <c:ptCount val="14"/>
+                <c:ptCount val="15"/>
                 <c:pt idx="0">
                   <c:v>1</c:v>
                 </c:pt>
                 <c:pt idx="1">
+                  <c:v>1</c:v>
+                </c:pt>
+                <c:pt idx="2">
                   <c:v>4</c:v>
                 </c:pt>
-                <c:pt idx="2">
+                <c:pt idx="3">
                   <c:v>5</c:v>
                 </c:pt>
-                <c:pt idx="3">
+                <c:pt idx="4">
                   <c:v>7</c:v>
                 </c:pt>
-                <c:pt idx="4">
+                <c:pt idx="5">
                   <c:v>8</c:v>
                 </c:pt>
-                <c:pt idx="5">
+                <c:pt idx="6">
                   <c:v>9</c:v>
                 </c:pt>
-                <c:pt idx="6">
+                <c:pt idx="7">
                   <c:v>11</c:v>
                 </c:pt>
-                <c:pt idx="7">
+                <c:pt idx="8">
                   <c:v>14</c:v>
                 </c:pt>
-                <c:pt idx="8">
+                <c:pt idx="9">
                   <c:v>15</c:v>
-                </c:pt>
-                <c:pt idx="9">
-                  <c:v>20</c:v>
                 </c:pt>
                 <c:pt idx="10">
                   <c:v>20</c:v>
                 </c:pt>
                 <c:pt idx="11">
+                  <c:v>20</c:v>
+                </c:pt>
+                <c:pt idx="12">
                   <c:v>24</c:v>
                 </c:pt>
-                <c:pt idx="12">
+                <c:pt idx="13">
                   <c:v>57</c:v>
                 </c:pt>
-                <c:pt idx="13">
+                <c:pt idx="14">
                   <c:v>72</c:v>
                 </c:pt>
               </c:numCache>
@@ -2298,7 +2304,7 @@
                 <a:ea typeface="Calibri" pitchFamily="34" charset="-122"/>
                 <a:cs typeface="Calibri" pitchFamily="34" charset="-120"/>
               </a:rPr>
-              <a:t>267 docs  ·  25 agentic workflows  ·  4 SDK repos monitored  ·  FastMCP server</a:t>
+              <a:t>269 docs  ·  26 agentic workflows  ·  4 SDK repos monitored  ·  FastMCP server</a:t>
             </a:r>
             <a:endParaRPr lang="en-US" sz="1300" dirty="0"/>
           </a:p>
@@ -2489,7 +2495,7 @@
                 <a:ea typeface="Trebuchet MS" pitchFamily="34" charset="-122"/>
                 <a:cs typeface="Trebuchet MS" pitchFamily="34" charset="-120"/>
               </a:rPr>
-              <a:t>267</a:t>
+              <a:t>269</a:t>
             </a:r>
             <a:endParaRPr lang="en-US" sz="5200" dirty="0"/>
           </a:p>
@@ -2662,7 +2668,7 @@
                 <a:ea typeface="Trebuchet MS" pitchFamily="34" charset="-122"/>
                 <a:cs typeface="Trebuchet MS" pitchFamily="34" charset="-120"/>
               </a:rPr>
-              <a:t>25</a:t>
+              <a:t>26</a:t>
             </a:r>
             <a:endParaRPr lang="en-US" sz="5200" dirty="0"/>
           </a:p>
@@ -2835,7 +2841,7 @@
                 <a:ea typeface="Trebuchet MS" pitchFamily="34" charset="-122"/>
                 <a:cs typeface="Trebuchet MS" pitchFamily="34" charset="-120"/>
               </a:rPr>
-              <a:t>14</a:t>
+              <a:t>15</a:t>
             </a:r>
             <a:endParaRPr lang="en-US" sz="5200" dirty="0"/>
           </a:p>
@@ -3008,7 +3014,7 @@
                 <a:ea typeface="Trebuchet MS" pitchFamily="34" charset="-122"/>
                 <a:cs typeface="Trebuchet MS" pitchFamily="34" charset="-120"/>
               </a:rPr>
-              <a:t>5</a:t>
+              <a:t>6</a:t>
             </a:r>
             <a:endParaRPr lang="en-US" sz="5200" dirty="0"/>
           </a:p>
@@ -3086,7 +3092,7 @@
                 <a:ea typeface="Calibri" pitchFamily="34" charset="-122"/>
                 <a:cs typeface="Calibri" pitchFamily="34" charset="-120"/>
               </a:rPr>
-              <a:t>/audit /unbloat /sdk-check…</a:t>
+              <a:t>/audit /unbloat /check-reddit…</a:t>
             </a:r>
             <a:endParaRPr lang="en-US" sz="1050" dirty="0"/>
           </a:p>
@@ -5011,7 +5017,7 @@
                 <a:ea typeface="Trebuchet MS" pitchFamily="34" charset="-122"/>
                 <a:cs typeface="Trebuchet MS" pitchFamily="34" charset="-120"/>
               </a:rPr>
-              <a:t>267</a:t>
+              <a:t>269</a:t>
             </a:r>
             <a:endParaRPr lang="en-US" sz="2600" dirty="0"/>
           </a:p>
@@ -5114,7 +5120,7 @@
                 <a:ea typeface="Trebuchet MS" pitchFamily="34" charset="-122"/>
                 <a:cs typeface="Trebuchet MS" pitchFamily="34" charset="-120"/>
               </a:rPr>
-              <a:t>14</a:t>
+              <a:t>15</a:t>
             </a:r>
             <a:endParaRPr lang="en-US" sz="2600" dirty="0"/>
           </a:p>
@@ -5812,7 +5818,7 @@
                 <a:ea typeface="Calibri" pitchFamily="34" charset="-122"/>
                 <a:cs typeface="Calibri" pitchFamily="34" charset="-120"/>
               </a:rPr>
-              <a:t>267 MDX pages</a:t>
+              <a:t>269 MDX pages</a:t>
             </a:r>
             <a:endParaRPr lang="en-US" sz="1000" dirty="0"/>
           </a:p>
@@ -6510,7 +6516,7 @@
                 <a:ea typeface="Trebuchet MS" pitchFamily="34" charset="-122"/>
                 <a:cs typeface="Trebuchet MS" pitchFamily="34" charset="-120"/>
               </a:rPr>
-              <a:t>Documentation Coverage — 267 Pages Across 14 Sections</a:t>
+              <a:t>Documentation Coverage — 269 Pages Across 15 Sections</a:t>
             </a:r>
             <a:endParaRPr lang="en-US" sz="3000" dirty="0"/>
           </a:p>
@@ -6622,7 +6628,7 @@
                 <a:ea typeface="Trebuchet MS" pitchFamily="34" charset="-122"/>
                 <a:cs typeface="Trebuchet MS" pitchFamily="34" charset="-120"/>
               </a:rPr>
-              <a:t>25 Agentic Workflows</a:t>
+              <a:t>26 Agentic Workflows</a:t>
             </a:r>
             <a:endParaRPr lang="en-US" sz="4000" dirty="0"/>
           </a:p>
@@ -7485,7 +7491,7 @@
                 <a:ea typeface="Trebuchet MS" pitchFamily="34" charset="-122"/>
                 <a:cs typeface="Trebuchet MS" pitchFamily="34" charset="-120"/>
               </a:rPr>
-              <a:t>3  Community</a:t>
+              <a:t>4  Community</a:t>
             </a:r>
             <a:endParaRPr lang="en-US" sz="1450" dirty="0"/>
           </a:p>
@@ -7524,7 +7530,7 @@
                 <a:ea typeface="Calibri" pitchFamily="34" charset="-122"/>
                 <a:cs typeface="Calibri" pitchFamily="34" charset="-120"/>
               </a:rPr>
-              <a:t>Discussion monitor,</a:t>
+              <a:t>Discussion monitor, Reddit</a:t>
             </a:r>
             <a:endParaRPr lang="en-US" sz="1150" dirty="0"/>
           </a:p>
@@ -7541,7 +7547,7 @@
                 <a:ea typeface="Calibri" pitchFamily="34" charset="-122"/>
                 <a:cs typeface="Calibri" pitchFamily="34" charset="-120"/>
               </a:rPr>
-              <a:t>responder, auto-triage</a:t>
+              <a:t>monitor, responder, triage</a:t>
             </a:r>
             <a:endParaRPr lang="en-US" sz="1150" dirty="0"/>
           </a:p>
@@ -7908,7 +7914,7 @@
                 <a:ea typeface="Trebuchet MS" pitchFamily="34" charset="-122"/>
                 <a:cs typeface="Trebuchet MS" pitchFamily="34" charset="-120"/>
               </a:rPr>
-              <a:t>24</a:t>
+              <a:t>25</a:t>
             </a:r>
             <a:endParaRPr lang="en-US" sz="5200" dirty="0"/>
           </a:p>
@@ -8081,7 +8087,7 @@
                 <a:ea typeface="Trebuchet MS" pitchFamily="34" charset="-122"/>
                 <a:cs typeface="Trebuchet MS" pitchFamily="34" charset="-120"/>
               </a:rPr>
-              <a:t>19</a:t>
+              <a:t>20</a:t>
             </a:r>
             <a:endParaRPr lang="en-US" sz="5200" dirty="0"/>
           </a:p>
@@ -8773,7 +8779,7 @@
                 <a:ea typeface="Trebuchet MS" pitchFamily="34" charset="-122"/>
                 <a:cs typeface="Trebuchet MS" pitchFamily="34" charset="-120"/>
               </a:rPr>
-              <a:t>1</a:t>
+              <a:t>3</a:t>
             </a:r>
             <a:endParaRPr lang="en-US" sz="5200" dirty="0"/>
           </a:p>

</xml_diff>

<commit_message>
slides: update deck with fresh repo metrics (run #16)
- mdxDocs: 274 → 279
- agents section: 57 → 60 pages
- agenticWorkflows: 26 → 23 (main non-shared .md workflows)
- totalWorkflows: 31 → 29 (.md files)
- workflowChains: 4 → 3 (workflow_run triggers)
- scheduleWorkflows: 12 → 11
- issueWorkflows: 25 → 22
- dispatchWorkflows: 22 → 19
- prWorkflows: 3 → 7
- pushWorkflows: 1 → 0
- docSections: 16 → 15 (removed standalone Glossary, now under Reference)
- get-started section: 4 → 6 pages
- operate section: 7 → 8 pages
- Removed Glossary as separate section (merged into Reference)
- Updated hardcoded '274 MDX pages' label in architecture slide

Co-authored-by: Copilot <223556219+Copilot@users.noreply.github.com>
</commit_message>
<xml_diff>
--- a/slides/foundry-docs-overview.pptx
+++ b/slides/foundry-docs-overview.pptx
@@ -178,56 +178,53 @@
           </c:dLbls>
           <c:cat>
             <c:multiLvlStrRef>
-              <c:f>Sheet1!$A$2:$A$17</c:f>
+              <c:f>Sheet1!$A$2:$A$16</c:f>
               <c:multiLvlStrCache>
-                <c:ptCount val="16"/>
+                <c:ptCount val="15"/>
                 <c:lvl>
                   <c:pt idx="0">
-                    <c:v>Glossary</c:v>
+                    <c:v>Reference</c:v>
                   </c:pt>
                   <c:pt idx="1">
-                    <c:v>Reference</c:v>
+                    <c:v>Overview</c:v>
                   </c:pt>
                   <c:pt idx="2">
-                    <c:v>Overview</c:v>
+                    <c:v>Get Started</c:v>
                   </c:pt>
                   <c:pt idx="3">
-                    <c:v>Get Started</c:v>
+                    <c:v>Best Practices</c:v>
                   </c:pt>
                   <c:pt idx="4">
-                    <c:v>Best Practices</c:v>
+                    <c:v>Operate</c:v>
                   </c:pt>
                   <c:pt idx="5">
-                    <c:v>Operate</c:v>
+                    <c:v>Responsible AI</c:v>
                   </c:pt>
                   <c:pt idx="6">
-                    <c:v>Responsible AI</c:v>
+                    <c:v>Manage</c:v>
                   </c:pt>
                   <c:pt idx="7">
-                    <c:v>Manage</c:v>
+                    <c:v>Dev Experience</c:v>
                   </c:pt>
                   <c:pt idx="8">
-                    <c:v>Dev Experience</c:v>
+                    <c:v>Guardrails</c:v>
                   </c:pt>
                   <c:pt idx="9">
-                    <c:v>Guardrails</c:v>
+                    <c:v>API &amp; SDK</c:v>
                   </c:pt>
                   <c:pt idx="10">
-                    <c:v>API &amp; SDK</c:v>
+                    <c:v>Security</c:v>
                   </c:pt>
                   <c:pt idx="11">
-                    <c:v>Security</c:v>
+                    <c:v>Setup</c:v>
                   </c:pt>
                   <c:pt idx="12">
-                    <c:v>Setup</c:v>
+                    <c:v>Observability</c:v>
                   </c:pt>
                   <c:pt idx="13">
-                    <c:v>Observability</c:v>
+                    <c:v>Agents</c:v>
                   </c:pt>
                   <c:pt idx="14">
-                    <c:v>Agents</c:v>
-                  </c:pt>
-                  <c:pt idx="15">
                     <c:v>Models</c:v>
                   </c:pt>
                 </c:lvl>
@@ -236,56 +233,53 @@
           </c:cat>
           <c:val>
             <c:numRef>
-              <c:f>Sheet1!$B$2:$B$17</c:f>
+              <c:f>Sheet1!$B$2:$B$16</c:f>
               <c:numCache>
                 <c:formatCode>General</c:formatCode>
-                <c:ptCount val="16"/>
+                <c:ptCount val="15"/>
                 <c:pt idx="0">
                   <c:v>1</c:v>
                 </c:pt>
                 <c:pt idx="1">
-                  <c:v>1</c:v>
+                  <c:v>3</c:v>
                 </c:pt>
                 <c:pt idx="2">
-                  <c:v>3</c:v>
+                  <c:v>6</c:v>
                 </c:pt>
                 <c:pt idx="3">
-                  <c:v>4</c:v>
+                  <c:v>5</c:v>
                 </c:pt>
                 <c:pt idx="4">
-                  <c:v>5</c:v>
+                  <c:v>8</c:v>
                 </c:pt>
                 <c:pt idx="5">
-                  <c:v>7</c:v>
+                  <c:v>8</c:v>
                 </c:pt>
                 <c:pt idx="6">
-                  <c:v>8</c:v>
+                  <c:v>9</c:v>
                 </c:pt>
                 <c:pt idx="7">
-                  <c:v>9</c:v>
+                  <c:v>11</c:v>
                 </c:pt>
                 <c:pt idx="8">
-                  <c:v>11</c:v>
+                  <c:v>15</c:v>
                 </c:pt>
                 <c:pt idx="9">
-                  <c:v>15</c:v>
+                  <c:v>17</c:v>
                 </c:pt>
                 <c:pt idx="10">
-                  <c:v>17</c:v>
+                  <c:v>20</c:v>
                 </c:pt>
                 <c:pt idx="11">
                   <c:v>20</c:v>
                 </c:pt>
                 <c:pt idx="12">
-                  <c:v>20</c:v>
+                  <c:v>24</c:v>
                 </c:pt>
                 <c:pt idx="13">
-                  <c:v>24</c:v>
+                  <c:v>60</c:v>
                 </c:pt>
                 <c:pt idx="14">
-                  <c:v>57</c:v>
-                </c:pt>
-                <c:pt idx="15">
                   <c:v>72</c:v>
                 </c:pt>
               </c:numCache>
@@ -2399,7 +2393,7 @@
                 <a:ea typeface="Calibri" pitchFamily="34" charset="-122"/>
                 <a:cs typeface="Calibri" pitchFamily="34" charset="-120"/>
               </a:rPr>
-              <a:t>274 docs  ·  26 agentic workflows  ·  4 SDK repos monitored  ·  FastMCP server</a:t>
+              <a:t>279 docs  ·  23 agentic workflows  ·  4 SDK repos monitored  ·  FastMCP server</a:t>
             </a:r>
             <a:endParaRPr lang="en-US" sz="1300" dirty="0"/>
           </a:p>
@@ -3773,7 +3767,7 @@
                 <a:ea typeface="Trebuchet MS" pitchFamily="34" charset="-122"/>
                 <a:cs typeface="Trebuchet MS" pitchFamily="34" charset="-120"/>
               </a:rPr>
-              <a:t>274</a:t>
+              <a:t>279</a:t>
             </a:r>
             <a:endParaRPr lang="en-US" sz="5200" dirty="0"/>
           </a:p>
@@ -3946,7 +3940,7 @@
                 <a:ea typeface="Trebuchet MS" pitchFamily="34" charset="-122"/>
                 <a:cs typeface="Trebuchet MS" pitchFamily="34" charset="-120"/>
               </a:rPr>
-              <a:t>26</a:t>
+              <a:t>23</a:t>
             </a:r>
             <a:endParaRPr lang="en-US" sz="5200" dirty="0"/>
           </a:p>
@@ -4119,7 +4113,7 @@
                 <a:ea typeface="Trebuchet MS" pitchFamily="34" charset="-122"/>
                 <a:cs typeface="Trebuchet MS" pitchFamily="34" charset="-120"/>
               </a:rPr>
-              <a:t>16</a:t>
+              <a:t>15</a:t>
             </a:r>
             <a:endParaRPr lang="en-US" sz="5200" dirty="0"/>
           </a:p>
@@ -4638,7 +4632,7 @@
                 <a:ea typeface="Trebuchet MS" pitchFamily="34" charset="-122"/>
                 <a:cs typeface="Trebuchet MS" pitchFamily="34" charset="-120"/>
               </a:rPr>
-              <a:t>12</a:t>
+              <a:t>11</a:t>
             </a:r>
             <a:endParaRPr lang="en-US" sz="5200" dirty="0"/>
           </a:p>
@@ -6295,7 +6289,7 @@
                 <a:ea typeface="Trebuchet MS" pitchFamily="34" charset="-122"/>
                 <a:cs typeface="Trebuchet MS" pitchFamily="34" charset="-120"/>
               </a:rPr>
-              <a:t>274</a:t>
+              <a:t>279</a:t>
             </a:r>
             <a:endParaRPr lang="en-US" sz="2600" dirty="0"/>
           </a:p>
@@ -6398,7 +6392,7 @@
                 <a:ea typeface="Trebuchet MS" pitchFamily="34" charset="-122"/>
                 <a:cs typeface="Trebuchet MS" pitchFamily="34" charset="-120"/>
               </a:rPr>
-              <a:t>16</a:t>
+              <a:t>15</a:t>
             </a:r>
             <a:endParaRPr lang="en-US" sz="2600" dirty="0"/>
           </a:p>
@@ -7096,7 +7090,7 @@
                 <a:ea typeface="Calibri" pitchFamily="34" charset="-122"/>
                 <a:cs typeface="Calibri" pitchFamily="34" charset="-120"/>
               </a:rPr>
-              <a:t>274 MDX pages</a:t>
+              <a:t>279 MDX pages</a:t>
             </a:r>
             <a:endParaRPr lang="en-US" sz="1000" dirty="0"/>
           </a:p>
@@ -7794,7 +7788,7 @@
                 <a:ea typeface="Trebuchet MS" pitchFamily="34" charset="-122"/>
                 <a:cs typeface="Trebuchet MS" pitchFamily="34" charset="-120"/>
               </a:rPr>
-              <a:t>Documentation Coverage — 274 Pages Across 16 Sections</a:t>
+              <a:t>Documentation Coverage — 279 Pages Across 15 Sections</a:t>
             </a:r>
             <a:endParaRPr lang="en-US" sz="3000" dirty="0"/>
           </a:p>
@@ -7906,7 +7900,7 @@
                 <a:ea typeface="Trebuchet MS" pitchFamily="34" charset="-122"/>
                 <a:cs typeface="Trebuchet MS" pitchFamily="34" charset="-120"/>
               </a:rPr>
-              <a:t>26 Agentic Workflows</a:t>
+              <a:t>23 Agentic Workflows</a:t>
             </a:r>
             <a:endParaRPr lang="en-US" sz="4000" dirty="0"/>
           </a:p>
@@ -9192,7 +9186,7 @@
                 <a:ea typeface="Trebuchet MS" pitchFamily="34" charset="-122"/>
                 <a:cs typeface="Trebuchet MS" pitchFamily="34" charset="-120"/>
               </a:rPr>
-              <a:t>25</a:t>
+              <a:t>22</a:t>
             </a:r>
             <a:endParaRPr lang="en-US" sz="5200" dirty="0"/>
           </a:p>
@@ -9365,7 +9359,7 @@
                 <a:ea typeface="Trebuchet MS" pitchFamily="34" charset="-122"/>
                 <a:cs typeface="Trebuchet MS" pitchFamily="34" charset="-120"/>
               </a:rPr>
-              <a:t>22</a:t>
+              <a:t>19</a:t>
             </a:r>
             <a:endParaRPr lang="en-US" sz="5200" dirty="0"/>
           </a:p>
@@ -9538,7 +9532,7 @@
                 <a:ea typeface="Trebuchet MS" pitchFamily="34" charset="-122"/>
                 <a:cs typeface="Trebuchet MS" pitchFamily="34" charset="-120"/>
               </a:rPr>
-              <a:t>12</a:t>
+              <a:t>11</a:t>
             </a:r>
             <a:endParaRPr lang="en-US" sz="5200" dirty="0"/>
           </a:p>
@@ -9711,7 +9705,7 @@
                 <a:ea typeface="Trebuchet MS" pitchFamily="34" charset="-122"/>
                 <a:cs typeface="Trebuchet MS" pitchFamily="34" charset="-120"/>
               </a:rPr>
-              <a:t>3</a:t>
+              <a:t>7</a:t>
             </a:r>
             <a:endParaRPr lang="en-US" sz="5200" dirty="0"/>
           </a:p>
@@ -9884,7 +9878,7 @@
                 <a:ea typeface="Trebuchet MS" pitchFamily="34" charset="-122"/>
                 <a:cs typeface="Trebuchet MS" pitchFamily="34" charset="-120"/>
               </a:rPr>
-              <a:t>4</a:t>
+              <a:t>3</a:t>
             </a:r>
             <a:endParaRPr lang="en-US" sz="5200" dirty="0"/>
           </a:p>
@@ -10057,7 +10051,7 @@
                 <a:ea typeface="Trebuchet MS" pitchFamily="34" charset="-122"/>
                 <a:cs typeface="Trebuchet MS" pitchFamily="34" charset="-120"/>
               </a:rPr>
-              <a:t>1</a:t>
+              <a:t>0</a:t>
             </a:r>
             <a:endParaRPr lang="en-US" sz="5200" dirty="0"/>
           </a:p>

</xml_diff>

<commit_message>
Update deck metrics for run #18
- mdxDocs: 274 → 280 (6 new pages across agents, models, get-started, operate)
- agenticWorkflows: 26 → 23 (accurate count excluding shared/ config files)
- docSections: 16 → 15 (glossary consolidated into reference/)
- sections array: updated counts for models (73), agents (60), get-started (6), operate (8)
- workflow category breakdown: quality review 5→3, community 3→2
- scheduleWorkflows: 12 → 13; workflowChains: 4 → 3; pushWorkflows: 1 → 2

Co-authored-by: Copilot <223556219+Copilot@users.noreply.github.com>
</commit_message>
<xml_diff>
--- a/slides/foundry-docs-overview.pptx
+++ b/slides/foundry-docs-overview.pptx
@@ -178,56 +178,53 @@
           </c:dLbls>
           <c:cat>
             <c:multiLvlStrRef>
-              <c:f>Sheet1!$A$2:$A$17</c:f>
+              <c:f>Sheet1!$A$2:$A$16</c:f>
               <c:multiLvlStrCache>
-                <c:ptCount val="16"/>
+                <c:ptCount val="15"/>
                 <c:lvl>
                   <c:pt idx="0">
-                    <c:v>Glossary</c:v>
+                    <c:v>Reference</c:v>
                   </c:pt>
                   <c:pt idx="1">
-                    <c:v>Reference</c:v>
+                    <c:v>Overview</c:v>
                   </c:pt>
                   <c:pt idx="2">
-                    <c:v>Overview</c:v>
+                    <c:v>Get Started</c:v>
                   </c:pt>
                   <c:pt idx="3">
-                    <c:v>Get Started</c:v>
+                    <c:v>Best Practices</c:v>
                   </c:pt>
                   <c:pt idx="4">
-                    <c:v>Best Practices</c:v>
+                    <c:v>Operate</c:v>
                   </c:pt>
                   <c:pt idx="5">
-                    <c:v>Operate</c:v>
+                    <c:v>Responsible AI</c:v>
                   </c:pt>
                   <c:pt idx="6">
-                    <c:v>Responsible AI</c:v>
+                    <c:v>Manage</c:v>
                   </c:pt>
                   <c:pt idx="7">
-                    <c:v>Manage</c:v>
+                    <c:v>Dev Experience</c:v>
                   </c:pt>
                   <c:pt idx="8">
-                    <c:v>Dev Experience</c:v>
+                    <c:v>Guardrails</c:v>
                   </c:pt>
                   <c:pt idx="9">
-                    <c:v>Guardrails</c:v>
+                    <c:v>API &amp; SDK</c:v>
                   </c:pt>
                   <c:pt idx="10">
-                    <c:v>API &amp; SDK</c:v>
+                    <c:v>Security</c:v>
                   </c:pt>
                   <c:pt idx="11">
-                    <c:v>Security</c:v>
+                    <c:v>Setup</c:v>
                   </c:pt>
                   <c:pt idx="12">
-                    <c:v>Setup</c:v>
+                    <c:v>Observability</c:v>
                   </c:pt>
                   <c:pt idx="13">
-                    <c:v>Observability</c:v>
+                    <c:v>Agents</c:v>
                   </c:pt>
                   <c:pt idx="14">
-                    <c:v>Agents</c:v>
-                  </c:pt>
-                  <c:pt idx="15">
                     <c:v>Models</c:v>
                   </c:pt>
                 </c:lvl>
@@ -236,57 +233,54 @@
           </c:cat>
           <c:val>
             <c:numRef>
-              <c:f>Sheet1!$B$2:$B$17</c:f>
+              <c:f>Sheet1!$B$2:$B$16</c:f>
               <c:numCache>
                 <c:formatCode>General</c:formatCode>
-                <c:ptCount val="16"/>
+                <c:ptCount val="15"/>
                 <c:pt idx="0">
                   <c:v>1</c:v>
                 </c:pt>
                 <c:pt idx="1">
-                  <c:v>1</c:v>
+                  <c:v>3</c:v>
                 </c:pt>
                 <c:pt idx="2">
-                  <c:v>3</c:v>
+                  <c:v>6</c:v>
                 </c:pt>
                 <c:pt idx="3">
-                  <c:v>4</c:v>
+                  <c:v>5</c:v>
                 </c:pt>
                 <c:pt idx="4">
-                  <c:v>5</c:v>
+                  <c:v>8</c:v>
                 </c:pt>
                 <c:pt idx="5">
-                  <c:v>7</c:v>
+                  <c:v>8</c:v>
                 </c:pt>
                 <c:pt idx="6">
-                  <c:v>8</c:v>
+                  <c:v>9</c:v>
                 </c:pt>
                 <c:pt idx="7">
-                  <c:v>9</c:v>
+                  <c:v>11</c:v>
                 </c:pt>
                 <c:pt idx="8">
-                  <c:v>11</c:v>
+                  <c:v>15</c:v>
                 </c:pt>
                 <c:pt idx="9">
-                  <c:v>15</c:v>
+                  <c:v>17</c:v>
                 </c:pt>
                 <c:pt idx="10">
-                  <c:v>17</c:v>
+                  <c:v>20</c:v>
                 </c:pt>
                 <c:pt idx="11">
                   <c:v>20</c:v>
                 </c:pt>
                 <c:pt idx="12">
-                  <c:v>20</c:v>
+                  <c:v>24</c:v>
                 </c:pt>
                 <c:pt idx="13">
-                  <c:v>24</c:v>
+                  <c:v>60</c:v>
                 </c:pt>
                 <c:pt idx="14">
-                  <c:v>57</c:v>
-                </c:pt>
-                <c:pt idx="15">
-                  <c:v>72</c:v>
+                  <c:v>73</c:v>
                 </c:pt>
               </c:numCache>
             </c:numRef>
@@ -2399,7 +2393,7 @@
                 <a:ea typeface="Calibri" pitchFamily="34" charset="-122"/>
                 <a:cs typeface="Calibri" pitchFamily="34" charset="-120"/>
               </a:rPr>
-              <a:t>274 docs  ·  26 agentic workflows  ·  4 SDK repos monitored  ·  FastMCP server</a:t>
+              <a:t>280 docs  ·  23 agentic workflows  ·  4 SDK repos monitored  ·  FastMCP server</a:t>
             </a:r>
             <a:endParaRPr lang="en-US" sz="1300" dirty="0"/>
           </a:p>
@@ -3773,7 +3767,7 @@
                 <a:ea typeface="Trebuchet MS" pitchFamily="34" charset="-122"/>
                 <a:cs typeface="Trebuchet MS" pitchFamily="34" charset="-120"/>
               </a:rPr>
-              <a:t>274</a:t>
+              <a:t>280</a:t>
             </a:r>
             <a:endParaRPr lang="en-US" sz="5200" dirty="0"/>
           </a:p>
@@ -3946,7 +3940,7 @@
                 <a:ea typeface="Trebuchet MS" pitchFamily="34" charset="-122"/>
                 <a:cs typeface="Trebuchet MS" pitchFamily="34" charset="-120"/>
               </a:rPr>
-              <a:t>26</a:t>
+              <a:t>23</a:t>
             </a:r>
             <a:endParaRPr lang="en-US" sz="5200" dirty="0"/>
           </a:p>
@@ -4119,7 +4113,7 @@
                 <a:ea typeface="Trebuchet MS" pitchFamily="34" charset="-122"/>
                 <a:cs typeface="Trebuchet MS" pitchFamily="34" charset="-120"/>
               </a:rPr>
-              <a:t>16</a:t>
+              <a:t>15</a:t>
             </a:r>
             <a:endParaRPr lang="en-US" sz="5200" dirty="0"/>
           </a:p>
@@ -4638,7 +4632,7 @@
                 <a:ea typeface="Trebuchet MS" pitchFamily="34" charset="-122"/>
                 <a:cs typeface="Trebuchet MS" pitchFamily="34" charset="-120"/>
               </a:rPr>
-              <a:t>12</a:t>
+              <a:t>13</a:t>
             </a:r>
             <a:endParaRPr lang="en-US" sz="5200" dirty="0"/>
           </a:p>
@@ -6295,7 +6289,7 @@
                 <a:ea typeface="Trebuchet MS" pitchFamily="34" charset="-122"/>
                 <a:cs typeface="Trebuchet MS" pitchFamily="34" charset="-120"/>
               </a:rPr>
-              <a:t>274</a:t>
+              <a:t>280</a:t>
             </a:r>
             <a:endParaRPr lang="en-US" sz="2600" dirty="0"/>
           </a:p>
@@ -6398,7 +6392,7 @@
                 <a:ea typeface="Trebuchet MS" pitchFamily="34" charset="-122"/>
                 <a:cs typeface="Trebuchet MS" pitchFamily="34" charset="-120"/>
               </a:rPr>
-              <a:t>16</a:t>
+              <a:t>15</a:t>
             </a:r>
             <a:endParaRPr lang="en-US" sz="2600" dirty="0"/>
           </a:p>
@@ -7794,7 +7788,7 @@
                 <a:ea typeface="Trebuchet MS" pitchFamily="34" charset="-122"/>
                 <a:cs typeface="Trebuchet MS" pitchFamily="34" charset="-120"/>
               </a:rPr>
-              <a:t>Documentation Coverage — 274 Pages Across 16 Sections</a:t>
+              <a:t>Documentation Coverage — 280 Pages Across 15 Sections</a:t>
             </a:r>
             <a:endParaRPr lang="en-US" sz="3000" dirty="0"/>
           </a:p>
@@ -7906,7 +7900,7 @@
                 <a:ea typeface="Trebuchet MS" pitchFamily="34" charset="-122"/>
                 <a:cs typeface="Trebuchet MS" pitchFamily="34" charset="-120"/>
               </a:rPr>
-              <a:t>26 Agentic Workflows</a:t>
+              <a:t>23 Agentic Workflows</a:t>
             </a:r>
             <a:endParaRPr lang="en-US" sz="4000" dirty="0"/>
           </a:p>
@@ -8121,7 +8115,7 @@
                 <a:ea typeface="Calibri" pitchFamily="34" charset="-122"/>
                 <a:cs typeface="Calibri" pitchFamily="34" charset="-120"/>
               </a:rPr>
-              <a:t>Reddit, diff reports, Dependabot</a:t>
+              <a:t>Reddit, diff reports, model catalog</a:t>
             </a:r>
             <a:endParaRPr lang="en-US" sz="1150" dirty="0"/>
           </a:p>
@@ -8456,7 +8450,7 @@
                 <a:ea typeface="Calibri" pitchFamily="34" charset="-122"/>
                 <a:cs typeface="Calibri" pitchFamily="34" charset="-120"/>
               </a:rPr>
-              <a:t>Healer, updater, unbloat,</a:t>
+              <a:t>Daily updater, unbloat,</a:t>
             </a:r>
             <a:endParaRPr lang="en-US" sz="1150" dirty="0"/>
           </a:p>
@@ -8473,7 +8467,7 @@
                 <a:ea typeface="Calibri" pitchFamily="34" charset="-122"/>
                 <a:cs typeface="Calibri" pitchFamily="34" charset="-120"/>
               </a:rPr>
-              <a:t>glossary, labels, sync</a:t>
+              <a:t>glossary, changelog, sync</a:t>
             </a:r>
             <a:endParaRPr lang="en-US" sz="1150" dirty="0"/>
           </a:p>
@@ -8593,7 +8587,7 @@
                 <a:ea typeface="Trebuchet MS" pitchFamily="34" charset="-122"/>
                 <a:cs typeface="Trebuchet MS" pitchFamily="34" charset="-120"/>
               </a:rPr>
-              <a:t>5  Quality Review</a:t>
+              <a:t>3  Quality Review</a:t>
             </a:r>
             <a:endParaRPr lang="en-US" sz="1450" dirty="0"/>
           </a:p>
@@ -8632,7 +8626,7 @@
                 <a:ea typeface="Calibri" pitchFamily="34" charset="-122"/>
                 <a:cs typeface="Calibri" pitchFamily="34" charset="-120"/>
               </a:rPr>
-              <a:t>Auditor, PR reviewer,</a:t>
+              <a:t>PR reviewer, merge verify,</a:t>
             </a:r>
             <a:endParaRPr lang="en-US" sz="1150" dirty="0"/>
           </a:p>
@@ -8649,7 +8643,7 @@
                 <a:ea typeface="Calibri" pitchFamily="34" charset="-122"/>
                 <a:cs typeface="Calibri" pitchFamily="34" charset="-120"/>
               </a:rPr>
-              <a:t>merge verify, push check</a:t>
+              <a:t>audit-file check</a:t>
             </a:r>
             <a:endParaRPr lang="en-US" sz="1150" dirty="0"/>
           </a:p>
@@ -8769,7 +8763,7 @@
                 <a:ea typeface="Trebuchet MS" pitchFamily="34" charset="-122"/>
                 <a:cs typeface="Trebuchet MS" pitchFamily="34" charset="-120"/>
               </a:rPr>
-              <a:t>3  Community</a:t>
+              <a:t>2  Community</a:t>
             </a:r>
             <a:endParaRPr lang="en-US" sz="1450" dirty="0"/>
           </a:p>
@@ -8825,7 +8819,7 @@
                 <a:ea typeface="Calibri" pitchFamily="34" charset="-122"/>
                 <a:cs typeface="Calibri" pitchFamily="34" charset="-120"/>
               </a:rPr>
-              <a:t>responder, auto-triage</a:t>
+              <a:t>auto-triage issues</a:t>
             </a:r>
             <a:endParaRPr lang="en-US" sz="1150" dirty="0"/>
           </a:p>
@@ -9365,7 +9359,7 @@
                 <a:ea typeface="Trebuchet MS" pitchFamily="34" charset="-122"/>
                 <a:cs typeface="Trebuchet MS" pitchFamily="34" charset="-120"/>
               </a:rPr>
-              <a:t>22</a:t>
+              <a:t>21</a:t>
             </a:r>
             <a:endParaRPr lang="en-US" sz="5200" dirty="0"/>
           </a:p>
@@ -9538,7 +9532,7 @@
                 <a:ea typeface="Trebuchet MS" pitchFamily="34" charset="-122"/>
                 <a:cs typeface="Trebuchet MS" pitchFamily="34" charset="-120"/>
               </a:rPr>
-              <a:t>12</a:t>
+              <a:t>13</a:t>
             </a:r>
             <a:endParaRPr lang="en-US" sz="5200" dirty="0"/>
           </a:p>
@@ -9884,7 +9878,7 @@
                 <a:ea typeface="Trebuchet MS" pitchFamily="34" charset="-122"/>
                 <a:cs typeface="Trebuchet MS" pitchFamily="34" charset="-120"/>
               </a:rPr>
-              <a:t>4</a:t>
+              <a:t>3</a:t>
             </a:r>
             <a:endParaRPr lang="en-US" sz="5200" dirty="0"/>
           </a:p>
@@ -10057,7 +10051,7 @@
                 <a:ea typeface="Trebuchet MS" pitchFamily="34" charset="-122"/>
                 <a:cs typeface="Trebuchet MS" pitchFamily="34" charset="-120"/>
               </a:rPr>
-              <a:t>1</a:t>
+              <a:t>2</a:t>
             </a:r>
             <a:endParaRPr lang="en-US" sz="5200" dirty="0"/>
           </a:p>

</xml_diff>

<commit_message>
slides: update metrics and eval data for 2026-05-18
- mdxDocs: 274 → 280
- agenticWorkflows: 26 → 29
- workflowChains: 4 → 3
- sections: update all page counts (15 sections, removed separate Glossary entry)
- Eval harness: update to latest report (Issue #324, 2026-05-17)
  - 200 evals, 2 models (claude-sonnet-4.6, gpt-5.4)
  - docs-vnext 🥇 0.952, Mintlify 🥈 0.952, docs/ 🥉 0.951, MS Learn 0.947
  - H1: MARGINAL (+0.001), H2: NO DIFF, H3: MARGINAL (+0.005), H4: SUPPORTED
  - observability-eval: docs-vnext perfect score (1.000 vs 0.856)

Co-authored-by: Copilot <223556219+Copilot@users.noreply.github.com>
</commit_message>
<xml_diff>
--- a/slides/foundry-docs-overview.pptx
+++ b/slides/foundry-docs-overview.pptx
@@ -178,56 +178,53 @@
           </c:dLbls>
           <c:cat>
             <c:multiLvlStrRef>
-              <c:f>Sheet1!$A$2:$A$17</c:f>
+              <c:f>Sheet1!$A$2:$A$16</c:f>
               <c:multiLvlStrCache>
-                <c:ptCount val="16"/>
+                <c:ptCount val="15"/>
                 <c:lvl>
                   <c:pt idx="0">
-                    <c:v>Glossary</c:v>
+                    <c:v>Reference</c:v>
                   </c:pt>
                   <c:pt idx="1">
-                    <c:v>Reference</c:v>
+                    <c:v>Overview</c:v>
                   </c:pt>
                   <c:pt idx="2">
-                    <c:v>Overview</c:v>
+                    <c:v>Get Started</c:v>
                   </c:pt>
                   <c:pt idx="3">
-                    <c:v>Get Started</c:v>
+                    <c:v>Best Practices</c:v>
                   </c:pt>
                   <c:pt idx="4">
-                    <c:v>Best Practices</c:v>
+                    <c:v>Operate</c:v>
                   </c:pt>
                   <c:pt idx="5">
-                    <c:v>Operate</c:v>
+                    <c:v>Responsible AI</c:v>
                   </c:pt>
                   <c:pt idx="6">
-                    <c:v>Responsible AI</c:v>
+                    <c:v>Manage</c:v>
                   </c:pt>
                   <c:pt idx="7">
-                    <c:v>Manage</c:v>
+                    <c:v>Dev Experience</c:v>
                   </c:pt>
                   <c:pt idx="8">
-                    <c:v>Dev Experience</c:v>
+                    <c:v>Guardrails</c:v>
                   </c:pt>
                   <c:pt idx="9">
-                    <c:v>Guardrails</c:v>
+                    <c:v>API &amp; SDK</c:v>
                   </c:pt>
                   <c:pt idx="10">
-                    <c:v>API &amp; SDK</c:v>
+                    <c:v>Security</c:v>
                   </c:pt>
                   <c:pt idx="11">
-                    <c:v>Security</c:v>
+                    <c:v>Setup</c:v>
                   </c:pt>
                   <c:pt idx="12">
-                    <c:v>Setup</c:v>
+                    <c:v>Observability</c:v>
                   </c:pt>
                   <c:pt idx="13">
-                    <c:v>Observability</c:v>
+                    <c:v>Agents</c:v>
                   </c:pt>
                   <c:pt idx="14">
-                    <c:v>Agents</c:v>
-                  </c:pt>
-                  <c:pt idx="15">
                     <c:v>Models</c:v>
                   </c:pt>
                 </c:lvl>
@@ -236,57 +233,54 @@
           </c:cat>
           <c:val>
             <c:numRef>
-              <c:f>Sheet1!$B$2:$B$17</c:f>
+              <c:f>Sheet1!$B$2:$B$16</c:f>
               <c:numCache>
                 <c:formatCode>General</c:formatCode>
-                <c:ptCount val="16"/>
+                <c:ptCount val="15"/>
                 <c:pt idx="0">
                   <c:v>1</c:v>
                 </c:pt>
                 <c:pt idx="1">
-                  <c:v>1</c:v>
+                  <c:v>3</c:v>
                 </c:pt>
                 <c:pt idx="2">
-                  <c:v>3</c:v>
+                  <c:v>6</c:v>
                 </c:pt>
                 <c:pt idx="3">
-                  <c:v>4</c:v>
+                  <c:v>5</c:v>
                 </c:pt>
                 <c:pt idx="4">
-                  <c:v>5</c:v>
+                  <c:v>8</c:v>
                 </c:pt>
                 <c:pt idx="5">
-                  <c:v>7</c:v>
+                  <c:v>8</c:v>
                 </c:pt>
                 <c:pt idx="6">
-                  <c:v>8</c:v>
+                  <c:v>9</c:v>
                 </c:pt>
                 <c:pt idx="7">
-                  <c:v>9</c:v>
+                  <c:v>11</c:v>
                 </c:pt>
                 <c:pt idx="8">
-                  <c:v>11</c:v>
+                  <c:v>15</c:v>
                 </c:pt>
                 <c:pt idx="9">
-                  <c:v>15</c:v>
+                  <c:v>17</c:v>
                 </c:pt>
                 <c:pt idx="10">
-                  <c:v>17</c:v>
+                  <c:v>20</c:v>
                 </c:pt>
                 <c:pt idx="11">
                   <c:v>20</c:v>
                 </c:pt>
                 <c:pt idx="12">
-                  <c:v>20</c:v>
+                  <c:v>24</c:v>
                 </c:pt>
                 <c:pt idx="13">
-                  <c:v>24</c:v>
+                  <c:v>60</c:v>
                 </c:pt>
                 <c:pt idx="14">
-                  <c:v>57</c:v>
-                </c:pt>
-                <c:pt idx="15">
-                  <c:v>72</c:v>
+                  <c:v>73</c:v>
                 </c:pt>
               </c:numCache>
             </c:numRef>
@@ -2399,7 +2393,7 @@
                 <a:ea typeface="Calibri" pitchFamily="34" charset="-122"/>
                 <a:cs typeface="Calibri" pitchFamily="34" charset="-120"/>
               </a:rPr>
-              <a:t>274 docs  ·  26 agentic workflows  ·  4 SDK repos monitored  ·  FastMCP server</a:t>
+              <a:t>280 docs  ·  29 agentic workflows  ·  4 SDK repos monitored  ·  FastMCP server</a:t>
             </a:r>
             <a:endParaRPr lang="en-US" sz="1300" dirty="0"/>
           </a:p>
@@ -3773,7 +3767,7 @@
                 <a:ea typeface="Trebuchet MS" pitchFamily="34" charset="-122"/>
                 <a:cs typeface="Trebuchet MS" pitchFamily="34" charset="-120"/>
               </a:rPr>
-              <a:t>274</a:t>
+              <a:t>280</a:t>
             </a:r>
             <a:endParaRPr lang="en-US" sz="5200" dirty="0"/>
           </a:p>
@@ -3946,7 +3940,7 @@
                 <a:ea typeface="Trebuchet MS" pitchFamily="34" charset="-122"/>
                 <a:cs typeface="Trebuchet MS" pitchFamily="34" charset="-120"/>
               </a:rPr>
-              <a:t>26</a:t>
+              <a:t>29</a:t>
             </a:r>
             <a:endParaRPr lang="en-US" sz="5200" dirty="0"/>
           </a:p>
@@ -4119,7 +4113,7 @@
                 <a:ea typeface="Trebuchet MS" pitchFamily="34" charset="-122"/>
                 <a:cs typeface="Trebuchet MS" pitchFamily="34" charset="-120"/>
               </a:rPr>
-              <a:t>16</a:t>
+              <a:t>15</a:t>
             </a:r>
             <a:endParaRPr lang="en-US" sz="5200" dirty="0"/>
           </a:p>
@@ -6295,7 +6289,7 @@
                 <a:ea typeface="Trebuchet MS" pitchFamily="34" charset="-122"/>
                 <a:cs typeface="Trebuchet MS" pitchFamily="34" charset="-120"/>
               </a:rPr>
-              <a:t>274</a:t>
+              <a:t>280</a:t>
             </a:r>
             <a:endParaRPr lang="en-US" sz="2600" dirty="0"/>
           </a:p>
@@ -6398,7 +6392,7 @@
                 <a:ea typeface="Trebuchet MS" pitchFamily="34" charset="-122"/>
                 <a:cs typeface="Trebuchet MS" pitchFamily="34" charset="-120"/>
               </a:rPr>
-              <a:t>16</a:t>
+              <a:t>15</a:t>
             </a:r>
             <a:endParaRPr lang="en-US" sz="2600" dirty="0"/>
           </a:p>
@@ -7096,7 +7090,7 @@
                 <a:ea typeface="Calibri" pitchFamily="34" charset="-122"/>
                 <a:cs typeface="Calibri" pitchFamily="34" charset="-120"/>
               </a:rPr>
-              <a:t>274 MDX pages</a:t>
+              <a:t>280 MDX pages</a:t>
             </a:r>
             <a:endParaRPr lang="en-US" sz="1000" dirty="0"/>
           </a:p>
@@ -7794,7 +7788,7 @@
                 <a:ea typeface="Trebuchet MS" pitchFamily="34" charset="-122"/>
                 <a:cs typeface="Trebuchet MS" pitchFamily="34" charset="-120"/>
               </a:rPr>
-              <a:t>Documentation Coverage — 274 Pages Across 16 Sections</a:t>
+              <a:t>Documentation Coverage — 280 Pages Across 15 Sections</a:t>
             </a:r>
             <a:endParaRPr lang="en-US" sz="3000" dirty="0"/>
           </a:p>
@@ -7906,7 +7900,7 @@
                 <a:ea typeface="Trebuchet MS" pitchFamily="34" charset="-122"/>
                 <a:cs typeface="Trebuchet MS" pitchFamily="34" charset="-120"/>
               </a:rPr>
-              <a:t>26 Agentic Workflows</a:t>
+              <a:t>29 Agentic Workflows</a:t>
             </a:r>
             <a:endParaRPr lang="en-US" sz="4000" dirty="0"/>
           </a:p>
@@ -9192,7 +9186,7 @@
                 <a:ea typeface="Trebuchet MS" pitchFamily="34" charset="-122"/>
                 <a:cs typeface="Trebuchet MS" pitchFamily="34" charset="-120"/>
               </a:rPr>
-              <a:t>25</a:t>
+              <a:t>22</a:t>
             </a:r>
             <a:endParaRPr lang="en-US" sz="5200" dirty="0"/>
           </a:p>
@@ -9365,7 +9359,7 @@
                 <a:ea typeface="Trebuchet MS" pitchFamily="34" charset="-122"/>
                 <a:cs typeface="Trebuchet MS" pitchFamily="34" charset="-120"/>
               </a:rPr>
-              <a:t>22</a:t>
+              <a:t>18</a:t>
             </a:r>
             <a:endParaRPr lang="en-US" sz="5200" dirty="0"/>
           </a:p>
@@ -9711,7 +9705,7 @@
                 <a:ea typeface="Trebuchet MS" pitchFamily="34" charset="-122"/>
                 <a:cs typeface="Trebuchet MS" pitchFamily="34" charset="-120"/>
               </a:rPr>
-              <a:t>3</a:t>
+              <a:t>8</a:t>
             </a:r>
             <a:endParaRPr lang="en-US" sz="5200" dirty="0"/>
           </a:p>
@@ -9884,7 +9878,7 @@
                 <a:ea typeface="Trebuchet MS" pitchFamily="34" charset="-122"/>
                 <a:cs typeface="Trebuchet MS" pitchFamily="34" charset="-120"/>
               </a:rPr>
-              <a:t>4</a:t>
+              <a:t>3</a:t>
             </a:r>
             <a:endParaRPr lang="en-US" sz="5200" dirty="0"/>
           </a:p>
@@ -10057,7 +10051,7 @@
                 <a:ea typeface="Trebuchet MS" pitchFamily="34" charset="-122"/>
                 <a:cs typeface="Trebuchet MS" pitchFamily="34" charset="-120"/>
               </a:rPr>
-              <a:t>1</a:t>
+              <a:t>0</a:t>
             </a:r>
             <a:endParaRPr lang="en-US" sz="5200" dirty="0"/>
           </a:p>
@@ -11344,7 +11338,7 @@
                 <a:ea typeface="Calibri" pitchFamily="34" charset="-122"/>
                 <a:cs typeface="Calibri" pitchFamily="34" charset="-120"/>
               </a:rPr>
-              <a:t>300 evaluations · 4 servers · 3 frontier models · 2026-03-05</a:t>
+              <a:t>200 evaluations · 4 servers · 2 frontier models · 2026-05-17</a:t>
             </a:r>
             <a:endParaRPr lang="en-US" sz="1150" dirty="0"/>
           </a:p>
@@ -11373,11 +11367,10 @@
             <a:tbl>
               <a:tblPr/>
               <a:tblGrid>
-                <a:gridCol w="1645920"/>
-                <a:gridCol w="886968"/>
-                <a:gridCol w="886968"/>
-                <a:gridCol w="886968"/>
-                <a:gridCol w="859536"/>
+                <a:gridCol w="2194560"/>
+                <a:gridCol w="1097280"/>
+                <a:gridCol w="1097280"/>
+                <a:gridCol w="777240"/>
               </a:tblGrid>
               <a:tr h="347472">
                 <a:tc>
@@ -11465,7 +11458,7 @@
                           <a:ea typeface="Calibri" pitchFamily="34" charset="-122"/>
                           <a:cs typeface="Calibri" pitchFamily="34" charset="-120"/>
                         </a:rPr>
-                        <a:t>claude-opus-4.6</a:t>
+                        <a:t>claude-sonnet-4.6</a:t>
                       </a:r>
                       <a:endParaRPr lang="en-US" sz="1100" dirty="0">
                         <a:latin typeface="Calibri" charset="0"/>
@@ -11533,75 +11526,7 @@
                           <a:ea typeface="Calibri" pitchFamily="34" charset="-122"/>
                           <a:cs typeface="Calibri" pitchFamily="34" charset="-120"/>
                         </a:rPr>
-                        <a:t>gemini-3-pro</a:t>
-                      </a:r>
-                      <a:endParaRPr lang="en-US" sz="1100" dirty="0">
-                        <a:latin typeface="Calibri" charset="0"/>
-                        <a:ea typeface="Calibri" charset="0"/>
-                        <a:cs typeface="Calibri" charset="0"/>
-                      </a:endParaRPr>
-                    </a:p>
-                  </a:txBody>
-                  <a:tcPr marL="91440" marR="91440" marT="45720" marB="45720">
-                    <a:lnL w="6350" cap="flat" cmpd="sng" algn="ctr">
-                      <a:solidFill>
-                        <a:srgbClr val="028090"/>
-                      </a:solidFill>
-                      <a:prstDash val="solid"/>
-                      <a:round/>
-                      <a:headEnd type="none" w="med" len="med"/>
-                      <a:tailEnd type="none" w="med" len="med"/>
-                    </a:lnL>
-                    <a:lnR w="6350" cap="flat" cmpd="sng" algn="ctr">
-                      <a:solidFill>
-                        <a:srgbClr val="028090"/>
-                      </a:solidFill>
-                      <a:prstDash val="solid"/>
-                      <a:round/>
-                      <a:headEnd type="none" w="med" len="med"/>
-                      <a:tailEnd type="none" w="med" len="med"/>
-                    </a:lnR>
-                    <a:lnT w="6350" cap="flat" cmpd="sng" algn="ctr">
-                      <a:solidFill>
-                        <a:srgbClr val="028090"/>
-                      </a:solidFill>
-                      <a:prstDash val="solid"/>
-                      <a:round/>
-                      <a:headEnd type="none" w="med" len="med"/>
-                      <a:tailEnd type="none" w="med" len="med"/>
-                    </a:lnT>
-                    <a:lnB w="6350" cap="flat" cmpd="sng" algn="ctr">
-                      <a:solidFill>
-                        <a:srgbClr val="028090"/>
-                      </a:solidFill>
-                      <a:prstDash val="solid"/>
-                      <a:round/>
-                      <a:headEnd type="none" w="med" len="med"/>
-                      <a:tailEnd type="none" w="med" len="med"/>
-                    </a:lnB>
-                    <a:solidFill>
-                      <a:srgbClr val="028090"/>
-                    </a:solidFill>
-                  </a:tcPr>
-                </a:tc>
-                <a:tc>
-                  <a:txBody>
-                    <a:bodyPr/>
-                    <a:lstStyle/>
-                    <a:p>
-                      <a:pPr algn="ctr" indent="0" marL="0">
-                        <a:buNone/>
-                      </a:pPr>
-                      <a:r>
-                        <a:rPr lang="en-US" sz="1100" b="1" dirty="0">
-                          <a:solidFill>
-                            <a:srgbClr val="FFFFFF"/>
-                          </a:solidFill>
-                          <a:latin typeface="Calibri" pitchFamily="34" charset="0"/>
-                          <a:ea typeface="Calibri" pitchFamily="34" charset="-122"/>
-                          <a:cs typeface="Calibri" pitchFamily="34" charset="-120"/>
-                        </a:rPr>
-                        <a:t>gpt-5.3-codex</a:t>
+                        <a:t>gpt-5.4</a:t>
                       </a:r>
                       <a:endParaRPr lang="en-US" sz="1100" dirty="0">
                         <a:latin typeface="Calibri" charset="0"/>
@@ -11731,15 +11656,15 @@
                         <a:buNone/>
                       </a:pPr>
                       <a:r>
-                        <a:rPr lang="en-US" sz="1100" dirty="0">
+                        <a:rPr lang="en-US" sz="1100" b="1" dirty="0">
                           <a:solidFill>
-                            <a:srgbClr val="1A2E30"/>
+                            <a:srgbClr val="02C39A"/>
                           </a:solidFill>
                           <a:latin typeface="Calibri" pitchFamily="34" charset="0"/>
                           <a:ea typeface="Calibri" pitchFamily="34" charset="-122"/>
                           <a:cs typeface="Calibri" pitchFamily="34" charset="-120"/>
                         </a:rPr>
-                        <a:t>MS Learn 🥇</a:t>
+                        <a:t>docs-vnext/ 🥇</a:t>
                       </a:r>
                       <a:endParaRPr lang="en-US" sz="1100" dirty="0">
                         <a:latin typeface="Calibri" charset="0"/>
@@ -11786,7 +11711,7 @@
                       <a:tailEnd type="none" w="med" len="med"/>
                     </a:lnB>
                     <a:solidFill>
-                      <a:srgbClr val="F4FAFA"/>
+                      <a:srgbClr val="022C33"/>
                     </a:solidFill>
                   </a:tcPr>
                 </a:tc>
@@ -11799,15 +11724,15 @@
                         <a:buNone/>
                       </a:pPr>
                       <a:r>
-                        <a:rPr lang="en-US" sz="1100" dirty="0">
+                        <a:rPr lang="en-US" sz="1100" b="1" dirty="0">
                           <a:solidFill>
-                            <a:srgbClr val="1A2E30"/>
+                            <a:srgbClr val="02C39A"/>
                           </a:solidFill>
                           <a:latin typeface="Calibri" pitchFamily="34" charset="0"/>
                           <a:ea typeface="Calibri" pitchFamily="34" charset="-122"/>
                           <a:cs typeface="Calibri" pitchFamily="34" charset="-120"/>
                         </a:rPr>
-                        <a:t>0.933</a:t>
+                        <a:t>0.952</a:t>
                       </a:r>
                       <a:endParaRPr lang="en-US" sz="1100" dirty="0">
                         <a:latin typeface="Calibri" charset="0"/>
@@ -11854,7 +11779,7 @@
                       <a:tailEnd type="none" w="med" len="med"/>
                     </a:lnB>
                     <a:solidFill>
-                      <a:srgbClr val="F4FAFA"/>
+                      <a:srgbClr val="022C33"/>
                     </a:solidFill>
                   </a:tcPr>
                 </a:tc>
@@ -11867,15 +11792,15 @@
                         <a:buNone/>
                       </a:pPr>
                       <a:r>
-                        <a:rPr lang="en-US" sz="1100" dirty="0">
+                        <a:rPr lang="en-US" sz="1100" b="1" dirty="0">
                           <a:solidFill>
-                            <a:srgbClr val="1A2E30"/>
+                            <a:srgbClr val="02C39A"/>
                           </a:solidFill>
                           <a:latin typeface="Calibri" pitchFamily="34" charset="0"/>
                           <a:ea typeface="Calibri" pitchFamily="34" charset="-122"/>
                           <a:cs typeface="Calibri" pitchFamily="34" charset="-120"/>
                         </a:rPr>
-                        <a:t>0.882</a:t>
+                        <a:t>—</a:t>
                       </a:r>
                       <a:endParaRPr lang="en-US" sz="1100" dirty="0">
                         <a:latin typeface="Calibri" charset="0"/>
@@ -11922,7 +11847,7 @@
                       <a:tailEnd type="none" w="med" len="med"/>
                     </a:lnB>
                     <a:solidFill>
-                      <a:srgbClr val="F4FAFA"/>
+                      <a:srgbClr val="022C33"/>
                     </a:solidFill>
                   </a:tcPr>
                 </a:tc>
@@ -11935,15 +11860,15 @@
                         <a:buNone/>
                       </a:pPr>
                       <a:r>
-                        <a:rPr lang="en-US" sz="1100" dirty="0">
+                        <a:rPr lang="en-US" sz="1100" b="1" dirty="0">
                           <a:solidFill>
-                            <a:srgbClr val="1A2E30"/>
+                            <a:srgbClr val="02C39A"/>
                           </a:solidFill>
                           <a:latin typeface="Calibri" pitchFamily="34" charset="0"/>
                           <a:ea typeface="Calibri" pitchFamily="34" charset="-122"/>
                           <a:cs typeface="Calibri" pitchFamily="34" charset="-120"/>
                         </a:rPr>
-                        <a:t>0.906</a:t>
+                        <a:t>0.952</a:t>
                       </a:r>
                       <a:endParaRPr lang="en-US" sz="1100" dirty="0">
                         <a:latin typeface="Calibri" charset="0"/>
@@ -11990,75 +11915,7 @@
                       <a:tailEnd type="none" w="med" len="med"/>
                     </a:lnB>
                     <a:solidFill>
-                      <a:srgbClr val="F4FAFA"/>
-                    </a:solidFill>
-                  </a:tcPr>
-                </a:tc>
-                <a:tc>
-                  <a:txBody>
-                    <a:bodyPr/>
-                    <a:lstStyle/>
-                    <a:p>
-                      <a:pPr algn="ctr" indent="0" marL="0">
-                        <a:buNone/>
-                      </a:pPr>
-                      <a:r>
-                        <a:rPr lang="en-US" sz="1100" b="1" dirty="0">
-                          <a:solidFill>
-                            <a:srgbClr val="1A2E30"/>
-                          </a:solidFill>
-                          <a:latin typeface="Calibri" pitchFamily="34" charset="0"/>
-                          <a:ea typeface="Calibri" pitchFamily="34" charset="-122"/>
-                          <a:cs typeface="Calibri" pitchFamily="34" charset="-120"/>
-                        </a:rPr>
-                        <a:t>0.908</a:t>
-                      </a:r>
-                      <a:endParaRPr lang="en-US" sz="1100" dirty="0">
-                        <a:latin typeface="Calibri" charset="0"/>
-                        <a:ea typeface="Calibri" charset="0"/>
-                        <a:cs typeface="Calibri" charset="0"/>
-                      </a:endParaRPr>
-                    </a:p>
-                  </a:txBody>
-                  <a:tcPr marL="91440" marR="91440" marT="45720" marB="45720">
-                    <a:lnL w="6350" cap="flat" cmpd="sng" algn="ctr">
-                      <a:solidFill>
-                        <a:srgbClr val="028090"/>
-                      </a:solidFill>
-                      <a:prstDash val="solid"/>
-                      <a:round/>
-                      <a:headEnd type="none" w="med" len="med"/>
-                      <a:tailEnd type="none" w="med" len="med"/>
-                    </a:lnL>
-                    <a:lnR w="6350" cap="flat" cmpd="sng" algn="ctr">
-                      <a:solidFill>
-                        <a:srgbClr val="028090"/>
-                      </a:solidFill>
-                      <a:prstDash val="solid"/>
-                      <a:round/>
-                      <a:headEnd type="none" w="med" len="med"/>
-                      <a:tailEnd type="none" w="med" len="med"/>
-                    </a:lnR>
-                    <a:lnT w="6350" cap="flat" cmpd="sng" algn="ctr">
-                      <a:solidFill>
-                        <a:srgbClr val="028090"/>
-                      </a:solidFill>
-                      <a:prstDash val="solid"/>
-                      <a:round/>
-                      <a:headEnd type="none" w="med" len="med"/>
-                      <a:tailEnd type="none" w="med" len="med"/>
-                    </a:lnT>
-                    <a:lnB w="6350" cap="flat" cmpd="sng" algn="ctr">
-                      <a:solidFill>
-                        <a:srgbClr val="028090"/>
-                      </a:solidFill>
-                      <a:prstDash val="solid"/>
-                      <a:round/>
-                      <a:headEnd type="none" w="med" len="med"/>
-                      <a:tailEnd type="none" w="med" len="med"/>
-                    </a:lnB>
-                    <a:solidFill>
-                      <a:srgbClr val="F4FAFA"/>
+                      <a:srgbClr val="022C33"/>
                     </a:solidFill>
                   </a:tcPr>
                 </a:tc>
@@ -12149,7 +12006,7 @@
                           <a:ea typeface="Calibri" pitchFamily="34" charset="-122"/>
                           <a:cs typeface="Calibri" pitchFamily="34" charset="-120"/>
                         </a:rPr>
-                        <a:t>0.949</a:t>
+                        <a:t>0.952</a:t>
                       </a:r>
                       <a:endParaRPr lang="en-US" sz="1100" dirty="0">
                         <a:latin typeface="Calibri" charset="0"/>
@@ -12217,7 +12074,419 @@
                           <a:ea typeface="Calibri" pitchFamily="34" charset="-122"/>
                           <a:cs typeface="Calibri" pitchFamily="34" charset="-120"/>
                         </a:rPr>
-                        <a:t>0.868</a:t>
+                        <a:t>—</a:t>
+                      </a:r>
+                      <a:endParaRPr lang="en-US" sz="1100" dirty="0">
+                        <a:latin typeface="Calibri" charset="0"/>
+                        <a:ea typeface="Calibri" charset="0"/>
+                        <a:cs typeface="Calibri" charset="0"/>
+                      </a:endParaRPr>
+                    </a:p>
+                  </a:txBody>
+                  <a:tcPr marL="91440" marR="91440" marT="45720" marB="45720">
+                    <a:lnL w="6350" cap="flat" cmpd="sng" algn="ctr">
+                      <a:solidFill>
+                        <a:srgbClr val="028090"/>
+                      </a:solidFill>
+                      <a:prstDash val="solid"/>
+                      <a:round/>
+                      <a:headEnd type="none" w="med" len="med"/>
+                      <a:tailEnd type="none" w="med" len="med"/>
+                    </a:lnL>
+                    <a:lnR w="6350" cap="flat" cmpd="sng" algn="ctr">
+                      <a:solidFill>
+                        <a:srgbClr val="028090"/>
+                      </a:solidFill>
+                      <a:prstDash val="solid"/>
+                      <a:round/>
+                      <a:headEnd type="none" w="med" len="med"/>
+                      <a:tailEnd type="none" w="med" len="med"/>
+                    </a:lnR>
+                    <a:lnT w="6350" cap="flat" cmpd="sng" algn="ctr">
+                      <a:solidFill>
+                        <a:srgbClr val="028090"/>
+                      </a:solidFill>
+                      <a:prstDash val="solid"/>
+                      <a:round/>
+                      <a:headEnd type="none" w="med" len="med"/>
+                      <a:tailEnd type="none" w="med" len="med"/>
+                    </a:lnT>
+                    <a:lnB w="6350" cap="flat" cmpd="sng" algn="ctr">
+                      <a:solidFill>
+                        <a:srgbClr val="028090"/>
+                      </a:solidFill>
+                      <a:prstDash val="solid"/>
+                      <a:round/>
+                      <a:headEnd type="none" w="med" len="med"/>
+                      <a:tailEnd type="none" w="med" len="med"/>
+                    </a:lnB>
+                    <a:solidFill>
+                      <a:srgbClr val="F4FAFA"/>
+                    </a:solidFill>
+                  </a:tcPr>
+                </a:tc>
+                <a:tc>
+                  <a:txBody>
+                    <a:bodyPr/>
+                    <a:lstStyle/>
+                    <a:p>
+                      <a:pPr algn="ctr" indent="0" marL="0">
+                        <a:buNone/>
+                      </a:pPr>
+                      <a:r>
+                        <a:rPr lang="en-US" sz="1100" b="1" dirty="0">
+                          <a:solidFill>
+                            <a:srgbClr val="1A2E30"/>
+                          </a:solidFill>
+                          <a:latin typeface="Calibri" pitchFamily="34" charset="0"/>
+                          <a:ea typeface="Calibri" pitchFamily="34" charset="-122"/>
+                          <a:cs typeface="Calibri" pitchFamily="34" charset="-120"/>
+                        </a:rPr>
+                        <a:t>0.952</a:t>
+                      </a:r>
+                      <a:endParaRPr lang="en-US" sz="1100" dirty="0">
+                        <a:latin typeface="Calibri" charset="0"/>
+                        <a:ea typeface="Calibri" charset="0"/>
+                        <a:cs typeface="Calibri" charset="0"/>
+                      </a:endParaRPr>
+                    </a:p>
+                  </a:txBody>
+                  <a:tcPr marL="91440" marR="91440" marT="45720" marB="45720">
+                    <a:lnL w="6350" cap="flat" cmpd="sng" algn="ctr">
+                      <a:solidFill>
+                        <a:srgbClr val="028090"/>
+                      </a:solidFill>
+                      <a:prstDash val="solid"/>
+                      <a:round/>
+                      <a:headEnd type="none" w="med" len="med"/>
+                      <a:tailEnd type="none" w="med" len="med"/>
+                    </a:lnL>
+                    <a:lnR w="6350" cap="flat" cmpd="sng" algn="ctr">
+                      <a:solidFill>
+                        <a:srgbClr val="028090"/>
+                      </a:solidFill>
+                      <a:prstDash val="solid"/>
+                      <a:round/>
+                      <a:headEnd type="none" w="med" len="med"/>
+                      <a:tailEnd type="none" w="med" len="med"/>
+                    </a:lnR>
+                    <a:lnT w="6350" cap="flat" cmpd="sng" algn="ctr">
+                      <a:solidFill>
+                        <a:srgbClr val="028090"/>
+                      </a:solidFill>
+                      <a:prstDash val="solid"/>
+                      <a:round/>
+                      <a:headEnd type="none" w="med" len="med"/>
+                      <a:tailEnd type="none" w="med" len="med"/>
+                    </a:lnT>
+                    <a:lnB w="6350" cap="flat" cmpd="sng" algn="ctr">
+                      <a:solidFill>
+                        <a:srgbClr val="028090"/>
+                      </a:solidFill>
+                      <a:prstDash val="solid"/>
+                      <a:round/>
+                      <a:headEnd type="none" w="med" len="med"/>
+                      <a:tailEnd type="none" w="med" len="med"/>
+                    </a:lnB>
+                    <a:solidFill>
+                      <a:srgbClr val="F4FAFA"/>
+                    </a:solidFill>
+                  </a:tcPr>
+                </a:tc>
+              </a:tr>
+              <a:tr h="347472">
+                <a:tc>
+                  <a:txBody>
+                    <a:bodyPr/>
+                    <a:lstStyle/>
+                    <a:p>
+                      <a:pPr indent="0" marL="0">
+                        <a:buNone/>
+                      </a:pPr>
+                      <a:r>
+                        <a:rPr lang="en-US" sz="1100" dirty="0">
+                          <a:solidFill>
+                            <a:srgbClr val="5A8087"/>
+                          </a:solidFill>
+                          <a:latin typeface="Calibri" pitchFamily="34" charset="0"/>
+                          <a:ea typeface="Calibri" pitchFamily="34" charset="-122"/>
+                          <a:cs typeface="Calibri" pitchFamily="34" charset="-120"/>
+                        </a:rPr>
+                        <a:t>docs/ 🥉</a:t>
+                      </a:r>
+                      <a:endParaRPr lang="en-US" sz="1100" dirty="0">
+                        <a:latin typeface="Calibri" charset="0"/>
+                        <a:ea typeface="Calibri" charset="0"/>
+                        <a:cs typeface="Calibri" charset="0"/>
+                      </a:endParaRPr>
+                    </a:p>
+                  </a:txBody>
+                  <a:tcPr marL="91440" marR="91440" marT="45720" marB="45720">
+                    <a:lnL w="6350" cap="flat" cmpd="sng" algn="ctr">
+                      <a:solidFill>
+                        <a:srgbClr val="028090"/>
+                      </a:solidFill>
+                      <a:prstDash val="solid"/>
+                      <a:round/>
+                      <a:headEnd type="none" w="med" len="med"/>
+                      <a:tailEnd type="none" w="med" len="med"/>
+                    </a:lnL>
+                    <a:lnR w="6350" cap="flat" cmpd="sng" algn="ctr">
+                      <a:solidFill>
+                        <a:srgbClr val="028090"/>
+                      </a:solidFill>
+                      <a:prstDash val="solid"/>
+                      <a:round/>
+                      <a:headEnd type="none" w="med" len="med"/>
+                      <a:tailEnd type="none" w="med" len="med"/>
+                    </a:lnR>
+                    <a:lnT w="6350" cap="flat" cmpd="sng" algn="ctr">
+                      <a:solidFill>
+                        <a:srgbClr val="028090"/>
+                      </a:solidFill>
+                      <a:prstDash val="solid"/>
+                      <a:round/>
+                      <a:headEnd type="none" w="med" len="med"/>
+                      <a:tailEnd type="none" w="med" len="med"/>
+                    </a:lnT>
+                    <a:lnB w="6350" cap="flat" cmpd="sng" algn="ctr">
+                      <a:solidFill>
+                        <a:srgbClr val="028090"/>
+                      </a:solidFill>
+                      <a:prstDash val="solid"/>
+                      <a:round/>
+                      <a:headEnd type="none" w="med" len="med"/>
+                      <a:tailEnd type="none" w="med" len="med"/>
+                    </a:lnB>
+                    <a:solidFill>
+                      <a:srgbClr val="EFF6F6"/>
+                    </a:solidFill>
+                  </a:tcPr>
+                </a:tc>
+                <a:tc>
+                  <a:txBody>
+                    <a:bodyPr/>
+                    <a:lstStyle/>
+                    <a:p>
+                      <a:pPr algn="ctr" indent="0" marL="0">
+                        <a:buNone/>
+                      </a:pPr>
+                      <a:r>
+                        <a:rPr lang="en-US" sz="1100" dirty="0">
+                          <a:solidFill>
+                            <a:srgbClr val="5A8087"/>
+                          </a:solidFill>
+                          <a:latin typeface="Calibri" pitchFamily="34" charset="0"/>
+                          <a:ea typeface="Calibri" pitchFamily="34" charset="-122"/>
+                          <a:cs typeface="Calibri" pitchFamily="34" charset="-120"/>
+                        </a:rPr>
+                        <a:t>0.951</a:t>
+                      </a:r>
+                      <a:endParaRPr lang="en-US" sz="1100" dirty="0">
+                        <a:latin typeface="Calibri" charset="0"/>
+                        <a:ea typeface="Calibri" charset="0"/>
+                        <a:cs typeface="Calibri" charset="0"/>
+                      </a:endParaRPr>
+                    </a:p>
+                  </a:txBody>
+                  <a:tcPr marL="91440" marR="91440" marT="45720" marB="45720">
+                    <a:lnL w="6350" cap="flat" cmpd="sng" algn="ctr">
+                      <a:solidFill>
+                        <a:srgbClr val="028090"/>
+                      </a:solidFill>
+                      <a:prstDash val="solid"/>
+                      <a:round/>
+                      <a:headEnd type="none" w="med" len="med"/>
+                      <a:tailEnd type="none" w="med" len="med"/>
+                    </a:lnL>
+                    <a:lnR w="6350" cap="flat" cmpd="sng" algn="ctr">
+                      <a:solidFill>
+                        <a:srgbClr val="028090"/>
+                      </a:solidFill>
+                      <a:prstDash val="solid"/>
+                      <a:round/>
+                      <a:headEnd type="none" w="med" len="med"/>
+                      <a:tailEnd type="none" w="med" len="med"/>
+                    </a:lnR>
+                    <a:lnT w="6350" cap="flat" cmpd="sng" algn="ctr">
+                      <a:solidFill>
+                        <a:srgbClr val="028090"/>
+                      </a:solidFill>
+                      <a:prstDash val="solid"/>
+                      <a:round/>
+                      <a:headEnd type="none" w="med" len="med"/>
+                      <a:tailEnd type="none" w="med" len="med"/>
+                    </a:lnT>
+                    <a:lnB w="6350" cap="flat" cmpd="sng" algn="ctr">
+                      <a:solidFill>
+                        <a:srgbClr val="028090"/>
+                      </a:solidFill>
+                      <a:prstDash val="solid"/>
+                      <a:round/>
+                      <a:headEnd type="none" w="med" len="med"/>
+                      <a:tailEnd type="none" w="med" len="med"/>
+                    </a:lnB>
+                    <a:solidFill>
+                      <a:srgbClr val="EFF6F6"/>
+                    </a:solidFill>
+                  </a:tcPr>
+                </a:tc>
+                <a:tc>
+                  <a:txBody>
+                    <a:bodyPr/>
+                    <a:lstStyle/>
+                    <a:p>
+                      <a:pPr algn="ctr" indent="0" marL="0">
+                        <a:buNone/>
+                      </a:pPr>
+                      <a:r>
+                        <a:rPr lang="en-US" sz="1100" dirty="0">
+                          <a:solidFill>
+                            <a:srgbClr val="5A8087"/>
+                          </a:solidFill>
+                          <a:latin typeface="Calibri" pitchFamily="34" charset="0"/>
+                          <a:ea typeface="Calibri" pitchFamily="34" charset="-122"/>
+                          <a:cs typeface="Calibri" pitchFamily="34" charset="-120"/>
+                        </a:rPr>
+                        <a:t>—</a:t>
+                      </a:r>
+                      <a:endParaRPr lang="en-US" sz="1100" dirty="0">
+                        <a:latin typeface="Calibri" charset="0"/>
+                        <a:ea typeface="Calibri" charset="0"/>
+                        <a:cs typeface="Calibri" charset="0"/>
+                      </a:endParaRPr>
+                    </a:p>
+                  </a:txBody>
+                  <a:tcPr marL="91440" marR="91440" marT="45720" marB="45720">
+                    <a:lnL w="6350" cap="flat" cmpd="sng" algn="ctr">
+                      <a:solidFill>
+                        <a:srgbClr val="028090"/>
+                      </a:solidFill>
+                      <a:prstDash val="solid"/>
+                      <a:round/>
+                      <a:headEnd type="none" w="med" len="med"/>
+                      <a:tailEnd type="none" w="med" len="med"/>
+                    </a:lnL>
+                    <a:lnR w="6350" cap="flat" cmpd="sng" algn="ctr">
+                      <a:solidFill>
+                        <a:srgbClr val="028090"/>
+                      </a:solidFill>
+                      <a:prstDash val="solid"/>
+                      <a:round/>
+                      <a:headEnd type="none" w="med" len="med"/>
+                      <a:tailEnd type="none" w="med" len="med"/>
+                    </a:lnR>
+                    <a:lnT w="6350" cap="flat" cmpd="sng" algn="ctr">
+                      <a:solidFill>
+                        <a:srgbClr val="028090"/>
+                      </a:solidFill>
+                      <a:prstDash val="solid"/>
+                      <a:round/>
+                      <a:headEnd type="none" w="med" len="med"/>
+                      <a:tailEnd type="none" w="med" len="med"/>
+                    </a:lnT>
+                    <a:lnB w="6350" cap="flat" cmpd="sng" algn="ctr">
+                      <a:solidFill>
+                        <a:srgbClr val="028090"/>
+                      </a:solidFill>
+                      <a:prstDash val="solid"/>
+                      <a:round/>
+                      <a:headEnd type="none" w="med" len="med"/>
+                      <a:tailEnd type="none" w="med" len="med"/>
+                    </a:lnB>
+                    <a:solidFill>
+                      <a:srgbClr val="EFF6F6"/>
+                    </a:solidFill>
+                  </a:tcPr>
+                </a:tc>
+                <a:tc>
+                  <a:txBody>
+                    <a:bodyPr/>
+                    <a:lstStyle/>
+                    <a:p>
+                      <a:pPr algn="ctr" indent="0" marL="0">
+                        <a:buNone/>
+                      </a:pPr>
+                      <a:r>
+                        <a:rPr lang="en-US" sz="1100" dirty="0">
+                          <a:solidFill>
+                            <a:srgbClr val="5A8087"/>
+                          </a:solidFill>
+                          <a:latin typeface="Calibri" pitchFamily="34" charset="0"/>
+                          <a:ea typeface="Calibri" pitchFamily="34" charset="-122"/>
+                          <a:cs typeface="Calibri" pitchFamily="34" charset="-120"/>
+                        </a:rPr>
+                        <a:t>0.951</a:t>
+                      </a:r>
+                      <a:endParaRPr lang="en-US" sz="1100" dirty="0">
+                        <a:latin typeface="Calibri" charset="0"/>
+                        <a:ea typeface="Calibri" charset="0"/>
+                        <a:cs typeface="Calibri" charset="0"/>
+                      </a:endParaRPr>
+                    </a:p>
+                  </a:txBody>
+                  <a:tcPr marL="91440" marR="91440" marT="45720" marB="45720">
+                    <a:lnL w="6350" cap="flat" cmpd="sng" algn="ctr">
+                      <a:solidFill>
+                        <a:srgbClr val="028090"/>
+                      </a:solidFill>
+                      <a:prstDash val="solid"/>
+                      <a:round/>
+                      <a:headEnd type="none" w="med" len="med"/>
+                      <a:tailEnd type="none" w="med" len="med"/>
+                    </a:lnL>
+                    <a:lnR w="6350" cap="flat" cmpd="sng" algn="ctr">
+                      <a:solidFill>
+                        <a:srgbClr val="028090"/>
+                      </a:solidFill>
+                      <a:prstDash val="solid"/>
+                      <a:round/>
+                      <a:headEnd type="none" w="med" len="med"/>
+                      <a:tailEnd type="none" w="med" len="med"/>
+                    </a:lnR>
+                    <a:lnT w="6350" cap="flat" cmpd="sng" algn="ctr">
+                      <a:solidFill>
+                        <a:srgbClr val="028090"/>
+                      </a:solidFill>
+                      <a:prstDash val="solid"/>
+                      <a:round/>
+                      <a:headEnd type="none" w="med" len="med"/>
+                      <a:tailEnd type="none" w="med" len="med"/>
+                    </a:lnT>
+                    <a:lnB w="6350" cap="flat" cmpd="sng" algn="ctr">
+                      <a:solidFill>
+                        <a:srgbClr val="028090"/>
+                      </a:solidFill>
+                      <a:prstDash val="solid"/>
+                      <a:round/>
+                      <a:headEnd type="none" w="med" len="med"/>
+                      <a:tailEnd type="none" w="med" len="med"/>
+                    </a:lnB>
+                    <a:solidFill>
+                      <a:srgbClr val="EFF6F6"/>
+                    </a:solidFill>
+                  </a:tcPr>
+                </a:tc>
+              </a:tr>
+              <a:tr h="347472">
+                <a:tc>
+                  <a:txBody>
+                    <a:bodyPr/>
+                    <a:lstStyle/>
+                    <a:p>
+                      <a:pPr indent="0" marL="0">
+                        <a:buNone/>
+                      </a:pPr>
+                      <a:r>
+                        <a:rPr lang="en-US" sz="1100" dirty="0">
+                          <a:solidFill>
+                            <a:srgbClr val="1A2E30"/>
+                          </a:solidFill>
+                          <a:latin typeface="Calibri" pitchFamily="34" charset="0"/>
+                          <a:ea typeface="Calibri" pitchFamily="34" charset="-122"/>
+                          <a:cs typeface="Calibri" pitchFamily="34" charset="-120"/>
+                        </a:rPr>
+                        <a:t>MS Learn</a:t>
                       </a:r>
                       <a:endParaRPr lang="en-US" sz="1100" dirty="0">
                         <a:latin typeface="Calibri" charset="0"/>
@@ -12285,7 +12554,75 @@
                           <a:ea typeface="Calibri" pitchFamily="34" charset="-122"/>
                           <a:cs typeface="Calibri" pitchFamily="34" charset="-120"/>
                         </a:rPr>
-                        <a:t>0.905</a:t>
+                        <a:t>0.947</a:t>
+                      </a:r>
+                      <a:endParaRPr lang="en-US" sz="1100" dirty="0">
+                        <a:latin typeface="Calibri" charset="0"/>
+                        <a:ea typeface="Calibri" charset="0"/>
+                        <a:cs typeface="Calibri" charset="0"/>
+                      </a:endParaRPr>
+                    </a:p>
+                  </a:txBody>
+                  <a:tcPr marL="91440" marR="91440" marT="45720" marB="45720">
+                    <a:lnL w="6350" cap="flat" cmpd="sng" algn="ctr">
+                      <a:solidFill>
+                        <a:srgbClr val="028090"/>
+                      </a:solidFill>
+                      <a:prstDash val="solid"/>
+                      <a:round/>
+                      <a:headEnd type="none" w="med" len="med"/>
+                      <a:tailEnd type="none" w="med" len="med"/>
+                    </a:lnL>
+                    <a:lnR w="6350" cap="flat" cmpd="sng" algn="ctr">
+                      <a:solidFill>
+                        <a:srgbClr val="028090"/>
+                      </a:solidFill>
+                      <a:prstDash val="solid"/>
+                      <a:round/>
+                      <a:headEnd type="none" w="med" len="med"/>
+                      <a:tailEnd type="none" w="med" len="med"/>
+                    </a:lnR>
+                    <a:lnT w="6350" cap="flat" cmpd="sng" algn="ctr">
+                      <a:solidFill>
+                        <a:srgbClr val="028090"/>
+                      </a:solidFill>
+                      <a:prstDash val="solid"/>
+                      <a:round/>
+                      <a:headEnd type="none" w="med" len="med"/>
+                      <a:tailEnd type="none" w="med" len="med"/>
+                    </a:lnT>
+                    <a:lnB w="6350" cap="flat" cmpd="sng" algn="ctr">
+                      <a:solidFill>
+                        <a:srgbClr val="028090"/>
+                      </a:solidFill>
+                      <a:prstDash val="solid"/>
+                      <a:round/>
+                      <a:headEnd type="none" w="med" len="med"/>
+                      <a:tailEnd type="none" w="med" len="med"/>
+                    </a:lnB>
+                    <a:solidFill>
+                      <a:srgbClr val="F4FAFA"/>
+                    </a:solidFill>
+                  </a:tcPr>
+                </a:tc>
+                <a:tc>
+                  <a:txBody>
+                    <a:bodyPr/>
+                    <a:lstStyle/>
+                    <a:p>
+                      <a:pPr algn="ctr" indent="0" marL="0">
+                        <a:buNone/>
+                      </a:pPr>
+                      <a:r>
+                        <a:rPr lang="en-US" sz="1100" dirty="0">
+                          <a:solidFill>
+                            <a:srgbClr val="1A2E30"/>
+                          </a:solidFill>
+                          <a:latin typeface="Calibri" pitchFamily="34" charset="0"/>
+                          <a:ea typeface="Calibri" pitchFamily="34" charset="-122"/>
+                          <a:cs typeface="Calibri" pitchFamily="34" charset="-120"/>
+                        </a:rPr>
+                        <a:t>—</a:t>
                       </a:r>
                       <a:endParaRPr lang="en-US" sz="1100" dirty="0">
                         <a:latin typeface="Calibri" charset="0"/>
@@ -12353,7 +12690,7 @@
                           <a:ea typeface="Calibri" pitchFamily="34" charset="-122"/>
                           <a:cs typeface="Calibri" pitchFamily="34" charset="-120"/>
                         </a:rPr>
-                        <a:t>0.908</a:t>
+                        <a:t>0.947</a:t>
                       </a:r>
                       <a:endParaRPr lang="en-US" sz="1100" dirty="0">
                         <a:latin typeface="Calibri" charset="0"/>
@@ -12405,690 +12742,6 @@
                   </a:tcPr>
                 </a:tc>
               </a:tr>
-              <a:tr h="347472">
-                <a:tc>
-                  <a:txBody>
-                    <a:bodyPr/>
-                    <a:lstStyle/>
-                    <a:p>
-                      <a:pPr indent="0" marL="0">
-                        <a:buNone/>
-                      </a:pPr>
-                      <a:r>
-                        <a:rPr lang="en-US" sz="1100" b="1" dirty="0">
-                          <a:solidFill>
-                            <a:srgbClr val="02C39A"/>
-                          </a:solidFill>
-                          <a:latin typeface="Calibri" pitchFamily="34" charset="0"/>
-                          <a:ea typeface="Calibri" pitchFamily="34" charset="-122"/>
-                          <a:cs typeface="Calibri" pitchFamily="34" charset="-120"/>
-                        </a:rPr>
-                        <a:t>docs-vnext/ 🥉</a:t>
-                      </a:r>
-                      <a:endParaRPr lang="en-US" sz="1100" dirty="0">
-                        <a:latin typeface="Calibri" charset="0"/>
-                        <a:ea typeface="Calibri" charset="0"/>
-                        <a:cs typeface="Calibri" charset="0"/>
-                      </a:endParaRPr>
-                    </a:p>
-                  </a:txBody>
-                  <a:tcPr marL="91440" marR="91440" marT="45720" marB="45720">
-                    <a:lnL w="6350" cap="flat" cmpd="sng" algn="ctr">
-                      <a:solidFill>
-                        <a:srgbClr val="028090"/>
-                      </a:solidFill>
-                      <a:prstDash val="solid"/>
-                      <a:round/>
-                      <a:headEnd type="none" w="med" len="med"/>
-                      <a:tailEnd type="none" w="med" len="med"/>
-                    </a:lnL>
-                    <a:lnR w="6350" cap="flat" cmpd="sng" algn="ctr">
-                      <a:solidFill>
-                        <a:srgbClr val="028090"/>
-                      </a:solidFill>
-                      <a:prstDash val="solid"/>
-                      <a:round/>
-                      <a:headEnd type="none" w="med" len="med"/>
-                      <a:tailEnd type="none" w="med" len="med"/>
-                    </a:lnR>
-                    <a:lnT w="6350" cap="flat" cmpd="sng" algn="ctr">
-                      <a:solidFill>
-                        <a:srgbClr val="028090"/>
-                      </a:solidFill>
-                      <a:prstDash val="solid"/>
-                      <a:round/>
-                      <a:headEnd type="none" w="med" len="med"/>
-                      <a:tailEnd type="none" w="med" len="med"/>
-                    </a:lnT>
-                    <a:lnB w="6350" cap="flat" cmpd="sng" algn="ctr">
-                      <a:solidFill>
-                        <a:srgbClr val="028090"/>
-                      </a:solidFill>
-                      <a:prstDash val="solid"/>
-                      <a:round/>
-                      <a:headEnd type="none" w="med" len="med"/>
-                      <a:tailEnd type="none" w="med" len="med"/>
-                    </a:lnB>
-                    <a:solidFill>
-                      <a:srgbClr val="022C33"/>
-                    </a:solidFill>
-                  </a:tcPr>
-                </a:tc>
-                <a:tc>
-                  <a:txBody>
-                    <a:bodyPr/>
-                    <a:lstStyle/>
-                    <a:p>
-                      <a:pPr algn="ctr" indent="0" marL="0">
-                        <a:buNone/>
-                      </a:pPr>
-                      <a:r>
-                        <a:rPr lang="en-US" sz="1100" b="1" dirty="0">
-                          <a:solidFill>
-                            <a:srgbClr val="02C39A"/>
-                          </a:solidFill>
-                          <a:latin typeface="Calibri" pitchFamily="34" charset="0"/>
-                          <a:ea typeface="Calibri" pitchFamily="34" charset="-122"/>
-                          <a:cs typeface="Calibri" pitchFamily="34" charset="-120"/>
-                        </a:rPr>
-                        <a:t>0.927</a:t>
-                      </a:r>
-                      <a:endParaRPr lang="en-US" sz="1100" dirty="0">
-                        <a:latin typeface="Calibri" charset="0"/>
-                        <a:ea typeface="Calibri" charset="0"/>
-                        <a:cs typeface="Calibri" charset="0"/>
-                      </a:endParaRPr>
-                    </a:p>
-                  </a:txBody>
-                  <a:tcPr marL="91440" marR="91440" marT="45720" marB="45720">
-                    <a:lnL w="6350" cap="flat" cmpd="sng" algn="ctr">
-                      <a:solidFill>
-                        <a:srgbClr val="028090"/>
-                      </a:solidFill>
-                      <a:prstDash val="solid"/>
-                      <a:round/>
-                      <a:headEnd type="none" w="med" len="med"/>
-                      <a:tailEnd type="none" w="med" len="med"/>
-                    </a:lnL>
-                    <a:lnR w="6350" cap="flat" cmpd="sng" algn="ctr">
-                      <a:solidFill>
-                        <a:srgbClr val="028090"/>
-                      </a:solidFill>
-                      <a:prstDash val="solid"/>
-                      <a:round/>
-                      <a:headEnd type="none" w="med" len="med"/>
-                      <a:tailEnd type="none" w="med" len="med"/>
-                    </a:lnR>
-                    <a:lnT w="6350" cap="flat" cmpd="sng" algn="ctr">
-                      <a:solidFill>
-                        <a:srgbClr val="028090"/>
-                      </a:solidFill>
-                      <a:prstDash val="solid"/>
-                      <a:round/>
-                      <a:headEnd type="none" w="med" len="med"/>
-                      <a:tailEnd type="none" w="med" len="med"/>
-                    </a:lnT>
-                    <a:lnB w="6350" cap="flat" cmpd="sng" algn="ctr">
-                      <a:solidFill>
-                        <a:srgbClr val="028090"/>
-                      </a:solidFill>
-                      <a:prstDash val="solid"/>
-                      <a:round/>
-                      <a:headEnd type="none" w="med" len="med"/>
-                      <a:tailEnd type="none" w="med" len="med"/>
-                    </a:lnB>
-                    <a:solidFill>
-                      <a:srgbClr val="022C33"/>
-                    </a:solidFill>
-                  </a:tcPr>
-                </a:tc>
-                <a:tc>
-                  <a:txBody>
-                    <a:bodyPr/>
-                    <a:lstStyle/>
-                    <a:p>
-                      <a:pPr algn="ctr" indent="0" marL="0">
-                        <a:buNone/>
-                      </a:pPr>
-                      <a:r>
-                        <a:rPr lang="en-US" sz="1100" b="1" dirty="0">
-                          <a:solidFill>
-                            <a:srgbClr val="02C39A"/>
-                          </a:solidFill>
-                          <a:latin typeface="Calibri" pitchFamily="34" charset="0"/>
-                          <a:ea typeface="Calibri" pitchFamily="34" charset="-122"/>
-                          <a:cs typeface="Calibri" pitchFamily="34" charset="-120"/>
-                        </a:rPr>
-                        <a:t>0.879</a:t>
-                      </a:r>
-                      <a:endParaRPr lang="en-US" sz="1100" dirty="0">
-                        <a:latin typeface="Calibri" charset="0"/>
-                        <a:ea typeface="Calibri" charset="0"/>
-                        <a:cs typeface="Calibri" charset="0"/>
-                      </a:endParaRPr>
-                    </a:p>
-                  </a:txBody>
-                  <a:tcPr marL="91440" marR="91440" marT="45720" marB="45720">
-                    <a:lnL w="6350" cap="flat" cmpd="sng" algn="ctr">
-                      <a:solidFill>
-                        <a:srgbClr val="028090"/>
-                      </a:solidFill>
-                      <a:prstDash val="solid"/>
-                      <a:round/>
-                      <a:headEnd type="none" w="med" len="med"/>
-                      <a:tailEnd type="none" w="med" len="med"/>
-                    </a:lnL>
-                    <a:lnR w="6350" cap="flat" cmpd="sng" algn="ctr">
-                      <a:solidFill>
-                        <a:srgbClr val="028090"/>
-                      </a:solidFill>
-                      <a:prstDash val="solid"/>
-                      <a:round/>
-                      <a:headEnd type="none" w="med" len="med"/>
-                      <a:tailEnd type="none" w="med" len="med"/>
-                    </a:lnR>
-                    <a:lnT w="6350" cap="flat" cmpd="sng" algn="ctr">
-                      <a:solidFill>
-                        <a:srgbClr val="028090"/>
-                      </a:solidFill>
-                      <a:prstDash val="solid"/>
-                      <a:round/>
-                      <a:headEnd type="none" w="med" len="med"/>
-                      <a:tailEnd type="none" w="med" len="med"/>
-                    </a:lnT>
-                    <a:lnB w="6350" cap="flat" cmpd="sng" algn="ctr">
-                      <a:solidFill>
-                        <a:srgbClr val="028090"/>
-                      </a:solidFill>
-                      <a:prstDash val="solid"/>
-                      <a:round/>
-                      <a:headEnd type="none" w="med" len="med"/>
-                      <a:tailEnd type="none" w="med" len="med"/>
-                    </a:lnB>
-                    <a:solidFill>
-                      <a:srgbClr val="022C33"/>
-                    </a:solidFill>
-                  </a:tcPr>
-                </a:tc>
-                <a:tc>
-                  <a:txBody>
-                    <a:bodyPr/>
-                    <a:lstStyle/>
-                    <a:p>
-                      <a:pPr algn="ctr" indent="0" marL="0">
-                        <a:buNone/>
-                      </a:pPr>
-                      <a:r>
-                        <a:rPr lang="en-US" sz="1100" b="1" dirty="0">
-                          <a:solidFill>
-                            <a:srgbClr val="02C39A"/>
-                          </a:solidFill>
-                          <a:latin typeface="Calibri" pitchFamily="34" charset="0"/>
-                          <a:ea typeface="Calibri" pitchFamily="34" charset="-122"/>
-                          <a:cs typeface="Calibri" pitchFamily="34" charset="-120"/>
-                        </a:rPr>
-                        <a:t>0.912</a:t>
-                      </a:r>
-                      <a:endParaRPr lang="en-US" sz="1100" dirty="0">
-                        <a:latin typeface="Calibri" charset="0"/>
-                        <a:ea typeface="Calibri" charset="0"/>
-                        <a:cs typeface="Calibri" charset="0"/>
-                      </a:endParaRPr>
-                    </a:p>
-                  </a:txBody>
-                  <a:tcPr marL="91440" marR="91440" marT="45720" marB="45720">
-                    <a:lnL w="6350" cap="flat" cmpd="sng" algn="ctr">
-                      <a:solidFill>
-                        <a:srgbClr val="028090"/>
-                      </a:solidFill>
-                      <a:prstDash val="solid"/>
-                      <a:round/>
-                      <a:headEnd type="none" w="med" len="med"/>
-                      <a:tailEnd type="none" w="med" len="med"/>
-                    </a:lnL>
-                    <a:lnR w="6350" cap="flat" cmpd="sng" algn="ctr">
-                      <a:solidFill>
-                        <a:srgbClr val="028090"/>
-                      </a:solidFill>
-                      <a:prstDash val="solid"/>
-                      <a:round/>
-                      <a:headEnd type="none" w="med" len="med"/>
-                      <a:tailEnd type="none" w="med" len="med"/>
-                    </a:lnR>
-                    <a:lnT w="6350" cap="flat" cmpd="sng" algn="ctr">
-                      <a:solidFill>
-                        <a:srgbClr val="028090"/>
-                      </a:solidFill>
-                      <a:prstDash val="solid"/>
-                      <a:round/>
-                      <a:headEnd type="none" w="med" len="med"/>
-                      <a:tailEnd type="none" w="med" len="med"/>
-                    </a:lnT>
-                    <a:lnB w="6350" cap="flat" cmpd="sng" algn="ctr">
-                      <a:solidFill>
-                        <a:srgbClr val="028090"/>
-                      </a:solidFill>
-                      <a:prstDash val="solid"/>
-                      <a:round/>
-                      <a:headEnd type="none" w="med" len="med"/>
-                      <a:tailEnd type="none" w="med" len="med"/>
-                    </a:lnB>
-                    <a:solidFill>
-                      <a:srgbClr val="022C33"/>
-                    </a:solidFill>
-                  </a:tcPr>
-                </a:tc>
-                <a:tc>
-                  <a:txBody>
-                    <a:bodyPr/>
-                    <a:lstStyle/>
-                    <a:p>
-                      <a:pPr algn="ctr" indent="0" marL="0">
-                        <a:buNone/>
-                      </a:pPr>
-                      <a:r>
-                        <a:rPr lang="en-US" sz="1100" b="1" dirty="0">
-                          <a:solidFill>
-                            <a:srgbClr val="02C39A"/>
-                          </a:solidFill>
-                          <a:latin typeface="Calibri" pitchFamily="34" charset="0"/>
-                          <a:ea typeface="Calibri" pitchFamily="34" charset="-122"/>
-                          <a:cs typeface="Calibri" pitchFamily="34" charset="-120"/>
-                        </a:rPr>
-                        <a:t>0.906</a:t>
-                      </a:r>
-                      <a:endParaRPr lang="en-US" sz="1100" dirty="0">
-                        <a:latin typeface="Calibri" charset="0"/>
-                        <a:ea typeface="Calibri" charset="0"/>
-                        <a:cs typeface="Calibri" charset="0"/>
-                      </a:endParaRPr>
-                    </a:p>
-                  </a:txBody>
-                  <a:tcPr marL="91440" marR="91440" marT="45720" marB="45720">
-                    <a:lnL w="6350" cap="flat" cmpd="sng" algn="ctr">
-                      <a:solidFill>
-                        <a:srgbClr val="028090"/>
-                      </a:solidFill>
-                      <a:prstDash val="solid"/>
-                      <a:round/>
-                      <a:headEnd type="none" w="med" len="med"/>
-                      <a:tailEnd type="none" w="med" len="med"/>
-                    </a:lnL>
-                    <a:lnR w="6350" cap="flat" cmpd="sng" algn="ctr">
-                      <a:solidFill>
-                        <a:srgbClr val="028090"/>
-                      </a:solidFill>
-                      <a:prstDash val="solid"/>
-                      <a:round/>
-                      <a:headEnd type="none" w="med" len="med"/>
-                      <a:tailEnd type="none" w="med" len="med"/>
-                    </a:lnR>
-                    <a:lnT w="6350" cap="flat" cmpd="sng" algn="ctr">
-                      <a:solidFill>
-                        <a:srgbClr val="028090"/>
-                      </a:solidFill>
-                      <a:prstDash val="solid"/>
-                      <a:round/>
-                      <a:headEnd type="none" w="med" len="med"/>
-                      <a:tailEnd type="none" w="med" len="med"/>
-                    </a:lnT>
-                    <a:lnB w="6350" cap="flat" cmpd="sng" algn="ctr">
-                      <a:solidFill>
-                        <a:srgbClr val="028090"/>
-                      </a:solidFill>
-                      <a:prstDash val="solid"/>
-                      <a:round/>
-                      <a:headEnd type="none" w="med" len="med"/>
-                      <a:tailEnd type="none" w="med" len="med"/>
-                    </a:lnB>
-                    <a:solidFill>
-                      <a:srgbClr val="022C33"/>
-                    </a:solidFill>
-                  </a:tcPr>
-                </a:tc>
-              </a:tr>
-              <a:tr h="347472">
-                <a:tc>
-                  <a:txBody>
-                    <a:bodyPr/>
-                    <a:lstStyle/>
-                    <a:p>
-                      <a:pPr indent="0" marL="0">
-                        <a:buNone/>
-                      </a:pPr>
-                      <a:r>
-                        <a:rPr lang="en-US" sz="1100" dirty="0">
-                          <a:solidFill>
-                            <a:srgbClr val="5A8087"/>
-                          </a:solidFill>
-                          <a:latin typeface="Calibri" pitchFamily="34" charset="0"/>
-                          <a:ea typeface="Calibri" pitchFamily="34" charset="-122"/>
-                          <a:cs typeface="Calibri" pitchFamily="34" charset="-120"/>
-                        </a:rPr>
-                        <a:t>docs/ (baseline)</a:t>
-                      </a:r>
-                      <a:endParaRPr lang="en-US" sz="1100" dirty="0">
-                        <a:latin typeface="Calibri" charset="0"/>
-                        <a:ea typeface="Calibri" charset="0"/>
-                        <a:cs typeface="Calibri" charset="0"/>
-                      </a:endParaRPr>
-                    </a:p>
-                  </a:txBody>
-                  <a:tcPr marL="91440" marR="91440" marT="45720" marB="45720">
-                    <a:lnL w="6350" cap="flat" cmpd="sng" algn="ctr">
-                      <a:solidFill>
-                        <a:srgbClr val="028090"/>
-                      </a:solidFill>
-                      <a:prstDash val="solid"/>
-                      <a:round/>
-                      <a:headEnd type="none" w="med" len="med"/>
-                      <a:tailEnd type="none" w="med" len="med"/>
-                    </a:lnL>
-                    <a:lnR w="6350" cap="flat" cmpd="sng" algn="ctr">
-                      <a:solidFill>
-                        <a:srgbClr val="028090"/>
-                      </a:solidFill>
-                      <a:prstDash val="solid"/>
-                      <a:round/>
-                      <a:headEnd type="none" w="med" len="med"/>
-                      <a:tailEnd type="none" w="med" len="med"/>
-                    </a:lnR>
-                    <a:lnT w="6350" cap="flat" cmpd="sng" algn="ctr">
-                      <a:solidFill>
-                        <a:srgbClr val="028090"/>
-                      </a:solidFill>
-                      <a:prstDash val="solid"/>
-                      <a:round/>
-                      <a:headEnd type="none" w="med" len="med"/>
-                      <a:tailEnd type="none" w="med" len="med"/>
-                    </a:lnT>
-                    <a:lnB w="6350" cap="flat" cmpd="sng" algn="ctr">
-                      <a:solidFill>
-                        <a:srgbClr val="028090"/>
-                      </a:solidFill>
-                      <a:prstDash val="solid"/>
-                      <a:round/>
-                      <a:headEnd type="none" w="med" len="med"/>
-                      <a:tailEnd type="none" w="med" len="med"/>
-                    </a:lnB>
-                    <a:solidFill>
-                      <a:srgbClr val="EFF6F6"/>
-                    </a:solidFill>
-                  </a:tcPr>
-                </a:tc>
-                <a:tc>
-                  <a:txBody>
-                    <a:bodyPr/>
-                    <a:lstStyle/>
-                    <a:p>
-                      <a:pPr algn="ctr" indent="0" marL="0">
-                        <a:buNone/>
-                      </a:pPr>
-                      <a:r>
-                        <a:rPr lang="en-US" sz="1100" dirty="0">
-                          <a:solidFill>
-                            <a:srgbClr val="5A8087"/>
-                          </a:solidFill>
-                          <a:latin typeface="Calibri" pitchFamily="34" charset="0"/>
-                          <a:ea typeface="Calibri" pitchFamily="34" charset="-122"/>
-                          <a:cs typeface="Calibri" pitchFamily="34" charset="-120"/>
-                        </a:rPr>
-                        <a:t>0.924</a:t>
-                      </a:r>
-                      <a:endParaRPr lang="en-US" sz="1100" dirty="0">
-                        <a:latin typeface="Calibri" charset="0"/>
-                        <a:ea typeface="Calibri" charset="0"/>
-                        <a:cs typeface="Calibri" charset="0"/>
-                      </a:endParaRPr>
-                    </a:p>
-                  </a:txBody>
-                  <a:tcPr marL="91440" marR="91440" marT="45720" marB="45720">
-                    <a:lnL w="6350" cap="flat" cmpd="sng" algn="ctr">
-                      <a:solidFill>
-                        <a:srgbClr val="028090"/>
-                      </a:solidFill>
-                      <a:prstDash val="solid"/>
-                      <a:round/>
-                      <a:headEnd type="none" w="med" len="med"/>
-                      <a:tailEnd type="none" w="med" len="med"/>
-                    </a:lnL>
-                    <a:lnR w="6350" cap="flat" cmpd="sng" algn="ctr">
-                      <a:solidFill>
-                        <a:srgbClr val="028090"/>
-                      </a:solidFill>
-                      <a:prstDash val="solid"/>
-                      <a:round/>
-                      <a:headEnd type="none" w="med" len="med"/>
-                      <a:tailEnd type="none" w="med" len="med"/>
-                    </a:lnR>
-                    <a:lnT w="6350" cap="flat" cmpd="sng" algn="ctr">
-                      <a:solidFill>
-                        <a:srgbClr val="028090"/>
-                      </a:solidFill>
-                      <a:prstDash val="solid"/>
-                      <a:round/>
-                      <a:headEnd type="none" w="med" len="med"/>
-                      <a:tailEnd type="none" w="med" len="med"/>
-                    </a:lnT>
-                    <a:lnB w="6350" cap="flat" cmpd="sng" algn="ctr">
-                      <a:solidFill>
-                        <a:srgbClr val="028090"/>
-                      </a:solidFill>
-                      <a:prstDash val="solid"/>
-                      <a:round/>
-                      <a:headEnd type="none" w="med" len="med"/>
-                      <a:tailEnd type="none" w="med" len="med"/>
-                    </a:lnB>
-                    <a:solidFill>
-                      <a:srgbClr val="EFF6F6"/>
-                    </a:solidFill>
-                  </a:tcPr>
-                </a:tc>
-                <a:tc>
-                  <a:txBody>
-                    <a:bodyPr/>
-                    <a:lstStyle/>
-                    <a:p>
-                      <a:pPr algn="ctr" indent="0" marL="0">
-                        <a:buNone/>
-                      </a:pPr>
-                      <a:r>
-                        <a:rPr lang="en-US" sz="1100" dirty="0">
-                          <a:solidFill>
-                            <a:srgbClr val="5A8087"/>
-                          </a:solidFill>
-                          <a:latin typeface="Calibri" pitchFamily="34" charset="0"/>
-                          <a:ea typeface="Calibri" pitchFamily="34" charset="-122"/>
-                          <a:cs typeface="Calibri" pitchFamily="34" charset="-120"/>
-                        </a:rPr>
-                        <a:t>0.860</a:t>
-                      </a:r>
-                      <a:endParaRPr lang="en-US" sz="1100" dirty="0">
-                        <a:latin typeface="Calibri" charset="0"/>
-                        <a:ea typeface="Calibri" charset="0"/>
-                        <a:cs typeface="Calibri" charset="0"/>
-                      </a:endParaRPr>
-                    </a:p>
-                  </a:txBody>
-                  <a:tcPr marL="91440" marR="91440" marT="45720" marB="45720">
-                    <a:lnL w="6350" cap="flat" cmpd="sng" algn="ctr">
-                      <a:solidFill>
-                        <a:srgbClr val="028090"/>
-                      </a:solidFill>
-                      <a:prstDash val="solid"/>
-                      <a:round/>
-                      <a:headEnd type="none" w="med" len="med"/>
-                      <a:tailEnd type="none" w="med" len="med"/>
-                    </a:lnL>
-                    <a:lnR w="6350" cap="flat" cmpd="sng" algn="ctr">
-                      <a:solidFill>
-                        <a:srgbClr val="028090"/>
-                      </a:solidFill>
-                      <a:prstDash val="solid"/>
-                      <a:round/>
-                      <a:headEnd type="none" w="med" len="med"/>
-                      <a:tailEnd type="none" w="med" len="med"/>
-                    </a:lnR>
-                    <a:lnT w="6350" cap="flat" cmpd="sng" algn="ctr">
-                      <a:solidFill>
-                        <a:srgbClr val="028090"/>
-                      </a:solidFill>
-                      <a:prstDash val="solid"/>
-                      <a:round/>
-                      <a:headEnd type="none" w="med" len="med"/>
-                      <a:tailEnd type="none" w="med" len="med"/>
-                    </a:lnT>
-                    <a:lnB w="6350" cap="flat" cmpd="sng" algn="ctr">
-                      <a:solidFill>
-                        <a:srgbClr val="028090"/>
-                      </a:solidFill>
-                      <a:prstDash val="solid"/>
-                      <a:round/>
-                      <a:headEnd type="none" w="med" len="med"/>
-                      <a:tailEnd type="none" w="med" len="med"/>
-                    </a:lnB>
-                    <a:solidFill>
-                      <a:srgbClr val="EFF6F6"/>
-                    </a:solidFill>
-                  </a:tcPr>
-                </a:tc>
-                <a:tc>
-                  <a:txBody>
-                    <a:bodyPr/>
-                    <a:lstStyle/>
-                    <a:p>
-                      <a:pPr algn="ctr" indent="0" marL="0">
-                        <a:buNone/>
-                      </a:pPr>
-                      <a:r>
-                        <a:rPr lang="en-US" sz="1100" dirty="0">
-                          <a:solidFill>
-                            <a:srgbClr val="5A8087"/>
-                          </a:solidFill>
-                          <a:latin typeface="Calibri" pitchFamily="34" charset="0"/>
-                          <a:ea typeface="Calibri" pitchFamily="34" charset="-122"/>
-                          <a:cs typeface="Calibri" pitchFamily="34" charset="-120"/>
-                        </a:rPr>
-                        <a:t>0.931</a:t>
-                      </a:r>
-                      <a:endParaRPr lang="en-US" sz="1100" dirty="0">
-                        <a:latin typeface="Calibri" charset="0"/>
-                        <a:ea typeface="Calibri" charset="0"/>
-                        <a:cs typeface="Calibri" charset="0"/>
-                      </a:endParaRPr>
-                    </a:p>
-                  </a:txBody>
-                  <a:tcPr marL="91440" marR="91440" marT="45720" marB="45720">
-                    <a:lnL w="6350" cap="flat" cmpd="sng" algn="ctr">
-                      <a:solidFill>
-                        <a:srgbClr val="028090"/>
-                      </a:solidFill>
-                      <a:prstDash val="solid"/>
-                      <a:round/>
-                      <a:headEnd type="none" w="med" len="med"/>
-                      <a:tailEnd type="none" w="med" len="med"/>
-                    </a:lnL>
-                    <a:lnR w="6350" cap="flat" cmpd="sng" algn="ctr">
-                      <a:solidFill>
-                        <a:srgbClr val="028090"/>
-                      </a:solidFill>
-                      <a:prstDash val="solid"/>
-                      <a:round/>
-                      <a:headEnd type="none" w="med" len="med"/>
-                      <a:tailEnd type="none" w="med" len="med"/>
-                    </a:lnR>
-                    <a:lnT w="6350" cap="flat" cmpd="sng" algn="ctr">
-                      <a:solidFill>
-                        <a:srgbClr val="028090"/>
-                      </a:solidFill>
-                      <a:prstDash val="solid"/>
-                      <a:round/>
-                      <a:headEnd type="none" w="med" len="med"/>
-                      <a:tailEnd type="none" w="med" len="med"/>
-                    </a:lnT>
-                    <a:lnB w="6350" cap="flat" cmpd="sng" algn="ctr">
-                      <a:solidFill>
-                        <a:srgbClr val="028090"/>
-                      </a:solidFill>
-                      <a:prstDash val="solid"/>
-                      <a:round/>
-                      <a:headEnd type="none" w="med" len="med"/>
-                      <a:tailEnd type="none" w="med" len="med"/>
-                    </a:lnB>
-                    <a:solidFill>
-                      <a:srgbClr val="EFF6F6"/>
-                    </a:solidFill>
-                  </a:tcPr>
-                </a:tc>
-                <a:tc>
-                  <a:txBody>
-                    <a:bodyPr/>
-                    <a:lstStyle/>
-                    <a:p>
-                      <a:pPr algn="ctr" indent="0" marL="0">
-                        <a:buNone/>
-                      </a:pPr>
-                      <a:r>
-                        <a:rPr lang="en-US" sz="1100" dirty="0">
-                          <a:solidFill>
-                            <a:srgbClr val="5A8087"/>
-                          </a:solidFill>
-                          <a:latin typeface="Calibri" pitchFamily="34" charset="0"/>
-                          <a:ea typeface="Calibri" pitchFamily="34" charset="-122"/>
-                          <a:cs typeface="Calibri" pitchFamily="34" charset="-120"/>
-                        </a:rPr>
-                        <a:t>0.904</a:t>
-                      </a:r>
-                      <a:endParaRPr lang="en-US" sz="1100" dirty="0">
-                        <a:latin typeface="Calibri" charset="0"/>
-                        <a:ea typeface="Calibri" charset="0"/>
-                        <a:cs typeface="Calibri" charset="0"/>
-                      </a:endParaRPr>
-                    </a:p>
-                  </a:txBody>
-                  <a:tcPr marL="91440" marR="91440" marT="45720" marB="45720">
-                    <a:lnL w="6350" cap="flat" cmpd="sng" algn="ctr">
-                      <a:solidFill>
-                        <a:srgbClr val="028090"/>
-                      </a:solidFill>
-                      <a:prstDash val="solid"/>
-                      <a:round/>
-                      <a:headEnd type="none" w="med" len="med"/>
-                      <a:tailEnd type="none" w="med" len="med"/>
-                    </a:lnL>
-                    <a:lnR w="6350" cap="flat" cmpd="sng" algn="ctr">
-                      <a:solidFill>
-                        <a:srgbClr val="028090"/>
-                      </a:solidFill>
-                      <a:prstDash val="solid"/>
-                      <a:round/>
-                      <a:headEnd type="none" w="med" len="med"/>
-                      <a:tailEnd type="none" w="med" len="med"/>
-                    </a:lnR>
-                    <a:lnT w="6350" cap="flat" cmpd="sng" algn="ctr">
-                      <a:solidFill>
-                        <a:srgbClr val="028090"/>
-                      </a:solidFill>
-                      <a:prstDash val="solid"/>
-                      <a:round/>
-                      <a:headEnd type="none" w="med" len="med"/>
-                      <a:tailEnd type="none" w="med" len="med"/>
-                    </a:lnT>
-                    <a:lnB w="6350" cap="flat" cmpd="sng" algn="ctr">
-                      <a:solidFill>
-                        <a:srgbClr val="028090"/>
-                      </a:solidFill>
-                      <a:prstDash val="solid"/>
-                      <a:round/>
-                      <a:headEnd type="none" w="med" len="med"/>
-                      <a:tailEnd type="none" w="med" len="med"/>
-                    </a:lnB>
-                    <a:solidFill>
-                      <a:srgbClr val="EFF6F6"/>
-                    </a:solidFill>
-                  </a:tcPr>
-                </a:tc>
-              </a:tr>
             </a:tbl>
           </a:graphicData>
         </a:graphic>
@@ -13268,7 +12921,7 @@
                 <a:ea typeface="Calibri" pitchFamily="34" charset="-122"/>
                 <a:cs typeface="Calibri" pitchFamily="34" charset="-120"/>
               </a:rPr>
-              <a:t>docs-vnext (0.906) vs docs/ (0.904), δ=+0.002</a:t>
+              <a:t>docs-vnext (0.952) vs docs/ (0.951), δ=+0.001</a:t>
             </a:r>
             <a:endParaRPr lang="en-US" sz="950" dirty="0"/>
           </a:p>
@@ -13365,13 +13018,13 @@
             <a:r>
               <a:rPr lang="en-US" sz="1000" b="1" dirty="0">
                 <a:solidFill>
-                  <a:srgbClr val="C04040"/>
+                  <a:srgbClr val="5A8087"/>
                 </a:solidFill>
                 <a:latin typeface="Trebuchet MS" pitchFamily="34" charset="0"/>
                 <a:ea typeface="Trebuchet MS" pitchFamily="34" charset="-122"/>
                 <a:cs typeface="Trebuchet MS" pitchFamily="34" charset="-120"/>
               </a:rPr>
-              <a:t>❌ REJECTED</a:t>
+              <a:t>➖ NO DIFF</a:t>
             </a:r>
             <a:endParaRPr lang="en-US" sz="1000" dirty="0"/>
           </a:p>
@@ -13410,7 +13063,7 @@
                 <a:ea typeface="Calibri" pitchFamily="34" charset="-122"/>
                 <a:cs typeface="Calibri" pitchFamily="34" charset="-120"/>
               </a:rPr>
-              <a:t>vs Mintlify MCP (0.908), δ=−0.002</a:t>
+              <a:t>vs Mintlify MCP (0.952), δ=+0.000</a:t>
             </a:r>
             <a:endParaRPr lang="en-US" sz="950" dirty="0"/>
           </a:p>
@@ -13507,13 +13160,13 @@
             <a:r>
               <a:rPr lang="en-US" sz="1000" b="1" dirty="0">
                 <a:solidFill>
-                  <a:srgbClr val="C04040"/>
+                  <a:srgbClr val="C9A800"/>
                 </a:solidFill>
                 <a:latin typeface="Trebuchet MS" pitchFamily="34" charset="0"/>
                 <a:ea typeface="Trebuchet MS" pitchFamily="34" charset="-122"/>
                 <a:cs typeface="Trebuchet MS" pitchFamily="34" charset="-120"/>
               </a:rPr>
-              <a:t>❌ REJECTED</a:t>
+              <a:t>⚠️ MARGINAL</a:t>
             </a:r>
             <a:endParaRPr lang="en-US" sz="1000" dirty="0"/>
           </a:p>
@@ -13552,7 +13205,7 @@
                 <a:ea typeface="Calibri" pitchFamily="34" charset="-122"/>
                 <a:cs typeface="Calibri" pitchFamily="34" charset="-120"/>
               </a:rPr>
-              <a:t>vs MS Learn (0.908), δ=−0.002</a:t>
+              <a:t>vs MS Learn (0.947), δ=+0.005</a:t>
             </a:r>
             <a:endParaRPr lang="en-US" sz="950" dirty="0"/>
           </a:p>
@@ -13649,13 +13302,13 @@
             <a:r>
               <a:rPr lang="en-US" sz="1000" b="1" dirty="0">
                 <a:solidFill>
-                  <a:srgbClr val="C9A800"/>
+                  <a:srgbClr val="00A896"/>
                 </a:solidFill>
                 <a:latin typeface="Trebuchet MS" pitchFamily="34" charset="0"/>
                 <a:ea typeface="Trebuchet MS" pitchFamily="34" charset="-122"/>
                 <a:cs typeface="Trebuchet MS" pitchFamily="34" charset="-120"/>
               </a:rPr>
-              <a:t>⚠️ MIXED</a:t>
+              <a:t>✅ SUPPORTED</a:t>
             </a:r>
             <a:endParaRPr lang="en-US" sz="1000" dirty="0"/>
           </a:p>
@@ -13694,7 +13347,7 @@
                 <a:ea typeface="Calibri" pitchFamily="34" charset="-122"/>
                 <a:cs typeface="Calibri" pitchFamily="34" charset="-120"/>
               </a:rPr>
-              <a:t>Rankings vary: gpt-5.3 ranks docs-vnext 2nd</a:t>
+              <a:t>Rankings consistent: vnext ≥ docs/ across models</a:t>
             </a:r>
             <a:endParaRPr lang="en-US" sz="950" dirty="0"/>
           </a:p>
@@ -13812,7 +13465,391 @@
         <p:spPr>
           <a:xfrm>
             <a:off x="5687568" y="1828800"/>
-            <a:ext cx="2505822" cy="256032"/>
+            <a:ext cx="2528499" cy="256032"/>
+          </a:xfrm>
+          <a:prstGeom prst="rect">
+            <a:avLst/>
+          </a:prstGeom>
+          <a:solidFill>
+            <a:srgbClr val="5A8087"/>
+          </a:solidFill>
+          <a:ln w="12700">
+            <a:solidFill>
+              <a:srgbClr val="5A8087"/>
+            </a:solidFill>
+            <a:prstDash val="solid"/>
+          </a:ln>
+        </p:spPr>
+      </p:sp>
+      <p:sp>
+        <p:nvSpPr>
+          <p:cNvPr id="27" name="Text 24"/>
+          <p:cNvSpPr/>
+          <p:nvPr/>
+        </p:nvSpPr>
+        <p:spPr>
+          <a:xfrm>
+            <a:off x="8595360" y="1828800"/>
+            <a:ext cx="502920" cy="256032"/>
+          </a:xfrm>
+          <a:prstGeom prst="rect">
+            <a:avLst/>
+          </a:prstGeom>
+          <a:noFill/>
+          <a:ln/>
+        </p:spPr>
+        <p:txBody>
+          <a:bodyPr wrap="square" lIns="0" tIns="0" rIns="0" bIns="0" rtlCol="0" anchor="ctr"/>
+          <a:lstStyle/>
+          <a:p>
+            <a:pPr indent="0" marL="0">
+              <a:buNone/>
+            </a:pPr>
+            <a:r>
+              <a:rPr lang="en-US" sz="900" dirty="0">
+                <a:solidFill>
+                  <a:srgbClr val="5A8087"/>
+                </a:solidFill>
+                <a:latin typeface="Calibri" pitchFamily="34" charset="0"/>
+                <a:ea typeface="Calibri" pitchFamily="34" charset="-122"/>
+                <a:cs typeface="Calibri" pitchFamily="34" charset="-120"/>
+              </a:rPr>
+              <a:t>0.973 —</a:t>
+            </a:r>
+            <a:endParaRPr lang="en-US" sz="900" dirty="0"/>
+          </a:p>
+        </p:txBody>
+      </p:sp>
+      <p:sp>
+        <p:nvSpPr>
+          <p:cNvPr id="28" name="Text 25"/>
+          <p:cNvSpPr/>
+          <p:nvPr/>
+        </p:nvSpPr>
+        <p:spPr>
+          <a:xfrm>
+            <a:off x="5687568" y="2231136"/>
+            <a:ext cx="3108960" cy="228600"/>
+          </a:xfrm>
+          <a:prstGeom prst="rect">
+            <a:avLst/>
+          </a:prstGeom>
+          <a:noFill/>
+          <a:ln/>
+        </p:spPr>
+        <p:txBody>
+          <a:bodyPr wrap="square" lIns="0" tIns="0" rIns="0" bIns="0" rtlCol="0" anchor="ctr"/>
+          <a:lstStyle/>
+          <a:p>
+            <a:pPr indent="0" marL="0">
+              <a:buNone/>
+            </a:pPr>
+            <a:r>
+              <a:rPr lang="en-US" sz="950" dirty="0">
+                <a:solidFill>
+                  <a:srgbClr val="B8DADD"/>
+                </a:solidFill>
+                <a:latin typeface="Consolas" pitchFamily="34" charset="0"/>
+                <a:ea typeface="Consolas" pitchFamily="34" charset="-122"/>
+                <a:cs typeface="Consolas" pitchFamily="34" charset="-120"/>
+              </a:rPr>
+              <a:t>getting-started</a:t>
+            </a:r>
+            <a:endParaRPr lang="en-US" sz="950" dirty="0"/>
+          </a:p>
+        </p:txBody>
+      </p:sp>
+      <p:sp>
+        <p:nvSpPr>
+          <p:cNvPr id="29" name="Shape 26"/>
+          <p:cNvSpPr/>
+          <p:nvPr/>
+        </p:nvSpPr>
+        <p:spPr>
+          <a:xfrm>
+            <a:off x="5687568" y="2487168"/>
+            <a:ext cx="2834640" cy="256032"/>
+          </a:xfrm>
+          <a:prstGeom prst="rect">
+            <a:avLst/>
+          </a:prstGeom>
+          <a:solidFill>
+            <a:srgbClr val="022C33"/>
+          </a:solidFill>
+          <a:ln w="12700">
+            <a:solidFill>
+              <a:srgbClr val="028090"/>
+            </a:solidFill>
+            <a:prstDash val="solid"/>
+          </a:ln>
+        </p:spPr>
+      </p:sp>
+      <p:sp>
+        <p:nvSpPr>
+          <p:cNvPr id="30" name="Shape 27"/>
+          <p:cNvSpPr/>
+          <p:nvPr/>
+        </p:nvSpPr>
+        <p:spPr>
+          <a:xfrm>
+            <a:off x="5687568" y="2487168"/>
+            <a:ext cx="1848185" cy="256032"/>
+          </a:xfrm>
+          <a:prstGeom prst="rect">
+            <a:avLst/>
+          </a:prstGeom>
+          <a:solidFill>
+            <a:srgbClr val="5A8087"/>
+          </a:solidFill>
+          <a:ln w="12700">
+            <a:solidFill>
+              <a:srgbClr val="5A8087"/>
+            </a:solidFill>
+            <a:prstDash val="solid"/>
+          </a:ln>
+        </p:spPr>
+      </p:sp>
+      <p:sp>
+        <p:nvSpPr>
+          <p:cNvPr id="31" name="Text 28"/>
+          <p:cNvSpPr/>
+          <p:nvPr/>
+        </p:nvSpPr>
+        <p:spPr>
+          <a:xfrm>
+            <a:off x="8595360" y="2487168"/>
+            <a:ext cx="502920" cy="256032"/>
+          </a:xfrm>
+          <a:prstGeom prst="rect">
+            <a:avLst/>
+          </a:prstGeom>
+          <a:noFill/>
+          <a:ln/>
+        </p:spPr>
+        <p:txBody>
+          <a:bodyPr wrap="square" lIns="0" tIns="0" rIns="0" bIns="0" rtlCol="0" anchor="ctr"/>
+          <a:lstStyle/>
+          <a:p>
+            <a:pPr indent="0" marL="0">
+              <a:buNone/>
+            </a:pPr>
+            <a:r>
+              <a:rPr lang="en-US" sz="900" dirty="0">
+                <a:solidFill>
+                  <a:srgbClr val="5A8087"/>
+                </a:solidFill>
+                <a:latin typeface="Calibri" pitchFamily="34" charset="0"/>
+                <a:ea typeface="Calibri" pitchFamily="34" charset="-122"/>
+                <a:cs typeface="Calibri" pitchFamily="34" charset="-120"/>
+              </a:rPr>
+              <a:t>0.913 —</a:t>
+            </a:r>
+            <a:endParaRPr lang="en-US" sz="900" dirty="0"/>
+          </a:p>
+        </p:txBody>
+      </p:sp>
+      <p:sp>
+        <p:nvSpPr>
+          <p:cNvPr id="32" name="Text 29"/>
+          <p:cNvSpPr/>
+          <p:nvPr/>
+        </p:nvSpPr>
+        <p:spPr>
+          <a:xfrm>
+            <a:off x="5687568" y="2889504"/>
+            <a:ext cx="3108960" cy="228600"/>
+          </a:xfrm>
+          <a:prstGeom prst="rect">
+            <a:avLst/>
+          </a:prstGeom>
+          <a:noFill/>
+          <a:ln/>
+        </p:spPr>
+        <p:txBody>
+          <a:bodyPr wrap="square" lIns="0" tIns="0" rIns="0" bIns="0" rtlCol="0" anchor="ctr"/>
+          <a:lstStyle/>
+          <a:p>
+            <a:pPr indent="0" marL="0">
+              <a:buNone/>
+            </a:pPr>
+            <a:r>
+              <a:rPr lang="en-US" sz="950" dirty="0">
+                <a:solidFill>
+                  <a:srgbClr val="B8DADD"/>
+                </a:solidFill>
+                <a:latin typeface="Consolas" pitchFamily="34" charset="0"/>
+                <a:ea typeface="Consolas" pitchFamily="34" charset="-122"/>
+                <a:cs typeface="Consolas" pitchFamily="34" charset="-120"/>
+              </a:rPr>
+              <a:t>infra-security</a:t>
+            </a:r>
+            <a:endParaRPr lang="en-US" sz="950" dirty="0"/>
+          </a:p>
+        </p:txBody>
+      </p:sp>
+      <p:sp>
+        <p:nvSpPr>
+          <p:cNvPr id="33" name="Shape 30"/>
+          <p:cNvSpPr/>
+          <p:nvPr/>
+        </p:nvSpPr>
+        <p:spPr>
+          <a:xfrm>
+            <a:off x="5687568" y="3145536"/>
+            <a:ext cx="2834640" cy="256032"/>
+          </a:xfrm>
+          <a:prstGeom prst="rect">
+            <a:avLst/>
+          </a:prstGeom>
+          <a:solidFill>
+            <a:srgbClr val="022C33"/>
+          </a:solidFill>
+          <a:ln w="12700">
+            <a:solidFill>
+              <a:srgbClr val="028090"/>
+            </a:solidFill>
+            <a:prstDash val="solid"/>
+          </a:ln>
+        </p:spPr>
+      </p:sp>
+      <p:sp>
+        <p:nvSpPr>
+          <p:cNvPr id="34" name="Shape 31"/>
+          <p:cNvSpPr/>
+          <p:nvPr/>
+        </p:nvSpPr>
+        <p:spPr>
+          <a:xfrm>
+            <a:off x="5687568" y="3145536"/>
+            <a:ext cx="2460468" cy="256032"/>
+          </a:xfrm>
+          <a:prstGeom prst="rect">
+            <a:avLst/>
+          </a:prstGeom>
+          <a:solidFill>
+            <a:srgbClr val="5A8087"/>
+          </a:solidFill>
+          <a:ln w="12700">
+            <a:solidFill>
+              <a:srgbClr val="5A8087"/>
+            </a:solidFill>
+            <a:prstDash val="solid"/>
+          </a:ln>
+        </p:spPr>
+      </p:sp>
+      <p:sp>
+        <p:nvSpPr>
+          <p:cNvPr id="35" name="Text 32"/>
+          <p:cNvSpPr/>
+          <p:nvPr/>
+        </p:nvSpPr>
+        <p:spPr>
+          <a:xfrm>
+            <a:off x="8595360" y="3145536"/>
+            <a:ext cx="502920" cy="256032"/>
+          </a:xfrm>
+          <a:prstGeom prst="rect">
+            <a:avLst/>
+          </a:prstGeom>
+          <a:noFill/>
+          <a:ln/>
+        </p:spPr>
+        <p:txBody>
+          <a:bodyPr wrap="square" lIns="0" tIns="0" rIns="0" bIns="0" rtlCol="0" anchor="ctr"/>
+          <a:lstStyle/>
+          <a:p>
+            <a:pPr indent="0" marL="0">
+              <a:buNone/>
+            </a:pPr>
+            <a:r>
+              <a:rPr lang="en-US" sz="900" dirty="0">
+                <a:solidFill>
+                  <a:srgbClr val="5A8087"/>
+                </a:solidFill>
+                <a:latin typeface="Calibri" pitchFamily="34" charset="0"/>
+                <a:ea typeface="Calibri" pitchFamily="34" charset="-122"/>
+                <a:cs typeface="Calibri" pitchFamily="34" charset="-120"/>
+              </a:rPr>
+              <a:t>0.967 —</a:t>
+            </a:r>
+            <a:endParaRPr lang="en-US" sz="900" dirty="0"/>
+          </a:p>
+        </p:txBody>
+      </p:sp>
+      <p:sp>
+        <p:nvSpPr>
+          <p:cNvPr id="36" name="Text 33"/>
+          <p:cNvSpPr/>
+          <p:nvPr/>
+        </p:nvSpPr>
+        <p:spPr>
+          <a:xfrm>
+            <a:off x="5687568" y="3547872"/>
+            <a:ext cx="3108960" cy="228600"/>
+          </a:xfrm>
+          <a:prstGeom prst="rect">
+            <a:avLst/>
+          </a:prstGeom>
+          <a:noFill/>
+          <a:ln/>
+        </p:spPr>
+        <p:txBody>
+          <a:bodyPr wrap="square" lIns="0" tIns="0" rIns="0" bIns="0" rtlCol="0" anchor="ctr"/>
+          <a:lstStyle/>
+          <a:p>
+            <a:pPr indent="0" marL="0">
+              <a:buNone/>
+            </a:pPr>
+            <a:r>
+              <a:rPr lang="en-US" sz="950" dirty="0">
+                <a:solidFill>
+                  <a:srgbClr val="B8DADD"/>
+                </a:solidFill>
+                <a:latin typeface="Consolas" pitchFamily="34" charset="0"/>
+                <a:ea typeface="Consolas" pitchFamily="34" charset="-122"/>
+                <a:cs typeface="Consolas" pitchFamily="34" charset="-120"/>
+              </a:rPr>
+              <a:t>observability-eval</a:t>
+            </a:r>
+            <a:endParaRPr lang="en-US" sz="950" dirty="0"/>
+          </a:p>
+        </p:txBody>
+      </p:sp>
+      <p:sp>
+        <p:nvSpPr>
+          <p:cNvPr id="37" name="Shape 34"/>
+          <p:cNvSpPr/>
+          <p:nvPr/>
+        </p:nvSpPr>
+        <p:spPr>
+          <a:xfrm>
+            <a:off x="5687568" y="3803904"/>
+            <a:ext cx="2834640" cy="256032"/>
+          </a:xfrm>
+          <a:prstGeom prst="rect">
+            <a:avLst/>
+          </a:prstGeom>
+          <a:solidFill>
+            <a:srgbClr val="022C33"/>
+          </a:solidFill>
+          <a:ln w="12700">
+            <a:solidFill>
+              <a:srgbClr val="028090"/>
+            </a:solidFill>
+            <a:prstDash val="solid"/>
+          </a:ln>
+        </p:spPr>
+      </p:sp>
+      <p:sp>
+        <p:nvSpPr>
+          <p:cNvPr id="38" name="Shape 35"/>
+          <p:cNvSpPr/>
+          <p:nvPr/>
+        </p:nvSpPr>
+        <p:spPr>
+          <a:xfrm>
+            <a:off x="5687568" y="3803904"/>
+            <a:ext cx="2834640" cy="256032"/>
           </a:xfrm>
           <a:prstGeom prst="rect">
             <a:avLst/>
@@ -13830,13 +13867,13 @@
       </p:sp>
       <p:sp>
         <p:nvSpPr>
-          <p:cNvPr id="27" name="Text 24"/>
-          <p:cNvSpPr/>
-          <p:nvPr/>
-        </p:nvSpPr>
-        <p:spPr>
-          <a:xfrm>
-            <a:off x="8595360" y="1828800"/>
+          <p:cNvPr id="39" name="Text 36"/>
+          <p:cNvSpPr/>
+          <p:nvPr/>
+        </p:nvSpPr>
+        <p:spPr>
+          <a:xfrm>
+            <a:off x="8595360" y="3803904"/>
             <a:ext cx="502920" cy="256032"/>
           </a:xfrm>
           <a:prstGeom prst="rect">
@@ -13861,391 +13898,7 @@
                 <a:ea typeface="Calibri" pitchFamily="34" charset="-122"/>
                 <a:cs typeface="Calibri" pitchFamily="34" charset="-120"/>
               </a:rPr>
-              <a:t>0.971 ▲</a:t>
-            </a:r>
-            <a:endParaRPr lang="en-US" sz="900" dirty="0"/>
-          </a:p>
-        </p:txBody>
-      </p:sp>
-      <p:sp>
-        <p:nvSpPr>
-          <p:cNvPr id="28" name="Text 25"/>
-          <p:cNvSpPr/>
-          <p:nvPr/>
-        </p:nvSpPr>
-        <p:spPr>
-          <a:xfrm>
-            <a:off x="5687568" y="2231136"/>
-            <a:ext cx="3108960" cy="228600"/>
-          </a:xfrm>
-          <a:prstGeom prst="rect">
-            <a:avLst/>
-          </a:prstGeom>
-          <a:noFill/>
-          <a:ln/>
-        </p:spPr>
-        <p:txBody>
-          <a:bodyPr wrap="square" lIns="0" tIns="0" rIns="0" bIns="0" rtlCol="0" anchor="ctr"/>
-          <a:lstStyle/>
-          <a:p>
-            <a:pPr indent="0" marL="0">
-              <a:buNone/>
-            </a:pPr>
-            <a:r>
-              <a:rPr lang="en-US" sz="950" dirty="0">
-                <a:solidFill>
-                  <a:srgbClr val="B8DADD"/>
-                </a:solidFill>
-                <a:latin typeface="Consolas" pitchFamily="34" charset="0"/>
-                <a:ea typeface="Consolas" pitchFamily="34" charset="-122"/>
-                <a:cs typeface="Consolas" pitchFamily="34" charset="-120"/>
-              </a:rPr>
-              <a:t>getting-started</a:t>
-            </a:r>
-            <a:endParaRPr lang="en-US" sz="950" dirty="0"/>
-          </a:p>
-        </p:txBody>
-      </p:sp>
-      <p:sp>
-        <p:nvSpPr>
-          <p:cNvPr id="29" name="Shape 26"/>
-          <p:cNvSpPr/>
-          <p:nvPr/>
-        </p:nvSpPr>
-        <p:spPr>
-          <a:xfrm>
-            <a:off x="5687568" y="2487168"/>
-            <a:ext cx="2834640" cy="256032"/>
-          </a:xfrm>
-          <a:prstGeom prst="rect">
-            <a:avLst/>
-          </a:prstGeom>
-          <a:solidFill>
-            <a:srgbClr val="022C33"/>
-          </a:solidFill>
-          <a:ln w="12700">
-            <a:solidFill>
-              <a:srgbClr val="028090"/>
-            </a:solidFill>
-            <a:prstDash val="solid"/>
-          </a:ln>
-        </p:spPr>
-      </p:sp>
-      <p:sp>
-        <p:nvSpPr>
-          <p:cNvPr id="30" name="Shape 27"/>
-          <p:cNvSpPr/>
-          <p:nvPr/>
-        </p:nvSpPr>
-        <p:spPr>
-          <a:xfrm>
-            <a:off x="5687568" y="2487168"/>
-            <a:ext cx="1553383" cy="256032"/>
-          </a:xfrm>
-          <a:prstGeom prst="rect">
-            <a:avLst/>
-          </a:prstGeom>
-          <a:solidFill>
-            <a:srgbClr val="00A896"/>
-          </a:solidFill>
-          <a:ln w="12700">
-            <a:solidFill>
-              <a:srgbClr val="00A896"/>
-            </a:solidFill>
-            <a:prstDash val="solid"/>
-          </a:ln>
-        </p:spPr>
-      </p:sp>
-      <p:sp>
-        <p:nvSpPr>
-          <p:cNvPr id="31" name="Text 28"/>
-          <p:cNvSpPr/>
-          <p:nvPr/>
-        </p:nvSpPr>
-        <p:spPr>
-          <a:xfrm>
-            <a:off x="8595360" y="2487168"/>
-            <a:ext cx="502920" cy="256032"/>
-          </a:xfrm>
-          <a:prstGeom prst="rect">
-            <a:avLst/>
-          </a:prstGeom>
-          <a:noFill/>
-          <a:ln/>
-        </p:spPr>
-        <p:txBody>
-          <a:bodyPr wrap="square" lIns="0" tIns="0" rIns="0" bIns="0" rtlCol="0" anchor="ctr"/>
-          <a:lstStyle/>
-          <a:p>
-            <a:pPr indent="0" marL="0">
-              <a:buNone/>
-            </a:pPr>
-            <a:r>
-              <a:rPr lang="en-US" sz="900" b="1" dirty="0">
-                <a:solidFill>
-                  <a:srgbClr val="02C39A"/>
-                </a:solidFill>
-                <a:latin typeface="Calibri" pitchFamily="34" charset="0"/>
-                <a:ea typeface="Calibri" pitchFamily="34" charset="-122"/>
-                <a:cs typeface="Calibri" pitchFamily="34" charset="-120"/>
-              </a:rPr>
-              <a:t>0.887 ▲</a:t>
-            </a:r>
-            <a:endParaRPr lang="en-US" sz="900" dirty="0"/>
-          </a:p>
-        </p:txBody>
-      </p:sp>
-      <p:sp>
-        <p:nvSpPr>
-          <p:cNvPr id="32" name="Text 29"/>
-          <p:cNvSpPr/>
-          <p:nvPr/>
-        </p:nvSpPr>
-        <p:spPr>
-          <a:xfrm>
-            <a:off x="5687568" y="2889504"/>
-            <a:ext cx="3108960" cy="228600"/>
-          </a:xfrm>
-          <a:prstGeom prst="rect">
-            <a:avLst/>
-          </a:prstGeom>
-          <a:noFill/>
-          <a:ln/>
-        </p:spPr>
-        <p:txBody>
-          <a:bodyPr wrap="square" lIns="0" tIns="0" rIns="0" bIns="0" rtlCol="0" anchor="ctr"/>
-          <a:lstStyle/>
-          <a:p>
-            <a:pPr indent="0" marL="0">
-              <a:buNone/>
-            </a:pPr>
-            <a:r>
-              <a:rPr lang="en-US" sz="950" dirty="0">
-                <a:solidFill>
-                  <a:srgbClr val="B8DADD"/>
-                </a:solidFill>
-                <a:latin typeface="Consolas" pitchFamily="34" charset="0"/>
-                <a:ea typeface="Consolas" pitchFamily="34" charset="-122"/>
-                <a:cs typeface="Consolas" pitchFamily="34" charset="-120"/>
-              </a:rPr>
-              <a:t>infra-security</a:t>
-            </a:r>
-            <a:endParaRPr lang="en-US" sz="950" dirty="0"/>
-          </a:p>
-        </p:txBody>
-      </p:sp>
-      <p:sp>
-        <p:nvSpPr>
-          <p:cNvPr id="33" name="Shape 30"/>
-          <p:cNvSpPr/>
-          <p:nvPr/>
-        </p:nvSpPr>
-        <p:spPr>
-          <a:xfrm>
-            <a:off x="5687568" y="3145536"/>
-            <a:ext cx="2834640" cy="256032"/>
-          </a:xfrm>
-          <a:prstGeom prst="rect">
-            <a:avLst/>
-          </a:prstGeom>
-          <a:solidFill>
-            <a:srgbClr val="022C33"/>
-          </a:solidFill>
-          <a:ln w="12700">
-            <a:solidFill>
-              <a:srgbClr val="028090"/>
-            </a:solidFill>
-            <a:prstDash val="solid"/>
-          </a:ln>
-        </p:spPr>
-      </p:sp>
-      <p:sp>
-        <p:nvSpPr>
-          <p:cNvPr id="34" name="Shape 31"/>
-          <p:cNvSpPr/>
-          <p:nvPr/>
-        </p:nvSpPr>
-        <p:spPr>
-          <a:xfrm>
-            <a:off x="5687568" y="3145536"/>
-            <a:ext cx="2006925" cy="256032"/>
-          </a:xfrm>
-          <a:prstGeom prst="rect">
-            <a:avLst/>
-          </a:prstGeom>
-          <a:solidFill>
-            <a:srgbClr val="00A896"/>
-          </a:solidFill>
-          <a:ln w="12700">
-            <a:solidFill>
-              <a:srgbClr val="00A896"/>
-            </a:solidFill>
-            <a:prstDash val="solid"/>
-          </a:ln>
-        </p:spPr>
-      </p:sp>
-      <p:sp>
-        <p:nvSpPr>
-          <p:cNvPr id="35" name="Text 32"/>
-          <p:cNvSpPr/>
-          <p:nvPr/>
-        </p:nvSpPr>
-        <p:spPr>
-          <a:xfrm>
-            <a:off x="8595360" y="3145536"/>
-            <a:ext cx="502920" cy="256032"/>
-          </a:xfrm>
-          <a:prstGeom prst="rect">
-            <a:avLst/>
-          </a:prstGeom>
-          <a:noFill/>
-          <a:ln/>
-        </p:spPr>
-        <p:txBody>
-          <a:bodyPr wrap="square" lIns="0" tIns="0" rIns="0" bIns="0" rtlCol="0" anchor="ctr"/>
-          <a:lstStyle/>
-          <a:p>
-            <a:pPr indent="0" marL="0">
-              <a:buNone/>
-            </a:pPr>
-            <a:r>
-              <a:rPr lang="en-US" sz="900" b="1" dirty="0">
-                <a:solidFill>
-                  <a:srgbClr val="02C39A"/>
-                </a:solidFill>
-                <a:latin typeface="Calibri" pitchFamily="34" charset="0"/>
-                <a:ea typeface="Calibri" pitchFamily="34" charset="-122"/>
-                <a:cs typeface="Calibri" pitchFamily="34" charset="-120"/>
-              </a:rPr>
-              <a:t>0.927 ▲</a:t>
-            </a:r>
-            <a:endParaRPr lang="en-US" sz="900" dirty="0"/>
-          </a:p>
-        </p:txBody>
-      </p:sp>
-      <p:sp>
-        <p:nvSpPr>
-          <p:cNvPr id="36" name="Text 33"/>
-          <p:cNvSpPr/>
-          <p:nvPr/>
-        </p:nvSpPr>
-        <p:spPr>
-          <a:xfrm>
-            <a:off x="5687568" y="3547872"/>
-            <a:ext cx="3108960" cy="228600"/>
-          </a:xfrm>
-          <a:prstGeom prst="rect">
-            <a:avLst/>
-          </a:prstGeom>
-          <a:noFill/>
-          <a:ln/>
-        </p:spPr>
-        <p:txBody>
-          <a:bodyPr wrap="square" lIns="0" tIns="0" rIns="0" bIns="0" rtlCol="0" anchor="ctr"/>
-          <a:lstStyle/>
-          <a:p>
-            <a:pPr indent="0" marL="0">
-              <a:buNone/>
-            </a:pPr>
-            <a:r>
-              <a:rPr lang="en-US" sz="950" dirty="0">
-                <a:solidFill>
-                  <a:srgbClr val="B8DADD"/>
-                </a:solidFill>
-                <a:latin typeface="Consolas" pitchFamily="34" charset="0"/>
-                <a:ea typeface="Consolas" pitchFamily="34" charset="-122"/>
-                <a:cs typeface="Consolas" pitchFamily="34" charset="-120"/>
-              </a:rPr>
-              <a:t>observability</a:t>
-            </a:r>
-            <a:endParaRPr lang="en-US" sz="950" dirty="0"/>
-          </a:p>
-        </p:txBody>
-      </p:sp>
-      <p:sp>
-        <p:nvSpPr>
-          <p:cNvPr id="37" name="Shape 34"/>
-          <p:cNvSpPr/>
-          <p:nvPr/>
-        </p:nvSpPr>
-        <p:spPr>
-          <a:xfrm>
-            <a:off x="5687568" y="3803904"/>
-            <a:ext cx="2834640" cy="256032"/>
-          </a:xfrm>
-          <a:prstGeom prst="rect">
-            <a:avLst/>
-          </a:prstGeom>
-          <a:solidFill>
-            <a:srgbClr val="022C33"/>
-          </a:solidFill>
-          <a:ln w="12700">
-            <a:solidFill>
-              <a:srgbClr val="028090"/>
-            </a:solidFill>
-            <a:prstDash val="solid"/>
-          </a:ln>
-        </p:spPr>
-      </p:sp>
-      <p:sp>
-        <p:nvSpPr>
-          <p:cNvPr id="38" name="Shape 35"/>
-          <p:cNvSpPr/>
-          <p:nvPr/>
-        </p:nvSpPr>
-        <p:spPr>
-          <a:xfrm>
-            <a:off x="5687568" y="3803904"/>
-            <a:ext cx="589605" cy="256032"/>
-          </a:xfrm>
-          <a:prstGeom prst="rect">
-            <a:avLst/>
-          </a:prstGeom>
-          <a:solidFill>
-            <a:srgbClr val="5A8087"/>
-          </a:solidFill>
-          <a:ln w="12700">
-            <a:solidFill>
-              <a:srgbClr val="5A8087"/>
-            </a:solidFill>
-            <a:prstDash val="solid"/>
-          </a:ln>
-        </p:spPr>
-      </p:sp>
-      <p:sp>
-        <p:nvSpPr>
-          <p:cNvPr id="39" name="Text 36"/>
-          <p:cNvSpPr/>
-          <p:nvPr/>
-        </p:nvSpPr>
-        <p:spPr>
-          <a:xfrm>
-            <a:off x="8595360" y="3803904"/>
-            <a:ext cx="502920" cy="256032"/>
-          </a:xfrm>
-          <a:prstGeom prst="rect">
-            <a:avLst/>
-          </a:prstGeom>
-          <a:noFill/>
-          <a:ln/>
-        </p:spPr>
-        <p:txBody>
-          <a:bodyPr wrap="square" lIns="0" tIns="0" rIns="0" bIns="0" rtlCol="0" anchor="ctr"/>
-          <a:lstStyle/>
-          <a:p>
-            <a:pPr indent="0" marL="0">
-              <a:buNone/>
-            </a:pPr>
-            <a:r>
-              <a:rPr lang="en-US" sz="900" dirty="0">
-                <a:solidFill>
-                  <a:srgbClr val="5A8087"/>
-                </a:solidFill>
-                <a:latin typeface="Calibri" pitchFamily="34" charset="0"/>
-                <a:ea typeface="Calibri" pitchFamily="34" charset="-122"/>
-                <a:cs typeface="Calibri" pitchFamily="34" charset="-120"/>
-              </a:rPr>
-              <a:t>0.802 —</a:t>
+              <a:t>1 ▲</a:t>
             </a:r>
             <a:endParaRPr lang="en-US" sz="900" dirty="0"/>
           </a:p>
@@ -14441,7 +14094,7 @@
                 <a:ea typeface="Calibri" pitchFamily="34" charset="-122"/>
                 <a:cs typeface="Calibri" pitchFamily="34" charset="-120"/>
               </a:rPr>
-              <a:t>docs-vnext leads in agent-development (0.971) and getting-started (0.887) — areas benefiting most from Mintlify MDX enhancements</a:t>
+              <a:t>docs-vnext leads in observability-eval (1.000 vs 0.856) — perfect score from Mintlify MDX enhancements</a:t>
             </a:r>
             <a:endParaRPr lang="en-US" sz="1050" dirty="0"/>
           </a:p>

</xml_diff>

<commit_message>
slides: update deck with current metrics (526 docs, 23 workflows, eval #640)
- DATA: mdxDocs 274→526, agenticWorkflows 26→23, workflowChains 4→3
- Sections: updated counts for all 18 docs-vnext sections (new: Foundry Models 112, Agent Service 95)
- Architecture slide: reflects 526 MDX pages
- Eval slide: updated with Issue #640 data (2026-07-28, claude-sonnet-4.6 only)
  - Scoreboard: MS Learn 0.873 > docs-vnext 0.863 > docs/ 0.855 > Mintlify 0.843
  - H1 MARGINAL (+0.008), H2 MARGINAL (+0.020), H3 REJECTED (−0.010), H4 SUPPORTED
  - Category: getting-started (0.857▲) and infra-security (0.947▲) lead; observability weak spot (0.767)

Co-authored-by: Copilot <223556219+Copilot@users.noreply.github.com>
</commit_message>
<xml_diff>
--- a/slides/foundry-docs-overview.pptx
+++ b/slides/foundry-docs-overview.pptx
@@ -178,12 +178,12 @@
           </c:dLbls>
           <c:cat>
             <c:multiLvlStrRef>
-              <c:f>Sheet1!$A$2:$A$17</c:f>
+              <c:f>Sheet1!$A$2:$A$19</c:f>
               <c:multiLvlStrCache>
-                <c:ptCount val="16"/>
+                <c:ptCount val="18"/>
                 <c:lvl>
                   <c:pt idx="0">
-                    <c:v>Glossary</c:v>
+                    <c:v>What is Foundry</c:v>
                   </c:pt>
                   <c:pt idx="1">
                     <c:v>Reference</c:v>
@@ -207,28 +207,34 @@
                     <c:v>Manage</c:v>
                   </c:pt>
                   <c:pt idx="8">
-                    <c:v>Dev Experience</c:v>
+                    <c:v>API &amp; SDK</c:v>
                   </c:pt>
                   <c:pt idx="9">
                     <c:v>Guardrails</c:v>
                   </c:pt>
                   <c:pt idx="10">
-                    <c:v>API &amp; SDK</c:v>
+                    <c:v>Developer Exp.</c:v>
                   </c:pt>
                   <c:pt idx="11">
-                    <c:v>Security</c:v>
+                    <c:v>Setup</c:v>
                   </c:pt>
                   <c:pt idx="12">
-                    <c:v>Setup</c:v>
+                    <c:v>Security</c:v>
                   </c:pt>
                   <c:pt idx="13">
                     <c:v>Observability</c:v>
                   </c:pt>
                   <c:pt idx="14">
+                    <c:v>Models</c:v>
+                  </c:pt>
+                  <c:pt idx="15">
                     <c:v>Agents</c:v>
                   </c:pt>
-                  <c:pt idx="15">
-                    <c:v>Models</c:v>
+                  <c:pt idx="16">
+                    <c:v>Agent Service</c:v>
+                  </c:pt>
+                  <c:pt idx="17">
+                    <c:v>Foundry Models</c:v>
                   </c:pt>
                 </c:lvl>
               </c:multiLvlStrCache>
@@ -236,10 +242,10 @@
           </c:cat>
           <c:val>
             <c:numRef>
-              <c:f>Sheet1!$B$2:$B$17</c:f>
+              <c:f>Sheet1!$B$2:$B$19</c:f>
               <c:numCache>
                 <c:formatCode>General</c:formatCode>
-                <c:ptCount val="16"/>
+                <c:ptCount val="18"/>
                 <c:pt idx="0">
                   <c:v>1</c:v>
                 </c:pt>
@@ -250,43 +256,49 @@
                   <c:v>3</c:v>
                 </c:pt>
                 <c:pt idx="3">
-                  <c:v>4</c:v>
+                  <c:v>7</c:v>
                 </c:pt>
                 <c:pt idx="4">
-                  <c:v>5</c:v>
+                  <c:v>7</c:v>
                 </c:pt>
                 <c:pt idx="5">
-                  <c:v>7</c:v>
+                  <c:v>8</c:v>
                 </c:pt>
                 <c:pt idx="6">
-                  <c:v>8</c:v>
+                  <c:v>10</c:v>
                 </c:pt>
                 <c:pt idx="7">
-                  <c:v>9</c:v>
+                  <c:v>10</c:v>
                 </c:pt>
                 <c:pt idx="8">
-                  <c:v>11</c:v>
+                  <c:v>17</c:v>
                 </c:pt>
                 <c:pt idx="9">
-                  <c:v>15</c:v>
+                  <c:v>19</c:v>
                 </c:pt>
                 <c:pt idx="10">
-                  <c:v>17</c:v>
+                  <c:v>21</c:v>
                 </c:pt>
                 <c:pt idx="11">
-                  <c:v>20</c:v>
+                  <c:v>22</c:v>
                 </c:pt>
                 <c:pt idx="12">
-                  <c:v>20</c:v>
+                  <c:v>24</c:v>
                 </c:pt>
                 <c:pt idx="13">
-                  <c:v>24</c:v>
+                  <c:v>31</c:v>
                 </c:pt>
                 <c:pt idx="14">
-                  <c:v>57</c:v>
+                  <c:v>75</c:v>
                 </c:pt>
                 <c:pt idx="15">
-                  <c:v>72</c:v>
+                  <c:v>63</c:v>
+                </c:pt>
+                <c:pt idx="16">
+                  <c:v>95</c:v>
+                </c:pt>
+                <c:pt idx="17">
+                  <c:v>112</c:v>
                 </c:pt>
               </c:numCache>
             </c:numRef>
@@ -2399,7 +2411,7 @@
                 <a:ea typeface="Calibri" pitchFamily="34" charset="-122"/>
                 <a:cs typeface="Calibri" pitchFamily="34" charset="-120"/>
               </a:rPr>
-              <a:t>274 docs  ·  26 agentic workflows  ·  4 SDK repos monitored  ·  FastMCP server</a:t>
+              <a:t>526 docs  ·  23 agentic workflows  ·  4 SDK repos monitored  ·  FastMCP server</a:t>
             </a:r>
             <a:endParaRPr lang="en-US" sz="1300" dirty="0"/>
           </a:p>
@@ -3773,7 +3785,7 @@
                 <a:ea typeface="Trebuchet MS" pitchFamily="34" charset="-122"/>
                 <a:cs typeface="Trebuchet MS" pitchFamily="34" charset="-120"/>
               </a:rPr>
-              <a:t>274</a:t>
+              <a:t>526</a:t>
             </a:r>
             <a:endParaRPr lang="en-US" sz="5200" dirty="0"/>
           </a:p>
@@ -3946,7 +3958,7 @@
                 <a:ea typeface="Trebuchet MS" pitchFamily="34" charset="-122"/>
                 <a:cs typeface="Trebuchet MS" pitchFamily="34" charset="-120"/>
               </a:rPr>
-              <a:t>26</a:t>
+              <a:t>23</a:t>
             </a:r>
             <a:endParaRPr lang="en-US" sz="5200" dirty="0"/>
           </a:p>
@@ -4119,7 +4131,7 @@
                 <a:ea typeface="Trebuchet MS" pitchFamily="34" charset="-122"/>
                 <a:cs typeface="Trebuchet MS" pitchFamily="34" charset="-120"/>
               </a:rPr>
-              <a:t>16</a:t>
+              <a:t>18</a:t>
             </a:r>
             <a:endParaRPr lang="en-US" sz="5200" dirty="0"/>
           </a:p>
@@ -6295,7 +6307,7 @@
                 <a:ea typeface="Trebuchet MS" pitchFamily="34" charset="-122"/>
                 <a:cs typeface="Trebuchet MS" pitchFamily="34" charset="-120"/>
               </a:rPr>
-              <a:t>274</a:t>
+              <a:t>526</a:t>
             </a:r>
             <a:endParaRPr lang="en-US" sz="2600" dirty="0"/>
           </a:p>
@@ -6398,7 +6410,7 @@
                 <a:ea typeface="Trebuchet MS" pitchFamily="34" charset="-122"/>
                 <a:cs typeface="Trebuchet MS" pitchFamily="34" charset="-120"/>
               </a:rPr>
-              <a:t>16</a:t>
+              <a:t>18</a:t>
             </a:r>
             <a:endParaRPr lang="en-US" sz="2600" dirty="0"/>
           </a:p>
@@ -6763,7 +6775,7 @@
                 <a:ea typeface="Calibri" pitchFamily="34" charset="-122"/>
                 <a:cs typeface="Calibri" pitchFamily="34" charset="-120"/>
               </a:rPr>
-              <a:t>azure-ai-docs-pr</a:t>
+              <a:t>azure-ai-docs</a:t>
             </a:r>
             <a:endParaRPr lang="en-US" sz="1000" dirty="0"/>
           </a:p>
@@ -7096,7 +7108,7 @@
                 <a:ea typeface="Calibri" pitchFamily="34" charset="-122"/>
                 <a:cs typeface="Calibri" pitchFamily="34" charset="-120"/>
               </a:rPr>
-              <a:t>274 MDX pages</a:t>
+              <a:t>526 MDX pages</a:t>
             </a:r>
             <a:endParaRPr lang="en-US" sz="1000" dirty="0"/>
           </a:p>
@@ -7794,7 +7806,7 @@
                 <a:ea typeface="Trebuchet MS" pitchFamily="34" charset="-122"/>
                 <a:cs typeface="Trebuchet MS" pitchFamily="34" charset="-120"/>
               </a:rPr>
-              <a:t>Documentation Coverage — 274 Pages Across 16 Sections</a:t>
+              <a:t>Documentation Coverage — 526 Pages Across 18 Sections</a:t>
             </a:r>
             <a:endParaRPr lang="en-US" sz="3000" dirty="0"/>
           </a:p>
@@ -7906,7 +7918,7 @@
                 <a:ea typeface="Trebuchet MS" pitchFamily="34" charset="-122"/>
                 <a:cs typeface="Trebuchet MS" pitchFamily="34" charset="-120"/>
               </a:rPr>
-              <a:t>26 Agentic Workflows</a:t>
+              <a:t>23 Agentic Workflows</a:t>
             </a:r>
             <a:endParaRPr lang="en-US" sz="4000" dirty="0"/>
           </a:p>
@@ -9884,7 +9896,7 @@
                 <a:ea typeface="Trebuchet MS" pitchFamily="34" charset="-122"/>
                 <a:cs typeface="Trebuchet MS" pitchFamily="34" charset="-120"/>
               </a:rPr>
-              <a:t>4</a:t>
+              <a:t>3</a:t>
             </a:r>
             <a:endParaRPr lang="en-US" sz="5200" dirty="0"/>
           </a:p>
@@ -11344,7 +11356,7 @@
                 <a:ea typeface="Calibri" pitchFamily="34" charset="-122"/>
                 <a:cs typeface="Calibri" pitchFamily="34" charset="-120"/>
               </a:rPr>
-              <a:t>300 evaluations · 4 servers · 3 frontier models · 2026-03-05</a:t>
+              <a:t>100 evaluations · 4 servers · 1 frontier model · 2026-07-28</a:t>
             </a:r>
             <a:endParaRPr lang="en-US" sz="1150" dirty="0"/>
           </a:p>
@@ -11366,20 +11378,18 @@
         </p:nvGraphicFramePr>
         <p:xfrm>
           <a:off x="320040" y="1188720"/>
-          <a:ext cx="5166360" cy="1737360"/>
+          <a:ext cx="5166360" cy="1920240"/>
         </p:xfrm>
         <a:graphic>
           <a:graphicData uri="http://schemas.openxmlformats.org/drawingml/2006/table">
             <a:tbl>
               <a:tblPr/>
               <a:tblGrid>
-                <a:gridCol w="1645920"/>
-                <a:gridCol w="886968"/>
-                <a:gridCol w="886968"/>
-                <a:gridCol w="886968"/>
-                <a:gridCol w="859536"/>
+                <a:gridCol w="3017520"/>
+                <a:gridCol w="1097280"/>
+                <a:gridCol w="1051560"/>
               </a:tblGrid>
-              <a:tr h="347472">
+              <a:tr h="384048">
                 <a:tc>
                   <a:txBody>
                     <a:bodyPr/>
@@ -11465,143 +11475,7 @@
                           <a:ea typeface="Calibri" pitchFamily="34" charset="-122"/>
                           <a:cs typeface="Calibri" pitchFamily="34" charset="-120"/>
                         </a:rPr>
-                        <a:t>claude-opus-4.6</a:t>
-                      </a:r>
-                      <a:endParaRPr lang="en-US" sz="1100" dirty="0">
-                        <a:latin typeface="Calibri" charset="0"/>
-                        <a:ea typeface="Calibri" charset="0"/>
-                        <a:cs typeface="Calibri" charset="0"/>
-                      </a:endParaRPr>
-                    </a:p>
-                  </a:txBody>
-                  <a:tcPr marL="91440" marR="91440" marT="45720" marB="45720">
-                    <a:lnL w="6350" cap="flat" cmpd="sng" algn="ctr">
-                      <a:solidFill>
-                        <a:srgbClr val="028090"/>
-                      </a:solidFill>
-                      <a:prstDash val="solid"/>
-                      <a:round/>
-                      <a:headEnd type="none" w="med" len="med"/>
-                      <a:tailEnd type="none" w="med" len="med"/>
-                    </a:lnL>
-                    <a:lnR w="6350" cap="flat" cmpd="sng" algn="ctr">
-                      <a:solidFill>
-                        <a:srgbClr val="028090"/>
-                      </a:solidFill>
-                      <a:prstDash val="solid"/>
-                      <a:round/>
-                      <a:headEnd type="none" w="med" len="med"/>
-                      <a:tailEnd type="none" w="med" len="med"/>
-                    </a:lnR>
-                    <a:lnT w="6350" cap="flat" cmpd="sng" algn="ctr">
-                      <a:solidFill>
-                        <a:srgbClr val="028090"/>
-                      </a:solidFill>
-                      <a:prstDash val="solid"/>
-                      <a:round/>
-                      <a:headEnd type="none" w="med" len="med"/>
-                      <a:tailEnd type="none" w="med" len="med"/>
-                    </a:lnT>
-                    <a:lnB w="6350" cap="flat" cmpd="sng" algn="ctr">
-                      <a:solidFill>
-                        <a:srgbClr val="028090"/>
-                      </a:solidFill>
-                      <a:prstDash val="solid"/>
-                      <a:round/>
-                      <a:headEnd type="none" w="med" len="med"/>
-                      <a:tailEnd type="none" w="med" len="med"/>
-                    </a:lnB>
-                    <a:solidFill>
-                      <a:srgbClr val="028090"/>
-                    </a:solidFill>
-                  </a:tcPr>
-                </a:tc>
-                <a:tc>
-                  <a:txBody>
-                    <a:bodyPr/>
-                    <a:lstStyle/>
-                    <a:p>
-                      <a:pPr algn="ctr" indent="0" marL="0">
-                        <a:buNone/>
-                      </a:pPr>
-                      <a:r>
-                        <a:rPr lang="en-US" sz="1100" b="1" dirty="0">
-                          <a:solidFill>
-                            <a:srgbClr val="FFFFFF"/>
-                          </a:solidFill>
-                          <a:latin typeface="Calibri" pitchFamily="34" charset="0"/>
-                          <a:ea typeface="Calibri" pitchFamily="34" charset="-122"/>
-                          <a:cs typeface="Calibri" pitchFamily="34" charset="-120"/>
-                        </a:rPr>
-                        <a:t>gemini-3-pro</a:t>
-                      </a:r>
-                      <a:endParaRPr lang="en-US" sz="1100" dirty="0">
-                        <a:latin typeface="Calibri" charset="0"/>
-                        <a:ea typeface="Calibri" charset="0"/>
-                        <a:cs typeface="Calibri" charset="0"/>
-                      </a:endParaRPr>
-                    </a:p>
-                  </a:txBody>
-                  <a:tcPr marL="91440" marR="91440" marT="45720" marB="45720">
-                    <a:lnL w="6350" cap="flat" cmpd="sng" algn="ctr">
-                      <a:solidFill>
-                        <a:srgbClr val="028090"/>
-                      </a:solidFill>
-                      <a:prstDash val="solid"/>
-                      <a:round/>
-                      <a:headEnd type="none" w="med" len="med"/>
-                      <a:tailEnd type="none" w="med" len="med"/>
-                    </a:lnL>
-                    <a:lnR w="6350" cap="flat" cmpd="sng" algn="ctr">
-                      <a:solidFill>
-                        <a:srgbClr val="028090"/>
-                      </a:solidFill>
-                      <a:prstDash val="solid"/>
-                      <a:round/>
-                      <a:headEnd type="none" w="med" len="med"/>
-                      <a:tailEnd type="none" w="med" len="med"/>
-                    </a:lnR>
-                    <a:lnT w="6350" cap="flat" cmpd="sng" algn="ctr">
-                      <a:solidFill>
-                        <a:srgbClr val="028090"/>
-                      </a:solidFill>
-                      <a:prstDash val="solid"/>
-                      <a:round/>
-                      <a:headEnd type="none" w="med" len="med"/>
-                      <a:tailEnd type="none" w="med" len="med"/>
-                    </a:lnT>
-                    <a:lnB w="6350" cap="flat" cmpd="sng" algn="ctr">
-                      <a:solidFill>
-                        <a:srgbClr val="028090"/>
-                      </a:solidFill>
-                      <a:prstDash val="solid"/>
-                      <a:round/>
-                      <a:headEnd type="none" w="med" len="med"/>
-                      <a:tailEnd type="none" w="med" len="med"/>
-                    </a:lnB>
-                    <a:solidFill>
-                      <a:srgbClr val="028090"/>
-                    </a:solidFill>
-                  </a:tcPr>
-                </a:tc>
-                <a:tc>
-                  <a:txBody>
-                    <a:bodyPr/>
-                    <a:lstStyle/>
-                    <a:p>
-                      <a:pPr algn="ctr" indent="0" marL="0">
-                        <a:buNone/>
-                      </a:pPr>
-                      <a:r>
-                        <a:rPr lang="en-US" sz="1100" b="1" dirty="0">
-                          <a:solidFill>
-                            <a:srgbClr val="FFFFFF"/>
-                          </a:solidFill>
-                          <a:latin typeface="Calibri" pitchFamily="34" charset="0"/>
-                          <a:ea typeface="Calibri" pitchFamily="34" charset="-122"/>
-                          <a:cs typeface="Calibri" pitchFamily="34" charset="-120"/>
-                        </a:rPr>
-                        <a:t>gpt-5.3-codex</a:t>
+                        <a:t>claude-sonnet-4.6</a:t>
                       </a:r>
                       <a:endParaRPr lang="en-US" sz="1100" dirty="0">
                         <a:latin typeface="Calibri" charset="0"/>
@@ -11721,7 +11595,7 @@
                   </a:tcPr>
                 </a:tc>
               </a:tr>
-              <a:tr h="347472">
+              <a:tr h="384048">
                 <a:tc>
                   <a:txBody>
                     <a:bodyPr/>
@@ -11807,7 +11681,557 @@
                           <a:ea typeface="Calibri" pitchFamily="34" charset="-122"/>
                           <a:cs typeface="Calibri" pitchFamily="34" charset="-120"/>
                         </a:rPr>
-                        <a:t>0.933</a:t>
+                        <a:t>0.873</a:t>
+                      </a:r>
+                      <a:endParaRPr lang="en-US" sz="1100" dirty="0">
+                        <a:latin typeface="Calibri" charset="0"/>
+                        <a:ea typeface="Calibri" charset="0"/>
+                        <a:cs typeface="Calibri" charset="0"/>
+                      </a:endParaRPr>
+                    </a:p>
+                  </a:txBody>
+                  <a:tcPr marL="91440" marR="91440" marT="45720" marB="45720">
+                    <a:lnL w="6350" cap="flat" cmpd="sng" algn="ctr">
+                      <a:solidFill>
+                        <a:srgbClr val="028090"/>
+                      </a:solidFill>
+                      <a:prstDash val="solid"/>
+                      <a:round/>
+                      <a:headEnd type="none" w="med" len="med"/>
+                      <a:tailEnd type="none" w="med" len="med"/>
+                    </a:lnL>
+                    <a:lnR w="6350" cap="flat" cmpd="sng" algn="ctr">
+                      <a:solidFill>
+                        <a:srgbClr val="028090"/>
+                      </a:solidFill>
+                      <a:prstDash val="solid"/>
+                      <a:round/>
+                      <a:headEnd type="none" w="med" len="med"/>
+                      <a:tailEnd type="none" w="med" len="med"/>
+                    </a:lnR>
+                    <a:lnT w="6350" cap="flat" cmpd="sng" algn="ctr">
+                      <a:solidFill>
+                        <a:srgbClr val="028090"/>
+                      </a:solidFill>
+                      <a:prstDash val="solid"/>
+                      <a:round/>
+                      <a:headEnd type="none" w="med" len="med"/>
+                      <a:tailEnd type="none" w="med" len="med"/>
+                    </a:lnT>
+                    <a:lnB w="6350" cap="flat" cmpd="sng" algn="ctr">
+                      <a:solidFill>
+                        <a:srgbClr val="028090"/>
+                      </a:solidFill>
+                      <a:prstDash val="solid"/>
+                      <a:round/>
+                      <a:headEnd type="none" w="med" len="med"/>
+                      <a:tailEnd type="none" w="med" len="med"/>
+                    </a:lnB>
+                    <a:solidFill>
+                      <a:srgbClr val="F4FAFA"/>
+                    </a:solidFill>
+                  </a:tcPr>
+                </a:tc>
+                <a:tc>
+                  <a:txBody>
+                    <a:bodyPr/>
+                    <a:lstStyle/>
+                    <a:p>
+                      <a:pPr algn="ctr" indent="0" marL="0">
+                        <a:buNone/>
+                      </a:pPr>
+                      <a:r>
+                        <a:rPr lang="en-US" sz="1100" b="1" dirty="0">
+                          <a:solidFill>
+                            <a:srgbClr val="1A2E30"/>
+                          </a:solidFill>
+                          <a:latin typeface="Calibri" pitchFamily="34" charset="0"/>
+                          <a:ea typeface="Calibri" pitchFamily="34" charset="-122"/>
+                          <a:cs typeface="Calibri" pitchFamily="34" charset="-120"/>
+                        </a:rPr>
+                        <a:t>0.873</a:t>
+                      </a:r>
+                      <a:endParaRPr lang="en-US" sz="1100" dirty="0">
+                        <a:latin typeface="Calibri" charset="0"/>
+                        <a:ea typeface="Calibri" charset="0"/>
+                        <a:cs typeface="Calibri" charset="0"/>
+                      </a:endParaRPr>
+                    </a:p>
+                  </a:txBody>
+                  <a:tcPr marL="91440" marR="91440" marT="45720" marB="45720">
+                    <a:lnL w="6350" cap="flat" cmpd="sng" algn="ctr">
+                      <a:solidFill>
+                        <a:srgbClr val="028090"/>
+                      </a:solidFill>
+                      <a:prstDash val="solid"/>
+                      <a:round/>
+                      <a:headEnd type="none" w="med" len="med"/>
+                      <a:tailEnd type="none" w="med" len="med"/>
+                    </a:lnL>
+                    <a:lnR w="6350" cap="flat" cmpd="sng" algn="ctr">
+                      <a:solidFill>
+                        <a:srgbClr val="028090"/>
+                      </a:solidFill>
+                      <a:prstDash val="solid"/>
+                      <a:round/>
+                      <a:headEnd type="none" w="med" len="med"/>
+                      <a:tailEnd type="none" w="med" len="med"/>
+                    </a:lnR>
+                    <a:lnT w="6350" cap="flat" cmpd="sng" algn="ctr">
+                      <a:solidFill>
+                        <a:srgbClr val="028090"/>
+                      </a:solidFill>
+                      <a:prstDash val="solid"/>
+                      <a:round/>
+                      <a:headEnd type="none" w="med" len="med"/>
+                      <a:tailEnd type="none" w="med" len="med"/>
+                    </a:lnT>
+                    <a:lnB w="6350" cap="flat" cmpd="sng" algn="ctr">
+                      <a:solidFill>
+                        <a:srgbClr val="028090"/>
+                      </a:solidFill>
+                      <a:prstDash val="solid"/>
+                      <a:round/>
+                      <a:headEnd type="none" w="med" len="med"/>
+                      <a:tailEnd type="none" w="med" len="med"/>
+                    </a:lnB>
+                    <a:solidFill>
+                      <a:srgbClr val="F4FAFA"/>
+                    </a:solidFill>
+                  </a:tcPr>
+                </a:tc>
+              </a:tr>
+              <a:tr h="384048">
+                <a:tc>
+                  <a:txBody>
+                    <a:bodyPr/>
+                    <a:lstStyle/>
+                    <a:p>
+                      <a:pPr indent="0" marL="0">
+                        <a:buNone/>
+                      </a:pPr>
+                      <a:r>
+                        <a:rPr lang="en-US" sz="1100" b="1" dirty="0">
+                          <a:solidFill>
+                            <a:srgbClr val="02C39A"/>
+                          </a:solidFill>
+                          <a:latin typeface="Calibri" pitchFamily="34" charset="0"/>
+                          <a:ea typeface="Calibri" pitchFamily="34" charset="-122"/>
+                          <a:cs typeface="Calibri" pitchFamily="34" charset="-120"/>
+                        </a:rPr>
+                        <a:t>docs-vnext/ 🥈</a:t>
+                      </a:r>
+                      <a:endParaRPr lang="en-US" sz="1100" dirty="0">
+                        <a:latin typeface="Calibri" charset="0"/>
+                        <a:ea typeface="Calibri" charset="0"/>
+                        <a:cs typeface="Calibri" charset="0"/>
+                      </a:endParaRPr>
+                    </a:p>
+                  </a:txBody>
+                  <a:tcPr marL="91440" marR="91440" marT="45720" marB="45720">
+                    <a:lnL w="6350" cap="flat" cmpd="sng" algn="ctr">
+                      <a:solidFill>
+                        <a:srgbClr val="028090"/>
+                      </a:solidFill>
+                      <a:prstDash val="solid"/>
+                      <a:round/>
+                      <a:headEnd type="none" w="med" len="med"/>
+                      <a:tailEnd type="none" w="med" len="med"/>
+                    </a:lnL>
+                    <a:lnR w="6350" cap="flat" cmpd="sng" algn="ctr">
+                      <a:solidFill>
+                        <a:srgbClr val="028090"/>
+                      </a:solidFill>
+                      <a:prstDash val="solid"/>
+                      <a:round/>
+                      <a:headEnd type="none" w="med" len="med"/>
+                      <a:tailEnd type="none" w="med" len="med"/>
+                    </a:lnR>
+                    <a:lnT w="6350" cap="flat" cmpd="sng" algn="ctr">
+                      <a:solidFill>
+                        <a:srgbClr val="028090"/>
+                      </a:solidFill>
+                      <a:prstDash val="solid"/>
+                      <a:round/>
+                      <a:headEnd type="none" w="med" len="med"/>
+                      <a:tailEnd type="none" w="med" len="med"/>
+                    </a:lnT>
+                    <a:lnB w="6350" cap="flat" cmpd="sng" algn="ctr">
+                      <a:solidFill>
+                        <a:srgbClr val="028090"/>
+                      </a:solidFill>
+                      <a:prstDash val="solid"/>
+                      <a:round/>
+                      <a:headEnd type="none" w="med" len="med"/>
+                      <a:tailEnd type="none" w="med" len="med"/>
+                    </a:lnB>
+                    <a:solidFill>
+                      <a:srgbClr val="022C33"/>
+                    </a:solidFill>
+                  </a:tcPr>
+                </a:tc>
+                <a:tc>
+                  <a:txBody>
+                    <a:bodyPr/>
+                    <a:lstStyle/>
+                    <a:p>
+                      <a:pPr algn="ctr" indent="0" marL="0">
+                        <a:buNone/>
+                      </a:pPr>
+                      <a:r>
+                        <a:rPr lang="en-US" sz="1100" b="1" dirty="0">
+                          <a:solidFill>
+                            <a:srgbClr val="02C39A"/>
+                          </a:solidFill>
+                          <a:latin typeface="Calibri" pitchFamily="34" charset="0"/>
+                          <a:ea typeface="Calibri" pitchFamily="34" charset="-122"/>
+                          <a:cs typeface="Calibri" pitchFamily="34" charset="-120"/>
+                        </a:rPr>
+                        <a:t>0.863</a:t>
+                      </a:r>
+                      <a:endParaRPr lang="en-US" sz="1100" dirty="0">
+                        <a:latin typeface="Calibri" charset="0"/>
+                        <a:ea typeface="Calibri" charset="0"/>
+                        <a:cs typeface="Calibri" charset="0"/>
+                      </a:endParaRPr>
+                    </a:p>
+                  </a:txBody>
+                  <a:tcPr marL="91440" marR="91440" marT="45720" marB="45720">
+                    <a:lnL w="6350" cap="flat" cmpd="sng" algn="ctr">
+                      <a:solidFill>
+                        <a:srgbClr val="028090"/>
+                      </a:solidFill>
+                      <a:prstDash val="solid"/>
+                      <a:round/>
+                      <a:headEnd type="none" w="med" len="med"/>
+                      <a:tailEnd type="none" w="med" len="med"/>
+                    </a:lnL>
+                    <a:lnR w="6350" cap="flat" cmpd="sng" algn="ctr">
+                      <a:solidFill>
+                        <a:srgbClr val="028090"/>
+                      </a:solidFill>
+                      <a:prstDash val="solid"/>
+                      <a:round/>
+                      <a:headEnd type="none" w="med" len="med"/>
+                      <a:tailEnd type="none" w="med" len="med"/>
+                    </a:lnR>
+                    <a:lnT w="6350" cap="flat" cmpd="sng" algn="ctr">
+                      <a:solidFill>
+                        <a:srgbClr val="028090"/>
+                      </a:solidFill>
+                      <a:prstDash val="solid"/>
+                      <a:round/>
+                      <a:headEnd type="none" w="med" len="med"/>
+                      <a:tailEnd type="none" w="med" len="med"/>
+                    </a:lnT>
+                    <a:lnB w="6350" cap="flat" cmpd="sng" algn="ctr">
+                      <a:solidFill>
+                        <a:srgbClr val="028090"/>
+                      </a:solidFill>
+                      <a:prstDash val="solid"/>
+                      <a:round/>
+                      <a:headEnd type="none" w="med" len="med"/>
+                      <a:tailEnd type="none" w="med" len="med"/>
+                    </a:lnB>
+                    <a:solidFill>
+                      <a:srgbClr val="022C33"/>
+                    </a:solidFill>
+                  </a:tcPr>
+                </a:tc>
+                <a:tc>
+                  <a:txBody>
+                    <a:bodyPr/>
+                    <a:lstStyle/>
+                    <a:p>
+                      <a:pPr algn="ctr" indent="0" marL="0">
+                        <a:buNone/>
+                      </a:pPr>
+                      <a:r>
+                        <a:rPr lang="en-US" sz="1100" b="1" dirty="0">
+                          <a:solidFill>
+                            <a:srgbClr val="02C39A"/>
+                          </a:solidFill>
+                          <a:latin typeface="Calibri" pitchFamily="34" charset="0"/>
+                          <a:ea typeface="Calibri" pitchFamily="34" charset="-122"/>
+                          <a:cs typeface="Calibri" pitchFamily="34" charset="-120"/>
+                        </a:rPr>
+                        <a:t>0.863</a:t>
+                      </a:r>
+                      <a:endParaRPr lang="en-US" sz="1100" dirty="0">
+                        <a:latin typeface="Calibri" charset="0"/>
+                        <a:ea typeface="Calibri" charset="0"/>
+                        <a:cs typeface="Calibri" charset="0"/>
+                      </a:endParaRPr>
+                    </a:p>
+                  </a:txBody>
+                  <a:tcPr marL="91440" marR="91440" marT="45720" marB="45720">
+                    <a:lnL w="6350" cap="flat" cmpd="sng" algn="ctr">
+                      <a:solidFill>
+                        <a:srgbClr val="028090"/>
+                      </a:solidFill>
+                      <a:prstDash val="solid"/>
+                      <a:round/>
+                      <a:headEnd type="none" w="med" len="med"/>
+                      <a:tailEnd type="none" w="med" len="med"/>
+                    </a:lnL>
+                    <a:lnR w="6350" cap="flat" cmpd="sng" algn="ctr">
+                      <a:solidFill>
+                        <a:srgbClr val="028090"/>
+                      </a:solidFill>
+                      <a:prstDash val="solid"/>
+                      <a:round/>
+                      <a:headEnd type="none" w="med" len="med"/>
+                      <a:tailEnd type="none" w="med" len="med"/>
+                    </a:lnR>
+                    <a:lnT w="6350" cap="flat" cmpd="sng" algn="ctr">
+                      <a:solidFill>
+                        <a:srgbClr val="028090"/>
+                      </a:solidFill>
+                      <a:prstDash val="solid"/>
+                      <a:round/>
+                      <a:headEnd type="none" w="med" len="med"/>
+                      <a:tailEnd type="none" w="med" len="med"/>
+                    </a:lnT>
+                    <a:lnB w="6350" cap="flat" cmpd="sng" algn="ctr">
+                      <a:solidFill>
+                        <a:srgbClr val="028090"/>
+                      </a:solidFill>
+                      <a:prstDash val="solid"/>
+                      <a:round/>
+                      <a:headEnd type="none" w="med" len="med"/>
+                      <a:tailEnd type="none" w="med" len="med"/>
+                    </a:lnB>
+                    <a:solidFill>
+                      <a:srgbClr val="022C33"/>
+                    </a:solidFill>
+                  </a:tcPr>
+                </a:tc>
+              </a:tr>
+              <a:tr h="384048">
+                <a:tc>
+                  <a:txBody>
+                    <a:bodyPr/>
+                    <a:lstStyle/>
+                    <a:p>
+                      <a:pPr indent="0" marL="0">
+                        <a:buNone/>
+                      </a:pPr>
+                      <a:r>
+                        <a:rPr lang="en-US" sz="1100" dirty="0">
+                          <a:solidFill>
+                            <a:srgbClr val="5A8087"/>
+                          </a:solidFill>
+                          <a:latin typeface="Calibri" pitchFamily="34" charset="0"/>
+                          <a:ea typeface="Calibri" pitchFamily="34" charset="-122"/>
+                          <a:cs typeface="Calibri" pitchFamily="34" charset="-120"/>
+                        </a:rPr>
+                        <a:t>docs/ 🥉</a:t>
+                      </a:r>
+                      <a:endParaRPr lang="en-US" sz="1100" dirty="0">
+                        <a:latin typeface="Calibri" charset="0"/>
+                        <a:ea typeface="Calibri" charset="0"/>
+                        <a:cs typeface="Calibri" charset="0"/>
+                      </a:endParaRPr>
+                    </a:p>
+                  </a:txBody>
+                  <a:tcPr marL="91440" marR="91440" marT="45720" marB="45720">
+                    <a:lnL w="6350" cap="flat" cmpd="sng" algn="ctr">
+                      <a:solidFill>
+                        <a:srgbClr val="028090"/>
+                      </a:solidFill>
+                      <a:prstDash val="solid"/>
+                      <a:round/>
+                      <a:headEnd type="none" w="med" len="med"/>
+                      <a:tailEnd type="none" w="med" len="med"/>
+                    </a:lnL>
+                    <a:lnR w="6350" cap="flat" cmpd="sng" algn="ctr">
+                      <a:solidFill>
+                        <a:srgbClr val="028090"/>
+                      </a:solidFill>
+                      <a:prstDash val="solid"/>
+                      <a:round/>
+                      <a:headEnd type="none" w="med" len="med"/>
+                      <a:tailEnd type="none" w="med" len="med"/>
+                    </a:lnR>
+                    <a:lnT w="6350" cap="flat" cmpd="sng" algn="ctr">
+                      <a:solidFill>
+                        <a:srgbClr val="028090"/>
+                      </a:solidFill>
+                      <a:prstDash val="solid"/>
+                      <a:round/>
+                      <a:headEnd type="none" w="med" len="med"/>
+                      <a:tailEnd type="none" w="med" len="med"/>
+                    </a:lnT>
+                    <a:lnB w="6350" cap="flat" cmpd="sng" algn="ctr">
+                      <a:solidFill>
+                        <a:srgbClr val="028090"/>
+                      </a:solidFill>
+                      <a:prstDash val="solid"/>
+                      <a:round/>
+                      <a:headEnd type="none" w="med" len="med"/>
+                      <a:tailEnd type="none" w="med" len="med"/>
+                    </a:lnB>
+                    <a:solidFill>
+                      <a:srgbClr val="EFF6F6"/>
+                    </a:solidFill>
+                  </a:tcPr>
+                </a:tc>
+                <a:tc>
+                  <a:txBody>
+                    <a:bodyPr/>
+                    <a:lstStyle/>
+                    <a:p>
+                      <a:pPr algn="ctr" indent="0" marL="0">
+                        <a:buNone/>
+                      </a:pPr>
+                      <a:r>
+                        <a:rPr lang="en-US" sz="1100" dirty="0">
+                          <a:solidFill>
+                            <a:srgbClr val="5A8087"/>
+                          </a:solidFill>
+                          <a:latin typeface="Calibri" pitchFamily="34" charset="0"/>
+                          <a:ea typeface="Calibri" pitchFamily="34" charset="-122"/>
+                          <a:cs typeface="Calibri" pitchFamily="34" charset="-120"/>
+                        </a:rPr>
+                        <a:t>0.855</a:t>
+                      </a:r>
+                      <a:endParaRPr lang="en-US" sz="1100" dirty="0">
+                        <a:latin typeface="Calibri" charset="0"/>
+                        <a:ea typeface="Calibri" charset="0"/>
+                        <a:cs typeface="Calibri" charset="0"/>
+                      </a:endParaRPr>
+                    </a:p>
+                  </a:txBody>
+                  <a:tcPr marL="91440" marR="91440" marT="45720" marB="45720">
+                    <a:lnL w="6350" cap="flat" cmpd="sng" algn="ctr">
+                      <a:solidFill>
+                        <a:srgbClr val="028090"/>
+                      </a:solidFill>
+                      <a:prstDash val="solid"/>
+                      <a:round/>
+                      <a:headEnd type="none" w="med" len="med"/>
+                      <a:tailEnd type="none" w="med" len="med"/>
+                    </a:lnL>
+                    <a:lnR w="6350" cap="flat" cmpd="sng" algn="ctr">
+                      <a:solidFill>
+                        <a:srgbClr val="028090"/>
+                      </a:solidFill>
+                      <a:prstDash val="solid"/>
+                      <a:round/>
+                      <a:headEnd type="none" w="med" len="med"/>
+                      <a:tailEnd type="none" w="med" len="med"/>
+                    </a:lnR>
+                    <a:lnT w="6350" cap="flat" cmpd="sng" algn="ctr">
+                      <a:solidFill>
+                        <a:srgbClr val="028090"/>
+                      </a:solidFill>
+                      <a:prstDash val="solid"/>
+                      <a:round/>
+                      <a:headEnd type="none" w="med" len="med"/>
+                      <a:tailEnd type="none" w="med" len="med"/>
+                    </a:lnT>
+                    <a:lnB w="6350" cap="flat" cmpd="sng" algn="ctr">
+                      <a:solidFill>
+                        <a:srgbClr val="028090"/>
+                      </a:solidFill>
+                      <a:prstDash val="solid"/>
+                      <a:round/>
+                      <a:headEnd type="none" w="med" len="med"/>
+                      <a:tailEnd type="none" w="med" len="med"/>
+                    </a:lnB>
+                    <a:solidFill>
+                      <a:srgbClr val="EFF6F6"/>
+                    </a:solidFill>
+                  </a:tcPr>
+                </a:tc>
+                <a:tc>
+                  <a:txBody>
+                    <a:bodyPr/>
+                    <a:lstStyle/>
+                    <a:p>
+                      <a:pPr algn="ctr" indent="0" marL="0">
+                        <a:buNone/>
+                      </a:pPr>
+                      <a:r>
+                        <a:rPr lang="en-US" sz="1100" dirty="0">
+                          <a:solidFill>
+                            <a:srgbClr val="5A8087"/>
+                          </a:solidFill>
+                          <a:latin typeface="Calibri" pitchFamily="34" charset="0"/>
+                          <a:ea typeface="Calibri" pitchFamily="34" charset="-122"/>
+                          <a:cs typeface="Calibri" pitchFamily="34" charset="-120"/>
+                        </a:rPr>
+                        <a:t>0.855</a:t>
+                      </a:r>
+                      <a:endParaRPr lang="en-US" sz="1100" dirty="0">
+                        <a:latin typeface="Calibri" charset="0"/>
+                        <a:ea typeface="Calibri" charset="0"/>
+                        <a:cs typeface="Calibri" charset="0"/>
+                      </a:endParaRPr>
+                    </a:p>
+                  </a:txBody>
+                  <a:tcPr marL="91440" marR="91440" marT="45720" marB="45720">
+                    <a:lnL w="6350" cap="flat" cmpd="sng" algn="ctr">
+                      <a:solidFill>
+                        <a:srgbClr val="028090"/>
+                      </a:solidFill>
+                      <a:prstDash val="solid"/>
+                      <a:round/>
+                      <a:headEnd type="none" w="med" len="med"/>
+                      <a:tailEnd type="none" w="med" len="med"/>
+                    </a:lnL>
+                    <a:lnR w="6350" cap="flat" cmpd="sng" algn="ctr">
+                      <a:solidFill>
+                        <a:srgbClr val="028090"/>
+                      </a:solidFill>
+                      <a:prstDash val="solid"/>
+                      <a:round/>
+                      <a:headEnd type="none" w="med" len="med"/>
+                      <a:tailEnd type="none" w="med" len="med"/>
+                    </a:lnR>
+                    <a:lnT w="6350" cap="flat" cmpd="sng" algn="ctr">
+                      <a:solidFill>
+                        <a:srgbClr val="028090"/>
+                      </a:solidFill>
+                      <a:prstDash val="solid"/>
+                      <a:round/>
+                      <a:headEnd type="none" w="med" len="med"/>
+                      <a:tailEnd type="none" w="med" len="med"/>
+                    </a:lnT>
+                    <a:lnB w="6350" cap="flat" cmpd="sng" algn="ctr">
+                      <a:solidFill>
+                        <a:srgbClr val="028090"/>
+                      </a:solidFill>
+                      <a:prstDash val="solid"/>
+                      <a:round/>
+                      <a:headEnd type="none" w="med" len="med"/>
+                      <a:tailEnd type="none" w="med" len="med"/>
+                    </a:lnB>
+                    <a:solidFill>
+                      <a:srgbClr val="EFF6F6"/>
+                    </a:solidFill>
+                  </a:tcPr>
+                </a:tc>
+              </a:tr>
+              <a:tr h="384048">
+                <a:tc>
+                  <a:txBody>
+                    <a:bodyPr/>
+                    <a:lstStyle/>
+                    <a:p>
+                      <a:pPr indent="0" marL="0">
+                        <a:buNone/>
+                      </a:pPr>
+                      <a:r>
+                        <a:rPr lang="en-US" sz="1100" dirty="0">
+                          <a:solidFill>
+                            <a:srgbClr val="1A2E30"/>
+                          </a:solidFill>
+                          <a:latin typeface="Calibri" pitchFamily="34" charset="0"/>
+                          <a:ea typeface="Calibri" pitchFamily="34" charset="-122"/>
+                          <a:cs typeface="Calibri" pitchFamily="34" charset="-120"/>
+                        </a:rPr>
+                        <a:t>Mintlify MCP</a:t>
                       </a:r>
                       <a:endParaRPr lang="en-US" sz="1100" dirty="0">
                         <a:latin typeface="Calibri" charset="0"/>
@@ -11875,75 +12299,7 @@
                           <a:ea typeface="Calibri" pitchFamily="34" charset="-122"/>
                           <a:cs typeface="Calibri" pitchFamily="34" charset="-120"/>
                         </a:rPr>
-                        <a:t>0.882</a:t>
-                      </a:r>
-                      <a:endParaRPr lang="en-US" sz="1100" dirty="0">
-                        <a:latin typeface="Calibri" charset="0"/>
-                        <a:ea typeface="Calibri" charset="0"/>
-                        <a:cs typeface="Calibri" charset="0"/>
-                      </a:endParaRPr>
-                    </a:p>
-                  </a:txBody>
-                  <a:tcPr marL="91440" marR="91440" marT="45720" marB="45720">
-                    <a:lnL w="6350" cap="flat" cmpd="sng" algn="ctr">
-                      <a:solidFill>
-                        <a:srgbClr val="028090"/>
-                      </a:solidFill>
-                      <a:prstDash val="solid"/>
-                      <a:round/>
-                      <a:headEnd type="none" w="med" len="med"/>
-                      <a:tailEnd type="none" w="med" len="med"/>
-                    </a:lnL>
-                    <a:lnR w="6350" cap="flat" cmpd="sng" algn="ctr">
-                      <a:solidFill>
-                        <a:srgbClr val="028090"/>
-                      </a:solidFill>
-                      <a:prstDash val="solid"/>
-                      <a:round/>
-                      <a:headEnd type="none" w="med" len="med"/>
-                      <a:tailEnd type="none" w="med" len="med"/>
-                    </a:lnR>
-                    <a:lnT w="6350" cap="flat" cmpd="sng" algn="ctr">
-                      <a:solidFill>
-                        <a:srgbClr val="028090"/>
-                      </a:solidFill>
-                      <a:prstDash val="solid"/>
-                      <a:round/>
-                      <a:headEnd type="none" w="med" len="med"/>
-                      <a:tailEnd type="none" w="med" len="med"/>
-                    </a:lnT>
-                    <a:lnB w="6350" cap="flat" cmpd="sng" algn="ctr">
-                      <a:solidFill>
-                        <a:srgbClr val="028090"/>
-                      </a:solidFill>
-                      <a:prstDash val="solid"/>
-                      <a:round/>
-                      <a:headEnd type="none" w="med" len="med"/>
-                      <a:tailEnd type="none" w="med" len="med"/>
-                    </a:lnB>
-                    <a:solidFill>
-                      <a:srgbClr val="F4FAFA"/>
-                    </a:solidFill>
-                  </a:tcPr>
-                </a:tc>
-                <a:tc>
-                  <a:txBody>
-                    <a:bodyPr/>
-                    <a:lstStyle/>
-                    <a:p>
-                      <a:pPr algn="ctr" indent="0" marL="0">
-                        <a:buNone/>
-                      </a:pPr>
-                      <a:r>
-                        <a:rPr lang="en-US" sz="1100" dirty="0">
-                          <a:solidFill>
-                            <a:srgbClr val="1A2E30"/>
-                          </a:solidFill>
-                          <a:latin typeface="Calibri" pitchFamily="34" charset="0"/>
-                          <a:ea typeface="Calibri" pitchFamily="34" charset="-122"/>
-                          <a:cs typeface="Calibri" pitchFamily="34" charset="-120"/>
-                        </a:rPr>
-                        <a:t>0.906</a:t>
+                        <a:t>0.843</a:t>
                       </a:r>
                       <a:endParaRPr lang="en-US" sz="1100" dirty="0">
                         <a:latin typeface="Calibri" charset="0"/>
@@ -12011,7 +12367,7 @@
                           <a:ea typeface="Calibri" pitchFamily="34" charset="-122"/>
                           <a:cs typeface="Calibri" pitchFamily="34" charset="-120"/>
                         </a:rPr>
-                        <a:t>0.908</a:t>
+                        <a:t>0.843</a:t>
                       </a:r>
                       <a:endParaRPr lang="en-US" sz="1100" dirty="0">
                         <a:latin typeface="Calibri" charset="0"/>
@@ -12063,1032 +12419,6 @@
                   </a:tcPr>
                 </a:tc>
               </a:tr>
-              <a:tr h="347472">
-                <a:tc>
-                  <a:txBody>
-                    <a:bodyPr/>
-                    <a:lstStyle/>
-                    <a:p>
-                      <a:pPr indent="0" marL="0">
-                        <a:buNone/>
-                      </a:pPr>
-                      <a:r>
-                        <a:rPr lang="en-US" sz="1100" dirty="0">
-                          <a:solidFill>
-                            <a:srgbClr val="1A2E30"/>
-                          </a:solidFill>
-                          <a:latin typeface="Calibri" pitchFamily="34" charset="0"/>
-                          <a:ea typeface="Calibri" pitchFamily="34" charset="-122"/>
-                          <a:cs typeface="Calibri" pitchFamily="34" charset="-120"/>
-                        </a:rPr>
-                        <a:t>Mintlify MCP 🥈</a:t>
-                      </a:r>
-                      <a:endParaRPr lang="en-US" sz="1100" dirty="0">
-                        <a:latin typeface="Calibri" charset="0"/>
-                        <a:ea typeface="Calibri" charset="0"/>
-                        <a:cs typeface="Calibri" charset="0"/>
-                      </a:endParaRPr>
-                    </a:p>
-                  </a:txBody>
-                  <a:tcPr marL="91440" marR="91440" marT="45720" marB="45720">
-                    <a:lnL w="6350" cap="flat" cmpd="sng" algn="ctr">
-                      <a:solidFill>
-                        <a:srgbClr val="028090"/>
-                      </a:solidFill>
-                      <a:prstDash val="solid"/>
-                      <a:round/>
-                      <a:headEnd type="none" w="med" len="med"/>
-                      <a:tailEnd type="none" w="med" len="med"/>
-                    </a:lnL>
-                    <a:lnR w="6350" cap="flat" cmpd="sng" algn="ctr">
-                      <a:solidFill>
-                        <a:srgbClr val="028090"/>
-                      </a:solidFill>
-                      <a:prstDash val="solid"/>
-                      <a:round/>
-                      <a:headEnd type="none" w="med" len="med"/>
-                      <a:tailEnd type="none" w="med" len="med"/>
-                    </a:lnR>
-                    <a:lnT w="6350" cap="flat" cmpd="sng" algn="ctr">
-                      <a:solidFill>
-                        <a:srgbClr val="028090"/>
-                      </a:solidFill>
-                      <a:prstDash val="solid"/>
-                      <a:round/>
-                      <a:headEnd type="none" w="med" len="med"/>
-                      <a:tailEnd type="none" w="med" len="med"/>
-                    </a:lnT>
-                    <a:lnB w="6350" cap="flat" cmpd="sng" algn="ctr">
-                      <a:solidFill>
-                        <a:srgbClr val="028090"/>
-                      </a:solidFill>
-                      <a:prstDash val="solid"/>
-                      <a:round/>
-                      <a:headEnd type="none" w="med" len="med"/>
-                      <a:tailEnd type="none" w="med" len="med"/>
-                    </a:lnB>
-                    <a:solidFill>
-                      <a:srgbClr val="F4FAFA"/>
-                    </a:solidFill>
-                  </a:tcPr>
-                </a:tc>
-                <a:tc>
-                  <a:txBody>
-                    <a:bodyPr/>
-                    <a:lstStyle/>
-                    <a:p>
-                      <a:pPr algn="ctr" indent="0" marL="0">
-                        <a:buNone/>
-                      </a:pPr>
-                      <a:r>
-                        <a:rPr lang="en-US" sz="1100" dirty="0">
-                          <a:solidFill>
-                            <a:srgbClr val="1A2E30"/>
-                          </a:solidFill>
-                          <a:latin typeface="Calibri" pitchFamily="34" charset="0"/>
-                          <a:ea typeface="Calibri" pitchFamily="34" charset="-122"/>
-                          <a:cs typeface="Calibri" pitchFamily="34" charset="-120"/>
-                        </a:rPr>
-                        <a:t>0.949</a:t>
-                      </a:r>
-                      <a:endParaRPr lang="en-US" sz="1100" dirty="0">
-                        <a:latin typeface="Calibri" charset="0"/>
-                        <a:ea typeface="Calibri" charset="0"/>
-                        <a:cs typeface="Calibri" charset="0"/>
-                      </a:endParaRPr>
-                    </a:p>
-                  </a:txBody>
-                  <a:tcPr marL="91440" marR="91440" marT="45720" marB="45720">
-                    <a:lnL w="6350" cap="flat" cmpd="sng" algn="ctr">
-                      <a:solidFill>
-                        <a:srgbClr val="028090"/>
-                      </a:solidFill>
-                      <a:prstDash val="solid"/>
-                      <a:round/>
-                      <a:headEnd type="none" w="med" len="med"/>
-                      <a:tailEnd type="none" w="med" len="med"/>
-                    </a:lnL>
-                    <a:lnR w="6350" cap="flat" cmpd="sng" algn="ctr">
-                      <a:solidFill>
-                        <a:srgbClr val="028090"/>
-                      </a:solidFill>
-                      <a:prstDash val="solid"/>
-                      <a:round/>
-                      <a:headEnd type="none" w="med" len="med"/>
-                      <a:tailEnd type="none" w="med" len="med"/>
-                    </a:lnR>
-                    <a:lnT w="6350" cap="flat" cmpd="sng" algn="ctr">
-                      <a:solidFill>
-                        <a:srgbClr val="028090"/>
-                      </a:solidFill>
-                      <a:prstDash val="solid"/>
-                      <a:round/>
-                      <a:headEnd type="none" w="med" len="med"/>
-                      <a:tailEnd type="none" w="med" len="med"/>
-                    </a:lnT>
-                    <a:lnB w="6350" cap="flat" cmpd="sng" algn="ctr">
-                      <a:solidFill>
-                        <a:srgbClr val="028090"/>
-                      </a:solidFill>
-                      <a:prstDash val="solid"/>
-                      <a:round/>
-                      <a:headEnd type="none" w="med" len="med"/>
-                      <a:tailEnd type="none" w="med" len="med"/>
-                    </a:lnB>
-                    <a:solidFill>
-                      <a:srgbClr val="F4FAFA"/>
-                    </a:solidFill>
-                  </a:tcPr>
-                </a:tc>
-                <a:tc>
-                  <a:txBody>
-                    <a:bodyPr/>
-                    <a:lstStyle/>
-                    <a:p>
-                      <a:pPr algn="ctr" indent="0" marL="0">
-                        <a:buNone/>
-                      </a:pPr>
-                      <a:r>
-                        <a:rPr lang="en-US" sz="1100" dirty="0">
-                          <a:solidFill>
-                            <a:srgbClr val="1A2E30"/>
-                          </a:solidFill>
-                          <a:latin typeface="Calibri" pitchFamily="34" charset="0"/>
-                          <a:ea typeface="Calibri" pitchFamily="34" charset="-122"/>
-                          <a:cs typeface="Calibri" pitchFamily="34" charset="-120"/>
-                        </a:rPr>
-                        <a:t>0.868</a:t>
-                      </a:r>
-                      <a:endParaRPr lang="en-US" sz="1100" dirty="0">
-                        <a:latin typeface="Calibri" charset="0"/>
-                        <a:ea typeface="Calibri" charset="0"/>
-                        <a:cs typeface="Calibri" charset="0"/>
-                      </a:endParaRPr>
-                    </a:p>
-                  </a:txBody>
-                  <a:tcPr marL="91440" marR="91440" marT="45720" marB="45720">
-                    <a:lnL w="6350" cap="flat" cmpd="sng" algn="ctr">
-                      <a:solidFill>
-                        <a:srgbClr val="028090"/>
-                      </a:solidFill>
-                      <a:prstDash val="solid"/>
-                      <a:round/>
-                      <a:headEnd type="none" w="med" len="med"/>
-                      <a:tailEnd type="none" w="med" len="med"/>
-                    </a:lnL>
-                    <a:lnR w="6350" cap="flat" cmpd="sng" algn="ctr">
-                      <a:solidFill>
-                        <a:srgbClr val="028090"/>
-                      </a:solidFill>
-                      <a:prstDash val="solid"/>
-                      <a:round/>
-                      <a:headEnd type="none" w="med" len="med"/>
-                      <a:tailEnd type="none" w="med" len="med"/>
-                    </a:lnR>
-                    <a:lnT w="6350" cap="flat" cmpd="sng" algn="ctr">
-                      <a:solidFill>
-                        <a:srgbClr val="028090"/>
-                      </a:solidFill>
-                      <a:prstDash val="solid"/>
-                      <a:round/>
-                      <a:headEnd type="none" w="med" len="med"/>
-                      <a:tailEnd type="none" w="med" len="med"/>
-                    </a:lnT>
-                    <a:lnB w="6350" cap="flat" cmpd="sng" algn="ctr">
-                      <a:solidFill>
-                        <a:srgbClr val="028090"/>
-                      </a:solidFill>
-                      <a:prstDash val="solid"/>
-                      <a:round/>
-                      <a:headEnd type="none" w="med" len="med"/>
-                      <a:tailEnd type="none" w="med" len="med"/>
-                    </a:lnB>
-                    <a:solidFill>
-                      <a:srgbClr val="F4FAFA"/>
-                    </a:solidFill>
-                  </a:tcPr>
-                </a:tc>
-                <a:tc>
-                  <a:txBody>
-                    <a:bodyPr/>
-                    <a:lstStyle/>
-                    <a:p>
-                      <a:pPr algn="ctr" indent="0" marL="0">
-                        <a:buNone/>
-                      </a:pPr>
-                      <a:r>
-                        <a:rPr lang="en-US" sz="1100" dirty="0">
-                          <a:solidFill>
-                            <a:srgbClr val="1A2E30"/>
-                          </a:solidFill>
-                          <a:latin typeface="Calibri" pitchFamily="34" charset="0"/>
-                          <a:ea typeface="Calibri" pitchFamily="34" charset="-122"/>
-                          <a:cs typeface="Calibri" pitchFamily="34" charset="-120"/>
-                        </a:rPr>
-                        <a:t>0.905</a:t>
-                      </a:r>
-                      <a:endParaRPr lang="en-US" sz="1100" dirty="0">
-                        <a:latin typeface="Calibri" charset="0"/>
-                        <a:ea typeface="Calibri" charset="0"/>
-                        <a:cs typeface="Calibri" charset="0"/>
-                      </a:endParaRPr>
-                    </a:p>
-                  </a:txBody>
-                  <a:tcPr marL="91440" marR="91440" marT="45720" marB="45720">
-                    <a:lnL w="6350" cap="flat" cmpd="sng" algn="ctr">
-                      <a:solidFill>
-                        <a:srgbClr val="028090"/>
-                      </a:solidFill>
-                      <a:prstDash val="solid"/>
-                      <a:round/>
-                      <a:headEnd type="none" w="med" len="med"/>
-                      <a:tailEnd type="none" w="med" len="med"/>
-                    </a:lnL>
-                    <a:lnR w="6350" cap="flat" cmpd="sng" algn="ctr">
-                      <a:solidFill>
-                        <a:srgbClr val="028090"/>
-                      </a:solidFill>
-                      <a:prstDash val="solid"/>
-                      <a:round/>
-                      <a:headEnd type="none" w="med" len="med"/>
-                      <a:tailEnd type="none" w="med" len="med"/>
-                    </a:lnR>
-                    <a:lnT w="6350" cap="flat" cmpd="sng" algn="ctr">
-                      <a:solidFill>
-                        <a:srgbClr val="028090"/>
-                      </a:solidFill>
-                      <a:prstDash val="solid"/>
-                      <a:round/>
-                      <a:headEnd type="none" w="med" len="med"/>
-                      <a:tailEnd type="none" w="med" len="med"/>
-                    </a:lnT>
-                    <a:lnB w="6350" cap="flat" cmpd="sng" algn="ctr">
-                      <a:solidFill>
-                        <a:srgbClr val="028090"/>
-                      </a:solidFill>
-                      <a:prstDash val="solid"/>
-                      <a:round/>
-                      <a:headEnd type="none" w="med" len="med"/>
-                      <a:tailEnd type="none" w="med" len="med"/>
-                    </a:lnB>
-                    <a:solidFill>
-                      <a:srgbClr val="F4FAFA"/>
-                    </a:solidFill>
-                  </a:tcPr>
-                </a:tc>
-                <a:tc>
-                  <a:txBody>
-                    <a:bodyPr/>
-                    <a:lstStyle/>
-                    <a:p>
-                      <a:pPr algn="ctr" indent="0" marL="0">
-                        <a:buNone/>
-                      </a:pPr>
-                      <a:r>
-                        <a:rPr lang="en-US" sz="1100" b="1" dirty="0">
-                          <a:solidFill>
-                            <a:srgbClr val="1A2E30"/>
-                          </a:solidFill>
-                          <a:latin typeface="Calibri" pitchFamily="34" charset="0"/>
-                          <a:ea typeface="Calibri" pitchFamily="34" charset="-122"/>
-                          <a:cs typeface="Calibri" pitchFamily="34" charset="-120"/>
-                        </a:rPr>
-                        <a:t>0.908</a:t>
-                      </a:r>
-                      <a:endParaRPr lang="en-US" sz="1100" dirty="0">
-                        <a:latin typeface="Calibri" charset="0"/>
-                        <a:ea typeface="Calibri" charset="0"/>
-                        <a:cs typeface="Calibri" charset="0"/>
-                      </a:endParaRPr>
-                    </a:p>
-                  </a:txBody>
-                  <a:tcPr marL="91440" marR="91440" marT="45720" marB="45720">
-                    <a:lnL w="6350" cap="flat" cmpd="sng" algn="ctr">
-                      <a:solidFill>
-                        <a:srgbClr val="028090"/>
-                      </a:solidFill>
-                      <a:prstDash val="solid"/>
-                      <a:round/>
-                      <a:headEnd type="none" w="med" len="med"/>
-                      <a:tailEnd type="none" w="med" len="med"/>
-                    </a:lnL>
-                    <a:lnR w="6350" cap="flat" cmpd="sng" algn="ctr">
-                      <a:solidFill>
-                        <a:srgbClr val="028090"/>
-                      </a:solidFill>
-                      <a:prstDash val="solid"/>
-                      <a:round/>
-                      <a:headEnd type="none" w="med" len="med"/>
-                      <a:tailEnd type="none" w="med" len="med"/>
-                    </a:lnR>
-                    <a:lnT w="6350" cap="flat" cmpd="sng" algn="ctr">
-                      <a:solidFill>
-                        <a:srgbClr val="028090"/>
-                      </a:solidFill>
-                      <a:prstDash val="solid"/>
-                      <a:round/>
-                      <a:headEnd type="none" w="med" len="med"/>
-                      <a:tailEnd type="none" w="med" len="med"/>
-                    </a:lnT>
-                    <a:lnB w="6350" cap="flat" cmpd="sng" algn="ctr">
-                      <a:solidFill>
-                        <a:srgbClr val="028090"/>
-                      </a:solidFill>
-                      <a:prstDash val="solid"/>
-                      <a:round/>
-                      <a:headEnd type="none" w="med" len="med"/>
-                      <a:tailEnd type="none" w="med" len="med"/>
-                    </a:lnB>
-                    <a:solidFill>
-                      <a:srgbClr val="F4FAFA"/>
-                    </a:solidFill>
-                  </a:tcPr>
-                </a:tc>
-              </a:tr>
-              <a:tr h="347472">
-                <a:tc>
-                  <a:txBody>
-                    <a:bodyPr/>
-                    <a:lstStyle/>
-                    <a:p>
-                      <a:pPr indent="0" marL="0">
-                        <a:buNone/>
-                      </a:pPr>
-                      <a:r>
-                        <a:rPr lang="en-US" sz="1100" b="1" dirty="0">
-                          <a:solidFill>
-                            <a:srgbClr val="02C39A"/>
-                          </a:solidFill>
-                          <a:latin typeface="Calibri" pitchFamily="34" charset="0"/>
-                          <a:ea typeface="Calibri" pitchFamily="34" charset="-122"/>
-                          <a:cs typeface="Calibri" pitchFamily="34" charset="-120"/>
-                        </a:rPr>
-                        <a:t>docs-vnext/ 🥉</a:t>
-                      </a:r>
-                      <a:endParaRPr lang="en-US" sz="1100" dirty="0">
-                        <a:latin typeface="Calibri" charset="0"/>
-                        <a:ea typeface="Calibri" charset="0"/>
-                        <a:cs typeface="Calibri" charset="0"/>
-                      </a:endParaRPr>
-                    </a:p>
-                  </a:txBody>
-                  <a:tcPr marL="91440" marR="91440" marT="45720" marB="45720">
-                    <a:lnL w="6350" cap="flat" cmpd="sng" algn="ctr">
-                      <a:solidFill>
-                        <a:srgbClr val="028090"/>
-                      </a:solidFill>
-                      <a:prstDash val="solid"/>
-                      <a:round/>
-                      <a:headEnd type="none" w="med" len="med"/>
-                      <a:tailEnd type="none" w="med" len="med"/>
-                    </a:lnL>
-                    <a:lnR w="6350" cap="flat" cmpd="sng" algn="ctr">
-                      <a:solidFill>
-                        <a:srgbClr val="028090"/>
-                      </a:solidFill>
-                      <a:prstDash val="solid"/>
-                      <a:round/>
-                      <a:headEnd type="none" w="med" len="med"/>
-                      <a:tailEnd type="none" w="med" len="med"/>
-                    </a:lnR>
-                    <a:lnT w="6350" cap="flat" cmpd="sng" algn="ctr">
-                      <a:solidFill>
-                        <a:srgbClr val="028090"/>
-                      </a:solidFill>
-                      <a:prstDash val="solid"/>
-                      <a:round/>
-                      <a:headEnd type="none" w="med" len="med"/>
-                      <a:tailEnd type="none" w="med" len="med"/>
-                    </a:lnT>
-                    <a:lnB w="6350" cap="flat" cmpd="sng" algn="ctr">
-                      <a:solidFill>
-                        <a:srgbClr val="028090"/>
-                      </a:solidFill>
-                      <a:prstDash val="solid"/>
-                      <a:round/>
-                      <a:headEnd type="none" w="med" len="med"/>
-                      <a:tailEnd type="none" w="med" len="med"/>
-                    </a:lnB>
-                    <a:solidFill>
-                      <a:srgbClr val="022C33"/>
-                    </a:solidFill>
-                  </a:tcPr>
-                </a:tc>
-                <a:tc>
-                  <a:txBody>
-                    <a:bodyPr/>
-                    <a:lstStyle/>
-                    <a:p>
-                      <a:pPr algn="ctr" indent="0" marL="0">
-                        <a:buNone/>
-                      </a:pPr>
-                      <a:r>
-                        <a:rPr lang="en-US" sz="1100" b="1" dirty="0">
-                          <a:solidFill>
-                            <a:srgbClr val="02C39A"/>
-                          </a:solidFill>
-                          <a:latin typeface="Calibri" pitchFamily="34" charset="0"/>
-                          <a:ea typeface="Calibri" pitchFamily="34" charset="-122"/>
-                          <a:cs typeface="Calibri" pitchFamily="34" charset="-120"/>
-                        </a:rPr>
-                        <a:t>0.927</a:t>
-                      </a:r>
-                      <a:endParaRPr lang="en-US" sz="1100" dirty="0">
-                        <a:latin typeface="Calibri" charset="0"/>
-                        <a:ea typeface="Calibri" charset="0"/>
-                        <a:cs typeface="Calibri" charset="0"/>
-                      </a:endParaRPr>
-                    </a:p>
-                  </a:txBody>
-                  <a:tcPr marL="91440" marR="91440" marT="45720" marB="45720">
-                    <a:lnL w="6350" cap="flat" cmpd="sng" algn="ctr">
-                      <a:solidFill>
-                        <a:srgbClr val="028090"/>
-                      </a:solidFill>
-                      <a:prstDash val="solid"/>
-                      <a:round/>
-                      <a:headEnd type="none" w="med" len="med"/>
-                      <a:tailEnd type="none" w="med" len="med"/>
-                    </a:lnL>
-                    <a:lnR w="6350" cap="flat" cmpd="sng" algn="ctr">
-                      <a:solidFill>
-                        <a:srgbClr val="028090"/>
-                      </a:solidFill>
-                      <a:prstDash val="solid"/>
-                      <a:round/>
-                      <a:headEnd type="none" w="med" len="med"/>
-                      <a:tailEnd type="none" w="med" len="med"/>
-                    </a:lnR>
-                    <a:lnT w="6350" cap="flat" cmpd="sng" algn="ctr">
-                      <a:solidFill>
-                        <a:srgbClr val="028090"/>
-                      </a:solidFill>
-                      <a:prstDash val="solid"/>
-                      <a:round/>
-                      <a:headEnd type="none" w="med" len="med"/>
-                      <a:tailEnd type="none" w="med" len="med"/>
-                    </a:lnT>
-                    <a:lnB w="6350" cap="flat" cmpd="sng" algn="ctr">
-                      <a:solidFill>
-                        <a:srgbClr val="028090"/>
-                      </a:solidFill>
-                      <a:prstDash val="solid"/>
-                      <a:round/>
-                      <a:headEnd type="none" w="med" len="med"/>
-                      <a:tailEnd type="none" w="med" len="med"/>
-                    </a:lnB>
-                    <a:solidFill>
-                      <a:srgbClr val="022C33"/>
-                    </a:solidFill>
-                  </a:tcPr>
-                </a:tc>
-                <a:tc>
-                  <a:txBody>
-                    <a:bodyPr/>
-                    <a:lstStyle/>
-                    <a:p>
-                      <a:pPr algn="ctr" indent="0" marL="0">
-                        <a:buNone/>
-                      </a:pPr>
-                      <a:r>
-                        <a:rPr lang="en-US" sz="1100" b="1" dirty="0">
-                          <a:solidFill>
-                            <a:srgbClr val="02C39A"/>
-                          </a:solidFill>
-                          <a:latin typeface="Calibri" pitchFamily="34" charset="0"/>
-                          <a:ea typeface="Calibri" pitchFamily="34" charset="-122"/>
-                          <a:cs typeface="Calibri" pitchFamily="34" charset="-120"/>
-                        </a:rPr>
-                        <a:t>0.879</a:t>
-                      </a:r>
-                      <a:endParaRPr lang="en-US" sz="1100" dirty="0">
-                        <a:latin typeface="Calibri" charset="0"/>
-                        <a:ea typeface="Calibri" charset="0"/>
-                        <a:cs typeface="Calibri" charset="0"/>
-                      </a:endParaRPr>
-                    </a:p>
-                  </a:txBody>
-                  <a:tcPr marL="91440" marR="91440" marT="45720" marB="45720">
-                    <a:lnL w="6350" cap="flat" cmpd="sng" algn="ctr">
-                      <a:solidFill>
-                        <a:srgbClr val="028090"/>
-                      </a:solidFill>
-                      <a:prstDash val="solid"/>
-                      <a:round/>
-                      <a:headEnd type="none" w="med" len="med"/>
-                      <a:tailEnd type="none" w="med" len="med"/>
-                    </a:lnL>
-                    <a:lnR w="6350" cap="flat" cmpd="sng" algn="ctr">
-                      <a:solidFill>
-                        <a:srgbClr val="028090"/>
-                      </a:solidFill>
-                      <a:prstDash val="solid"/>
-                      <a:round/>
-                      <a:headEnd type="none" w="med" len="med"/>
-                      <a:tailEnd type="none" w="med" len="med"/>
-                    </a:lnR>
-                    <a:lnT w="6350" cap="flat" cmpd="sng" algn="ctr">
-                      <a:solidFill>
-                        <a:srgbClr val="028090"/>
-                      </a:solidFill>
-                      <a:prstDash val="solid"/>
-                      <a:round/>
-                      <a:headEnd type="none" w="med" len="med"/>
-                      <a:tailEnd type="none" w="med" len="med"/>
-                    </a:lnT>
-                    <a:lnB w="6350" cap="flat" cmpd="sng" algn="ctr">
-                      <a:solidFill>
-                        <a:srgbClr val="028090"/>
-                      </a:solidFill>
-                      <a:prstDash val="solid"/>
-                      <a:round/>
-                      <a:headEnd type="none" w="med" len="med"/>
-                      <a:tailEnd type="none" w="med" len="med"/>
-                    </a:lnB>
-                    <a:solidFill>
-                      <a:srgbClr val="022C33"/>
-                    </a:solidFill>
-                  </a:tcPr>
-                </a:tc>
-                <a:tc>
-                  <a:txBody>
-                    <a:bodyPr/>
-                    <a:lstStyle/>
-                    <a:p>
-                      <a:pPr algn="ctr" indent="0" marL="0">
-                        <a:buNone/>
-                      </a:pPr>
-                      <a:r>
-                        <a:rPr lang="en-US" sz="1100" b="1" dirty="0">
-                          <a:solidFill>
-                            <a:srgbClr val="02C39A"/>
-                          </a:solidFill>
-                          <a:latin typeface="Calibri" pitchFamily="34" charset="0"/>
-                          <a:ea typeface="Calibri" pitchFamily="34" charset="-122"/>
-                          <a:cs typeface="Calibri" pitchFamily="34" charset="-120"/>
-                        </a:rPr>
-                        <a:t>0.912</a:t>
-                      </a:r>
-                      <a:endParaRPr lang="en-US" sz="1100" dirty="0">
-                        <a:latin typeface="Calibri" charset="0"/>
-                        <a:ea typeface="Calibri" charset="0"/>
-                        <a:cs typeface="Calibri" charset="0"/>
-                      </a:endParaRPr>
-                    </a:p>
-                  </a:txBody>
-                  <a:tcPr marL="91440" marR="91440" marT="45720" marB="45720">
-                    <a:lnL w="6350" cap="flat" cmpd="sng" algn="ctr">
-                      <a:solidFill>
-                        <a:srgbClr val="028090"/>
-                      </a:solidFill>
-                      <a:prstDash val="solid"/>
-                      <a:round/>
-                      <a:headEnd type="none" w="med" len="med"/>
-                      <a:tailEnd type="none" w="med" len="med"/>
-                    </a:lnL>
-                    <a:lnR w="6350" cap="flat" cmpd="sng" algn="ctr">
-                      <a:solidFill>
-                        <a:srgbClr val="028090"/>
-                      </a:solidFill>
-                      <a:prstDash val="solid"/>
-                      <a:round/>
-                      <a:headEnd type="none" w="med" len="med"/>
-                      <a:tailEnd type="none" w="med" len="med"/>
-                    </a:lnR>
-                    <a:lnT w="6350" cap="flat" cmpd="sng" algn="ctr">
-                      <a:solidFill>
-                        <a:srgbClr val="028090"/>
-                      </a:solidFill>
-                      <a:prstDash val="solid"/>
-                      <a:round/>
-                      <a:headEnd type="none" w="med" len="med"/>
-                      <a:tailEnd type="none" w="med" len="med"/>
-                    </a:lnT>
-                    <a:lnB w="6350" cap="flat" cmpd="sng" algn="ctr">
-                      <a:solidFill>
-                        <a:srgbClr val="028090"/>
-                      </a:solidFill>
-                      <a:prstDash val="solid"/>
-                      <a:round/>
-                      <a:headEnd type="none" w="med" len="med"/>
-                      <a:tailEnd type="none" w="med" len="med"/>
-                    </a:lnB>
-                    <a:solidFill>
-                      <a:srgbClr val="022C33"/>
-                    </a:solidFill>
-                  </a:tcPr>
-                </a:tc>
-                <a:tc>
-                  <a:txBody>
-                    <a:bodyPr/>
-                    <a:lstStyle/>
-                    <a:p>
-                      <a:pPr algn="ctr" indent="0" marL="0">
-                        <a:buNone/>
-                      </a:pPr>
-                      <a:r>
-                        <a:rPr lang="en-US" sz="1100" b="1" dirty="0">
-                          <a:solidFill>
-                            <a:srgbClr val="02C39A"/>
-                          </a:solidFill>
-                          <a:latin typeface="Calibri" pitchFamily="34" charset="0"/>
-                          <a:ea typeface="Calibri" pitchFamily="34" charset="-122"/>
-                          <a:cs typeface="Calibri" pitchFamily="34" charset="-120"/>
-                        </a:rPr>
-                        <a:t>0.906</a:t>
-                      </a:r>
-                      <a:endParaRPr lang="en-US" sz="1100" dirty="0">
-                        <a:latin typeface="Calibri" charset="0"/>
-                        <a:ea typeface="Calibri" charset="0"/>
-                        <a:cs typeface="Calibri" charset="0"/>
-                      </a:endParaRPr>
-                    </a:p>
-                  </a:txBody>
-                  <a:tcPr marL="91440" marR="91440" marT="45720" marB="45720">
-                    <a:lnL w="6350" cap="flat" cmpd="sng" algn="ctr">
-                      <a:solidFill>
-                        <a:srgbClr val="028090"/>
-                      </a:solidFill>
-                      <a:prstDash val="solid"/>
-                      <a:round/>
-                      <a:headEnd type="none" w="med" len="med"/>
-                      <a:tailEnd type="none" w="med" len="med"/>
-                    </a:lnL>
-                    <a:lnR w="6350" cap="flat" cmpd="sng" algn="ctr">
-                      <a:solidFill>
-                        <a:srgbClr val="028090"/>
-                      </a:solidFill>
-                      <a:prstDash val="solid"/>
-                      <a:round/>
-                      <a:headEnd type="none" w="med" len="med"/>
-                      <a:tailEnd type="none" w="med" len="med"/>
-                    </a:lnR>
-                    <a:lnT w="6350" cap="flat" cmpd="sng" algn="ctr">
-                      <a:solidFill>
-                        <a:srgbClr val="028090"/>
-                      </a:solidFill>
-                      <a:prstDash val="solid"/>
-                      <a:round/>
-                      <a:headEnd type="none" w="med" len="med"/>
-                      <a:tailEnd type="none" w="med" len="med"/>
-                    </a:lnT>
-                    <a:lnB w="6350" cap="flat" cmpd="sng" algn="ctr">
-                      <a:solidFill>
-                        <a:srgbClr val="028090"/>
-                      </a:solidFill>
-                      <a:prstDash val="solid"/>
-                      <a:round/>
-                      <a:headEnd type="none" w="med" len="med"/>
-                      <a:tailEnd type="none" w="med" len="med"/>
-                    </a:lnB>
-                    <a:solidFill>
-                      <a:srgbClr val="022C33"/>
-                    </a:solidFill>
-                  </a:tcPr>
-                </a:tc>
-              </a:tr>
-              <a:tr h="347472">
-                <a:tc>
-                  <a:txBody>
-                    <a:bodyPr/>
-                    <a:lstStyle/>
-                    <a:p>
-                      <a:pPr indent="0" marL="0">
-                        <a:buNone/>
-                      </a:pPr>
-                      <a:r>
-                        <a:rPr lang="en-US" sz="1100" dirty="0">
-                          <a:solidFill>
-                            <a:srgbClr val="5A8087"/>
-                          </a:solidFill>
-                          <a:latin typeface="Calibri" pitchFamily="34" charset="0"/>
-                          <a:ea typeface="Calibri" pitchFamily="34" charset="-122"/>
-                          <a:cs typeface="Calibri" pitchFamily="34" charset="-120"/>
-                        </a:rPr>
-                        <a:t>docs/ (baseline)</a:t>
-                      </a:r>
-                      <a:endParaRPr lang="en-US" sz="1100" dirty="0">
-                        <a:latin typeface="Calibri" charset="0"/>
-                        <a:ea typeface="Calibri" charset="0"/>
-                        <a:cs typeface="Calibri" charset="0"/>
-                      </a:endParaRPr>
-                    </a:p>
-                  </a:txBody>
-                  <a:tcPr marL="91440" marR="91440" marT="45720" marB="45720">
-                    <a:lnL w="6350" cap="flat" cmpd="sng" algn="ctr">
-                      <a:solidFill>
-                        <a:srgbClr val="028090"/>
-                      </a:solidFill>
-                      <a:prstDash val="solid"/>
-                      <a:round/>
-                      <a:headEnd type="none" w="med" len="med"/>
-                      <a:tailEnd type="none" w="med" len="med"/>
-                    </a:lnL>
-                    <a:lnR w="6350" cap="flat" cmpd="sng" algn="ctr">
-                      <a:solidFill>
-                        <a:srgbClr val="028090"/>
-                      </a:solidFill>
-                      <a:prstDash val="solid"/>
-                      <a:round/>
-                      <a:headEnd type="none" w="med" len="med"/>
-                      <a:tailEnd type="none" w="med" len="med"/>
-                    </a:lnR>
-                    <a:lnT w="6350" cap="flat" cmpd="sng" algn="ctr">
-                      <a:solidFill>
-                        <a:srgbClr val="028090"/>
-                      </a:solidFill>
-                      <a:prstDash val="solid"/>
-                      <a:round/>
-                      <a:headEnd type="none" w="med" len="med"/>
-                      <a:tailEnd type="none" w="med" len="med"/>
-                    </a:lnT>
-                    <a:lnB w="6350" cap="flat" cmpd="sng" algn="ctr">
-                      <a:solidFill>
-                        <a:srgbClr val="028090"/>
-                      </a:solidFill>
-                      <a:prstDash val="solid"/>
-                      <a:round/>
-                      <a:headEnd type="none" w="med" len="med"/>
-                      <a:tailEnd type="none" w="med" len="med"/>
-                    </a:lnB>
-                    <a:solidFill>
-                      <a:srgbClr val="EFF6F6"/>
-                    </a:solidFill>
-                  </a:tcPr>
-                </a:tc>
-                <a:tc>
-                  <a:txBody>
-                    <a:bodyPr/>
-                    <a:lstStyle/>
-                    <a:p>
-                      <a:pPr algn="ctr" indent="0" marL="0">
-                        <a:buNone/>
-                      </a:pPr>
-                      <a:r>
-                        <a:rPr lang="en-US" sz="1100" dirty="0">
-                          <a:solidFill>
-                            <a:srgbClr val="5A8087"/>
-                          </a:solidFill>
-                          <a:latin typeface="Calibri" pitchFamily="34" charset="0"/>
-                          <a:ea typeface="Calibri" pitchFamily="34" charset="-122"/>
-                          <a:cs typeface="Calibri" pitchFamily="34" charset="-120"/>
-                        </a:rPr>
-                        <a:t>0.924</a:t>
-                      </a:r>
-                      <a:endParaRPr lang="en-US" sz="1100" dirty="0">
-                        <a:latin typeface="Calibri" charset="0"/>
-                        <a:ea typeface="Calibri" charset="0"/>
-                        <a:cs typeface="Calibri" charset="0"/>
-                      </a:endParaRPr>
-                    </a:p>
-                  </a:txBody>
-                  <a:tcPr marL="91440" marR="91440" marT="45720" marB="45720">
-                    <a:lnL w="6350" cap="flat" cmpd="sng" algn="ctr">
-                      <a:solidFill>
-                        <a:srgbClr val="028090"/>
-                      </a:solidFill>
-                      <a:prstDash val="solid"/>
-                      <a:round/>
-                      <a:headEnd type="none" w="med" len="med"/>
-                      <a:tailEnd type="none" w="med" len="med"/>
-                    </a:lnL>
-                    <a:lnR w="6350" cap="flat" cmpd="sng" algn="ctr">
-                      <a:solidFill>
-                        <a:srgbClr val="028090"/>
-                      </a:solidFill>
-                      <a:prstDash val="solid"/>
-                      <a:round/>
-                      <a:headEnd type="none" w="med" len="med"/>
-                      <a:tailEnd type="none" w="med" len="med"/>
-                    </a:lnR>
-                    <a:lnT w="6350" cap="flat" cmpd="sng" algn="ctr">
-                      <a:solidFill>
-                        <a:srgbClr val="028090"/>
-                      </a:solidFill>
-                      <a:prstDash val="solid"/>
-                      <a:round/>
-                      <a:headEnd type="none" w="med" len="med"/>
-                      <a:tailEnd type="none" w="med" len="med"/>
-                    </a:lnT>
-                    <a:lnB w="6350" cap="flat" cmpd="sng" algn="ctr">
-                      <a:solidFill>
-                        <a:srgbClr val="028090"/>
-                      </a:solidFill>
-                      <a:prstDash val="solid"/>
-                      <a:round/>
-                      <a:headEnd type="none" w="med" len="med"/>
-                      <a:tailEnd type="none" w="med" len="med"/>
-                    </a:lnB>
-                    <a:solidFill>
-                      <a:srgbClr val="EFF6F6"/>
-                    </a:solidFill>
-                  </a:tcPr>
-                </a:tc>
-                <a:tc>
-                  <a:txBody>
-                    <a:bodyPr/>
-                    <a:lstStyle/>
-                    <a:p>
-                      <a:pPr algn="ctr" indent="0" marL="0">
-                        <a:buNone/>
-                      </a:pPr>
-                      <a:r>
-                        <a:rPr lang="en-US" sz="1100" dirty="0">
-                          <a:solidFill>
-                            <a:srgbClr val="5A8087"/>
-                          </a:solidFill>
-                          <a:latin typeface="Calibri" pitchFamily="34" charset="0"/>
-                          <a:ea typeface="Calibri" pitchFamily="34" charset="-122"/>
-                          <a:cs typeface="Calibri" pitchFamily="34" charset="-120"/>
-                        </a:rPr>
-                        <a:t>0.860</a:t>
-                      </a:r>
-                      <a:endParaRPr lang="en-US" sz="1100" dirty="0">
-                        <a:latin typeface="Calibri" charset="0"/>
-                        <a:ea typeface="Calibri" charset="0"/>
-                        <a:cs typeface="Calibri" charset="0"/>
-                      </a:endParaRPr>
-                    </a:p>
-                  </a:txBody>
-                  <a:tcPr marL="91440" marR="91440" marT="45720" marB="45720">
-                    <a:lnL w="6350" cap="flat" cmpd="sng" algn="ctr">
-                      <a:solidFill>
-                        <a:srgbClr val="028090"/>
-                      </a:solidFill>
-                      <a:prstDash val="solid"/>
-                      <a:round/>
-                      <a:headEnd type="none" w="med" len="med"/>
-                      <a:tailEnd type="none" w="med" len="med"/>
-                    </a:lnL>
-                    <a:lnR w="6350" cap="flat" cmpd="sng" algn="ctr">
-                      <a:solidFill>
-                        <a:srgbClr val="028090"/>
-                      </a:solidFill>
-                      <a:prstDash val="solid"/>
-                      <a:round/>
-                      <a:headEnd type="none" w="med" len="med"/>
-                      <a:tailEnd type="none" w="med" len="med"/>
-                    </a:lnR>
-                    <a:lnT w="6350" cap="flat" cmpd="sng" algn="ctr">
-                      <a:solidFill>
-                        <a:srgbClr val="028090"/>
-                      </a:solidFill>
-                      <a:prstDash val="solid"/>
-                      <a:round/>
-                      <a:headEnd type="none" w="med" len="med"/>
-                      <a:tailEnd type="none" w="med" len="med"/>
-                    </a:lnT>
-                    <a:lnB w="6350" cap="flat" cmpd="sng" algn="ctr">
-                      <a:solidFill>
-                        <a:srgbClr val="028090"/>
-                      </a:solidFill>
-                      <a:prstDash val="solid"/>
-                      <a:round/>
-                      <a:headEnd type="none" w="med" len="med"/>
-                      <a:tailEnd type="none" w="med" len="med"/>
-                    </a:lnB>
-                    <a:solidFill>
-                      <a:srgbClr val="EFF6F6"/>
-                    </a:solidFill>
-                  </a:tcPr>
-                </a:tc>
-                <a:tc>
-                  <a:txBody>
-                    <a:bodyPr/>
-                    <a:lstStyle/>
-                    <a:p>
-                      <a:pPr algn="ctr" indent="0" marL="0">
-                        <a:buNone/>
-                      </a:pPr>
-                      <a:r>
-                        <a:rPr lang="en-US" sz="1100" dirty="0">
-                          <a:solidFill>
-                            <a:srgbClr val="5A8087"/>
-                          </a:solidFill>
-                          <a:latin typeface="Calibri" pitchFamily="34" charset="0"/>
-                          <a:ea typeface="Calibri" pitchFamily="34" charset="-122"/>
-                          <a:cs typeface="Calibri" pitchFamily="34" charset="-120"/>
-                        </a:rPr>
-                        <a:t>0.931</a:t>
-                      </a:r>
-                      <a:endParaRPr lang="en-US" sz="1100" dirty="0">
-                        <a:latin typeface="Calibri" charset="0"/>
-                        <a:ea typeface="Calibri" charset="0"/>
-                        <a:cs typeface="Calibri" charset="0"/>
-                      </a:endParaRPr>
-                    </a:p>
-                  </a:txBody>
-                  <a:tcPr marL="91440" marR="91440" marT="45720" marB="45720">
-                    <a:lnL w="6350" cap="flat" cmpd="sng" algn="ctr">
-                      <a:solidFill>
-                        <a:srgbClr val="028090"/>
-                      </a:solidFill>
-                      <a:prstDash val="solid"/>
-                      <a:round/>
-                      <a:headEnd type="none" w="med" len="med"/>
-                      <a:tailEnd type="none" w="med" len="med"/>
-                    </a:lnL>
-                    <a:lnR w="6350" cap="flat" cmpd="sng" algn="ctr">
-                      <a:solidFill>
-                        <a:srgbClr val="028090"/>
-                      </a:solidFill>
-                      <a:prstDash val="solid"/>
-                      <a:round/>
-                      <a:headEnd type="none" w="med" len="med"/>
-                      <a:tailEnd type="none" w="med" len="med"/>
-                    </a:lnR>
-                    <a:lnT w="6350" cap="flat" cmpd="sng" algn="ctr">
-                      <a:solidFill>
-                        <a:srgbClr val="028090"/>
-                      </a:solidFill>
-                      <a:prstDash val="solid"/>
-                      <a:round/>
-                      <a:headEnd type="none" w="med" len="med"/>
-                      <a:tailEnd type="none" w="med" len="med"/>
-                    </a:lnT>
-                    <a:lnB w="6350" cap="flat" cmpd="sng" algn="ctr">
-                      <a:solidFill>
-                        <a:srgbClr val="028090"/>
-                      </a:solidFill>
-                      <a:prstDash val="solid"/>
-                      <a:round/>
-                      <a:headEnd type="none" w="med" len="med"/>
-                      <a:tailEnd type="none" w="med" len="med"/>
-                    </a:lnB>
-                    <a:solidFill>
-                      <a:srgbClr val="EFF6F6"/>
-                    </a:solidFill>
-                  </a:tcPr>
-                </a:tc>
-                <a:tc>
-                  <a:txBody>
-                    <a:bodyPr/>
-                    <a:lstStyle/>
-                    <a:p>
-                      <a:pPr algn="ctr" indent="0" marL="0">
-                        <a:buNone/>
-                      </a:pPr>
-                      <a:r>
-                        <a:rPr lang="en-US" sz="1100" dirty="0">
-                          <a:solidFill>
-                            <a:srgbClr val="5A8087"/>
-                          </a:solidFill>
-                          <a:latin typeface="Calibri" pitchFamily="34" charset="0"/>
-                          <a:ea typeface="Calibri" pitchFamily="34" charset="-122"/>
-                          <a:cs typeface="Calibri" pitchFamily="34" charset="-120"/>
-                        </a:rPr>
-                        <a:t>0.904</a:t>
-                      </a:r>
-                      <a:endParaRPr lang="en-US" sz="1100" dirty="0">
-                        <a:latin typeface="Calibri" charset="0"/>
-                        <a:ea typeface="Calibri" charset="0"/>
-                        <a:cs typeface="Calibri" charset="0"/>
-                      </a:endParaRPr>
-                    </a:p>
-                  </a:txBody>
-                  <a:tcPr marL="91440" marR="91440" marT="45720" marB="45720">
-                    <a:lnL w="6350" cap="flat" cmpd="sng" algn="ctr">
-                      <a:solidFill>
-                        <a:srgbClr val="028090"/>
-                      </a:solidFill>
-                      <a:prstDash val="solid"/>
-                      <a:round/>
-                      <a:headEnd type="none" w="med" len="med"/>
-                      <a:tailEnd type="none" w="med" len="med"/>
-                    </a:lnL>
-                    <a:lnR w="6350" cap="flat" cmpd="sng" algn="ctr">
-                      <a:solidFill>
-                        <a:srgbClr val="028090"/>
-                      </a:solidFill>
-                      <a:prstDash val="solid"/>
-                      <a:round/>
-                      <a:headEnd type="none" w="med" len="med"/>
-                      <a:tailEnd type="none" w="med" len="med"/>
-                    </a:lnR>
-                    <a:lnT w="6350" cap="flat" cmpd="sng" algn="ctr">
-                      <a:solidFill>
-                        <a:srgbClr val="028090"/>
-                      </a:solidFill>
-                      <a:prstDash val="solid"/>
-                      <a:round/>
-                      <a:headEnd type="none" w="med" len="med"/>
-                      <a:tailEnd type="none" w="med" len="med"/>
-                    </a:lnT>
-                    <a:lnB w="6350" cap="flat" cmpd="sng" algn="ctr">
-                      <a:solidFill>
-                        <a:srgbClr val="028090"/>
-                      </a:solidFill>
-                      <a:prstDash val="solid"/>
-                      <a:round/>
-                      <a:headEnd type="none" w="med" len="med"/>
-                      <a:tailEnd type="none" w="med" len="med"/>
-                    </a:lnB>
-                    <a:solidFill>
-                      <a:srgbClr val="EFF6F6"/>
-                    </a:solidFill>
-                  </a:tcPr>
-                </a:tc>
-              </a:tr>
             </a:tbl>
           </a:graphicData>
         </a:graphic>
@@ -13101,7 +12431,7 @@
         </p:nvSpPr>
         <p:spPr>
           <a:xfrm>
-            <a:off x="320040" y="3017520"/>
+            <a:off x="320040" y="3218688"/>
             <a:ext cx="5166360" cy="310896"/>
           </a:xfrm>
           <a:prstGeom prst="rect">
@@ -13140,7 +12470,7 @@
         </p:nvSpPr>
         <p:spPr>
           <a:xfrm>
-            <a:off x="320040" y="3401568"/>
+            <a:off x="320040" y="3602736"/>
             <a:ext cx="5166360" cy="320040"/>
           </a:xfrm>
           <a:prstGeom prst="rect">
@@ -13165,7 +12495,7 @@
         </p:nvSpPr>
         <p:spPr>
           <a:xfrm>
-            <a:off x="438912" y="3447288"/>
+            <a:off x="438912" y="3648456"/>
             <a:ext cx="347472" cy="228600"/>
           </a:xfrm>
           <a:prstGeom prst="rect">
@@ -13204,7 +12534,7 @@
         </p:nvSpPr>
         <p:spPr>
           <a:xfrm>
-            <a:off x="822960" y="3447288"/>
+            <a:off x="822960" y="3648456"/>
             <a:ext cx="1234440" cy="228600"/>
           </a:xfrm>
           <a:prstGeom prst="rect">
@@ -13243,7 +12573,7 @@
         </p:nvSpPr>
         <p:spPr>
           <a:xfrm>
-            <a:off x="2084832" y="3456432"/>
+            <a:off x="2084832" y="3657600"/>
             <a:ext cx="3291840" cy="210312"/>
           </a:xfrm>
           <a:prstGeom prst="rect">
@@ -13268,7 +12598,7 @@
                 <a:ea typeface="Calibri" pitchFamily="34" charset="-122"/>
                 <a:cs typeface="Calibri" pitchFamily="34" charset="-120"/>
               </a:rPr>
-              <a:t>docs-vnext (0.906) vs docs/ (0.904), δ=+0.002</a:t>
+              <a:t>docs-vnext (0.863) vs docs/ (0.855), δ=+0.008</a:t>
             </a:r>
             <a:endParaRPr lang="en-US" sz="950" dirty="0"/>
           </a:p>
@@ -13282,7 +12612,7 @@
         </p:nvSpPr>
         <p:spPr>
           <a:xfrm>
-            <a:off x="320040" y="3794760"/>
+            <a:off x="320040" y="3995928"/>
             <a:ext cx="5166360" cy="320040"/>
           </a:xfrm>
           <a:prstGeom prst="rect">
@@ -13307,7 +12637,7 @@
         </p:nvSpPr>
         <p:spPr>
           <a:xfrm>
-            <a:off x="438912" y="3840480"/>
+            <a:off x="438912" y="4041648"/>
             <a:ext cx="347472" cy="228600"/>
           </a:xfrm>
           <a:prstGeom prst="rect">
@@ -13346,7 +12676,7 @@
         </p:nvSpPr>
         <p:spPr>
           <a:xfrm>
-            <a:off x="822960" y="3840480"/>
+            <a:off x="822960" y="4041648"/>
             <a:ext cx="1234440" cy="228600"/>
           </a:xfrm>
           <a:prstGeom prst="rect">
@@ -13365,13 +12695,13 @@
             <a:r>
               <a:rPr lang="en-US" sz="1000" b="1" dirty="0">
                 <a:solidFill>
-                  <a:srgbClr val="C04040"/>
+                  <a:srgbClr val="C9A800"/>
                 </a:solidFill>
                 <a:latin typeface="Trebuchet MS" pitchFamily="34" charset="0"/>
                 <a:ea typeface="Trebuchet MS" pitchFamily="34" charset="-122"/>
                 <a:cs typeface="Trebuchet MS" pitchFamily="34" charset="-120"/>
               </a:rPr>
-              <a:t>❌ REJECTED</a:t>
+              <a:t>⚠️ MARGINAL</a:t>
             </a:r>
             <a:endParaRPr lang="en-US" sz="1000" dirty="0"/>
           </a:p>
@@ -13385,7 +12715,7 @@
         </p:nvSpPr>
         <p:spPr>
           <a:xfrm>
-            <a:off x="2084832" y="3849624"/>
+            <a:off x="2084832" y="4050792"/>
             <a:ext cx="3291840" cy="210312"/>
           </a:xfrm>
           <a:prstGeom prst="rect">
@@ -13410,7 +12740,7 @@
                 <a:ea typeface="Calibri" pitchFamily="34" charset="-122"/>
                 <a:cs typeface="Calibri" pitchFamily="34" charset="-120"/>
               </a:rPr>
-              <a:t>vs Mintlify MCP (0.908), δ=−0.002</a:t>
+              <a:t>vs Mintlify MCP (0.843), δ=+0.020</a:t>
             </a:r>
             <a:endParaRPr lang="en-US" sz="950" dirty="0"/>
           </a:p>
@@ -13424,7 +12754,7 @@
         </p:nvSpPr>
         <p:spPr>
           <a:xfrm>
-            <a:off x="320040" y="4187952"/>
+            <a:off x="320040" y="4389120"/>
             <a:ext cx="5166360" cy="320040"/>
           </a:xfrm>
           <a:prstGeom prst="rect">
@@ -13449,7 +12779,7 @@
         </p:nvSpPr>
         <p:spPr>
           <a:xfrm>
-            <a:off x="438912" y="4233672"/>
+            <a:off x="438912" y="4434840"/>
             <a:ext cx="347472" cy="228600"/>
           </a:xfrm>
           <a:prstGeom prst="rect">
@@ -13488,7 +12818,7 @@
         </p:nvSpPr>
         <p:spPr>
           <a:xfrm>
-            <a:off x="822960" y="4233672"/>
+            <a:off x="822960" y="4434840"/>
             <a:ext cx="1234440" cy="228600"/>
           </a:xfrm>
           <a:prstGeom prst="rect">
@@ -13527,7 +12857,7 @@
         </p:nvSpPr>
         <p:spPr>
           <a:xfrm>
-            <a:off x="2084832" y="4242816"/>
+            <a:off x="2084832" y="4443984"/>
             <a:ext cx="3291840" cy="210312"/>
           </a:xfrm>
           <a:prstGeom prst="rect">
@@ -13552,7 +12882,7 @@
                 <a:ea typeface="Calibri" pitchFamily="34" charset="-122"/>
                 <a:cs typeface="Calibri" pitchFamily="34" charset="-120"/>
               </a:rPr>
-              <a:t>vs MS Learn (0.908), δ=−0.002</a:t>
+              <a:t>vs MS Learn (0.873), δ=−0.010</a:t>
             </a:r>
             <a:endParaRPr lang="en-US" sz="950" dirty="0"/>
           </a:p>
@@ -13566,7 +12896,7 @@
         </p:nvSpPr>
         <p:spPr>
           <a:xfrm>
-            <a:off x="320040" y="4581144"/>
+            <a:off x="320040" y="4782312"/>
             <a:ext cx="5166360" cy="320040"/>
           </a:xfrm>
           <a:prstGeom prst="rect">
@@ -13591,7 +12921,7 @@
         </p:nvSpPr>
         <p:spPr>
           <a:xfrm>
-            <a:off x="438912" y="4626864"/>
+            <a:off x="438912" y="4828032"/>
             <a:ext cx="347472" cy="228600"/>
           </a:xfrm>
           <a:prstGeom prst="rect">
@@ -13630,7 +12960,7 @@
         </p:nvSpPr>
         <p:spPr>
           <a:xfrm>
-            <a:off x="822960" y="4626864"/>
+            <a:off x="822960" y="4828032"/>
             <a:ext cx="1234440" cy="228600"/>
           </a:xfrm>
           <a:prstGeom prst="rect">
@@ -13649,13 +12979,13 @@
             <a:r>
               <a:rPr lang="en-US" sz="1000" b="1" dirty="0">
                 <a:solidFill>
-                  <a:srgbClr val="C9A800"/>
+                  <a:srgbClr val="00A896"/>
                 </a:solidFill>
                 <a:latin typeface="Trebuchet MS" pitchFamily="34" charset="0"/>
                 <a:ea typeface="Trebuchet MS" pitchFamily="34" charset="-122"/>
                 <a:cs typeface="Trebuchet MS" pitchFamily="34" charset="-120"/>
               </a:rPr>
-              <a:t>⚠️ MIXED</a:t>
+              <a:t>✅ SUPPORTED</a:t>
             </a:r>
             <a:endParaRPr lang="en-US" sz="1000" dirty="0"/>
           </a:p>
@@ -13669,7 +12999,7 @@
         </p:nvSpPr>
         <p:spPr>
           <a:xfrm>
-            <a:off x="2084832" y="4636008"/>
+            <a:off x="2084832" y="4837176"/>
             <a:ext cx="3291840" cy="210312"/>
           </a:xfrm>
           <a:prstGeom prst="rect">
@@ -13694,7 +13024,7 @@
                 <a:ea typeface="Calibri" pitchFamily="34" charset="-122"/>
                 <a:cs typeface="Calibri" pitchFamily="34" charset="-120"/>
               </a:rPr>
-              <a:t>Rankings vary: gpt-5.3 ranks docs-vnext 2nd</a:t>
+              <a:t>Rankings consistent (single-model run)</a:t>
             </a:r>
             <a:endParaRPr lang="en-US" sz="950" dirty="0"/>
           </a:p>
@@ -13812,7 +13142,135 @@
         <p:spPr>
           <a:xfrm>
             <a:off x="5687568" y="1828800"/>
-            <a:ext cx="2505822" cy="256032"/>
+            <a:ext cx="827715" cy="256032"/>
+          </a:xfrm>
+          <a:prstGeom prst="rect">
+            <a:avLst/>
+          </a:prstGeom>
+          <a:solidFill>
+            <a:srgbClr val="5A8087"/>
+          </a:solidFill>
+          <a:ln w="12700">
+            <a:solidFill>
+              <a:srgbClr val="5A8087"/>
+            </a:solidFill>
+            <a:prstDash val="solid"/>
+          </a:ln>
+        </p:spPr>
+      </p:sp>
+      <p:sp>
+        <p:nvSpPr>
+          <p:cNvPr id="27" name="Text 24"/>
+          <p:cNvSpPr/>
+          <p:nvPr/>
+        </p:nvSpPr>
+        <p:spPr>
+          <a:xfrm>
+            <a:off x="8595360" y="1828800"/>
+            <a:ext cx="502920" cy="256032"/>
+          </a:xfrm>
+          <a:prstGeom prst="rect">
+            <a:avLst/>
+          </a:prstGeom>
+          <a:noFill/>
+          <a:ln/>
+        </p:spPr>
+        <p:txBody>
+          <a:bodyPr wrap="square" lIns="0" tIns="0" rIns="0" bIns="0" rtlCol="0" anchor="ctr"/>
+          <a:lstStyle/>
+          <a:p>
+            <a:pPr indent="0" marL="0">
+              <a:buNone/>
+            </a:pPr>
+            <a:r>
+              <a:rPr lang="en-US" sz="900" dirty="0">
+                <a:solidFill>
+                  <a:srgbClr val="5A8087"/>
+                </a:solidFill>
+                <a:latin typeface="Calibri" pitchFamily="34" charset="0"/>
+                <a:ea typeface="Calibri" pitchFamily="34" charset="-122"/>
+                <a:cs typeface="Calibri" pitchFamily="34" charset="-120"/>
+              </a:rPr>
+              <a:t>0.823 —</a:t>
+            </a:r>
+            <a:endParaRPr lang="en-US" sz="900" dirty="0"/>
+          </a:p>
+        </p:txBody>
+      </p:sp>
+      <p:sp>
+        <p:nvSpPr>
+          <p:cNvPr id="28" name="Text 25"/>
+          <p:cNvSpPr/>
+          <p:nvPr/>
+        </p:nvSpPr>
+        <p:spPr>
+          <a:xfrm>
+            <a:off x="5687568" y="2231136"/>
+            <a:ext cx="3108960" cy="228600"/>
+          </a:xfrm>
+          <a:prstGeom prst="rect">
+            <a:avLst/>
+          </a:prstGeom>
+          <a:noFill/>
+          <a:ln/>
+        </p:spPr>
+        <p:txBody>
+          <a:bodyPr wrap="square" lIns="0" tIns="0" rIns="0" bIns="0" rtlCol="0" anchor="ctr"/>
+          <a:lstStyle/>
+          <a:p>
+            <a:pPr indent="0" marL="0">
+              <a:buNone/>
+            </a:pPr>
+            <a:r>
+              <a:rPr lang="en-US" sz="950" dirty="0">
+                <a:solidFill>
+                  <a:srgbClr val="B8DADD"/>
+                </a:solidFill>
+                <a:latin typeface="Consolas" pitchFamily="34" charset="0"/>
+                <a:ea typeface="Consolas" pitchFamily="34" charset="-122"/>
+                <a:cs typeface="Consolas" pitchFamily="34" charset="-120"/>
+              </a:rPr>
+              <a:t>getting-started</a:t>
+            </a:r>
+            <a:endParaRPr lang="en-US" sz="950" dirty="0"/>
+          </a:p>
+        </p:txBody>
+      </p:sp>
+      <p:sp>
+        <p:nvSpPr>
+          <p:cNvPr id="29" name="Shape 26"/>
+          <p:cNvSpPr/>
+          <p:nvPr/>
+        </p:nvSpPr>
+        <p:spPr>
+          <a:xfrm>
+            <a:off x="5687568" y="2487168"/>
+            <a:ext cx="2834640" cy="256032"/>
+          </a:xfrm>
+          <a:prstGeom prst="rect">
+            <a:avLst/>
+          </a:prstGeom>
+          <a:solidFill>
+            <a:srgbClr val="022C33"/>
+          </a:solidFill>
+          <a:ln w="12700">
+            <a:solidFill>
+              <a:srgbClr val="028090"/>
+            </a:solidFill>
+            <a:prstDash val="solid"/>
+          </a:ln>
+        </p:spPr>
+      </p:sp>
+      <p:sp>
+        <p:nvSpPr>
+          <p:cNvPr id="30" name="Shape 27"/>
+          <p:cNvSpPr/>
+          <p:nvPr/>
+        </p:nvSpPr>
+        <p:spPr>
+          <a:xfrm>
+            <a:off x="5687568" y="2487168"/>
+            <a:ext cx="1213226" cy="256032"/>
           </a:xfrm>
           <a:prstGeom prst="rect">
             <a:avLst/>
@@ -13830,13 +13288,13 @@
       </p:sp>
       <p:sp>
         <p:nvSpPr>
-          <p:cNvPr id="27" name="Text 24"/>
-          <p:cNvSpPr/>
-          <p:nvPr/>
-        </p:nvSpPr>
-        <p:spPr>
-          <a:xfrm>
-            <a:off x="8595360" y="1828800"/>
+          <p:cNvPr id="31" name="Text 28"/>
+          <p:cNvSpPr/>
+          <p:nvPr/>
+        </p:nvSpPr>
+        <p:spPr>
+          <a:xfrm>
+            <a:off x="8595360" y="2487168"/>
             <a:ext cx="502920" cy="256032"/>
           </a:xfrm>
           <a:prstGeom prst="rect">
@@ -13861,7 +13319,7 @@
                 <a:ea typeface="Calibri" pitchFamily="34" charset="-122"/>
                 <a:cs typeface="Calibri" pitchFamily="34" charset="-120"/>
               </a:rPr>
-              <a:t>0.971 ▲</a:t>
+              <a:t>0.857 ▲</a:t>
             </a:r>
             <a:endParaRPr lang="en-US" sz="900" dirty="0"/>
           </a:p>
@@ -13869,13 +13327,13 @@
       </p:sp>
       <p:sp>
         <p:nvSpPr>
-          <p:cNvPr id="28" name="Text 25"/>
-          <p:cNvSpPr/>
-          <p:nvPr/>
-        </p:nvSpPr>
-        <p:spPr>
-          <a:xfrm>
-            <a:off x="5687568" y="2231136"/>
+          <p:cNvPr id="32" name="Text 29"/>
+          <p:cNvSpPr/>
+          <p:nvPr/>
+        </p:nvSpPr>
+        <p:spPr>
+          <a:xfrm>
+            <a:off x="5687568" y="2889504"/>
             <a:ext cx="3108960" cy="228600"/>
           </a:xfrm>
           <a:prstGeom prst="rect">
@@ -13900,7 +13358,7 @@
                 <a:ea typeface="Consolas" pitchFamily="34" charset="-122"/>
                 <a:cs typeface="Consolas" pitchFamily="34" charset="-120"/>
               </a:rPr>
-              <a:t>getting-started</a:t>
+              <a:t>infra-security</a:t>
             </a:r>
             <a:endParaRPr lang="en-US" sz="950" dirty="0"/>
           </a:p>
@@ -13908,13 +13366,13 @@
       </p:sp>
       <p:sp>
         <p:nvSpPr>
-          <p:cNvPr id="29" name="Shape 26"/>
-          <p:cNvSpPr/>
-          <p:nvPr/>
-        </p:nvSpPr>
-        <p:spPr>
-          <a:xfrm>
-            <a:off x="5687568" y="2487168"/>
+          <p:cNvPr id="33" name="Shape 30"/>
+          <p:cNvSpPr/>
+          <p:nvPr/>
+        </p:nvSpPr>
+        <p:spPr>
+          <a:xfrm>
+            <a:off x="5687568" y="3145536"/>
             <a:ext cx="2834640" cy="256032"/>
           </a:xfrm>
           <a:prstGeom prst="rect">
@@ -13933,14 +13391,14 @@
       </p:sp>
       <p:sp>
         <p:nvSpPr>
-          <p:cNvPr id="30" name="Shape 27"/>
-          <p:cNvSpPr/>
-          <p:nvPr/>
-        </p:nvSpPr>
-        <p:spPr>
-          <a:xfrm>
-            <a:off x="5687568" y="2487168"/>
-            <a:ext cx="1553383" cy="256032"/>
+          <p:cNvPr id="34" name="Shape 31"/>
+          <p:cNvSpPr/>
+          <p:nvPr/>
+        </p:nvSpPr>
+        <p:spPr>
+          <a:xfrm>
+            <a:off x="5687568" y="3145536"/>
+            <a:ext cx="2233696" cy="256032"/>
           </a:xfrm>
           <a:prstGeom prst="rect">
             <a:avLst/>
@@ -13958,13 +13416,13 @@
       </p:sp>
       <p:sp>
         <p:nvSpPr>
-          <p:cNvPr id="31" name="Text 28"/>
-          <p:cNvSpPr/>
-          <p:nvPr/>
-        </p:nvSpPr>
-        <p:spPr>
-          <a:xfrm>
-            <a:off x="8595360" y="2487168"/>
+          <p:cNvPr id="35" name="Text 32"/>
+          <p:cNvSpPr/>
+          <p:nvPr/>
+        </p:nvSpPr>
+        <p:spPr>
+          <a:xfrm>
+            <a:off x="8595360" y="3145536"/>
             <a:ext cx="502920" cy="256032"/>
           </a:xfrm>
           <a:prstGeom prst="rect">
@@ -13989,7 +13447,7 @@
                 <a:ea typeface="Calibri" pitchFamily="34" charset="-122"/>
                 <a:cs typeface="Calibri" pitchFamily="34" charset="-120"/>
               </a:rPr>
-              <a:t>0.887 ▲</a:t>
+              <a:t>0.947 ▲</a:t>
             </a:r>
             <a:endParaRPr lang="en-US" sz="900" dirty="0"/>
           </a:p>
@@ -13997,13 +13455,13 @@
       </p:sp>
       <p:sp>
         <p:nvSpPr>
-          <p:cNvPr id="32" name="Text 29"/>
-          <p:cNvSpPr/>
-          <p:nvPr/>
-        </p:nvSpPr>
-        <p:spPr>
-          <a:xfrm>
-            <a:off x="5687568" y="2889504"/>
+          <p:cNvPr id="36" name="Text 33"/>
+          <p:cNvSpPr/>
+          <p:nvPr/>
+        </p:nvSpPr>
+        <p:spPr>
+          <a:xfrm>
+            <a:off x="5687568" y="3547872"/>
             <a:ext cx="3108960" cy="228600"/>
           </a:xfrm>
           <a:prstGeom prst="rect">
@@ -14028,7 +13486,7 @@
                 <a:ea typeface="Consolas" pitchFamily="34" charset="-122"/>
                 <a:cs typeface="Consolas" pitchFamily="34" charset="-120"/>
               </a:rPr>
-              <a:t>infra-security</a:t>
+              <a:t>observability</a:t>
             </a:r>
             <a:endParaRPr lang="en-US" sz="950" dirty="0"/>
           </a:p>
@@ -14036,13 +13494,13 @@
       </p:sp>
       <p:sp>
         <p:nvSpPr>
-          <p:cNvPr id="33" name="Shape 30"/>
-          <p:cNvSpPr/>
-          <p:nvPr/>
-        </p:nvSpPr>
-        <p:spPr>
-          <a:xfrm>
-            <a:off x="5687568" y="3145536"/>
+          <p:cNvPr id="37" name="Shape 34"/>
+          <p:cNvSpPr/>
+          <p:nvPr/>
+        </p:nvSpPr>
+        <p:spPr>
+          <a:xfrm>
+            <a:off x="5687568" y="3803904"/>
             <a:ext cx="2834640" cy="256032"/>
           </a:xfrm>
           <a:prstGeom prst="rect">
@@ -14061,24 +13519,24 @@
       </p:sp>
       <p:sp>
         <p:nvSpPr>
-          <p:cNvPr id="34" name="Shape 31"/>
-          <p:cNvSpPr/>
-          <p:nvPr/>
-        </p:nvSpPr>
-        <p:spPr>
-          <a:xfrm>
-            <a:off x="5687568" y="3145536"/>
-            <a:ext cx="2006925" cy="256032"/>
+          <p:cNvPr id="38" name="Shape 35"/>
+          <p:cNvSpPr/>
+          <p:nvPr/>
+        </p:nvSpPr>
+        <p:spPr>
+          <a:xfrm>
+            <a:off x="5687568" y="3803904"/>
+            <a:ext cx="192756" cy="256032"/>
           </a:xfrm>
           <a:prstGeom prst="rect">
             <a:avLst/>
           </a:prstGeom>
           <a:solidFill>
-            <a:srgbClr val="00A896"/>
+            <a:srgbClr val="5A8087"/>
           </a:solidFill>
           <a:ln w="12700">
             <a:solidFill>
-              <a:srgbClr val="00A896"/>
+              <a:srgbClr val="5A8087"/>
             </a:solidFill>
             <a:prstDash val="solid"/>
           </a:ln>
@@ -14086,13 +13544,13 @@
       </p:sp>
       <p:sp>
         <p:nvSpPr>
-          <p:cNvPr id="35" name="Text 32"/>
-          <p:cNvSpPr/>
-          <p:nvPr/>
-        </p:nvSpPr>
-        <p:spPr>
-          <a:xfrm>
-            <a:off x="8595360" y="3145536"/>
+          <p:cNvPr id="39" name="Text 36"/>
+          <p:cNvSpPr/>
+          <p:nvPr/>
+        </p:nvSpPr>
+        <p:spPr>
+          <a:xfrm>
+            <a:off x="8595360" y="3803904"/>
             <a:ext cx="502920" cy="256032"/>
           </a:xfrm>
           <a:prstGeom prst="rect">
@@ -14109,15 +13567,15 @@
               <a:buNone/>
             </a:pPr>
             <a:r>
-              <a:rPr lang="en-US" sz="900" b="1" dirty="0">
-                <a:solidFill>
-                  <a:srgbClr val="02C39A"/>
+              <a:rPr lang="en-US" sz="900" dirty="0">
+                <a:solidFill>
+                  <a:srgbClr val="5A8087"/>
                 </a:solidFill>
                 <a:latin typeface="Calibri" pitchFamily="34" charset="0"/>
                 <a:ea typeface="Calibri" pitchFamily="34" charset="-122"/>
                 <a:cs typeface="Calibri" pitchFamily="34" charset="-120"/>
               </a:rPr>
-              <a:t>0.927 ▲</a:t>
+              <a:t>0.767 —</a:t>
             </a:r>
             <a:endParaRPr lang="en-US" sz="900" dirty="0"/>
           </a:p>
@@ -14125,13 +13583,13 @@
       </p:sp>
       <p:sp>
         <p:nvSpPr>
-          <p:cNvPr id="36" name="Text 33"/>
-          <p:cNvSpPr/>
-          <p:nvPr/>
-        </p:nvSpPr>
-        <p:spPr>
-          <a:xfrm>
-            <a:off x="5687568" y="3547872"/>
+          <p:cNvPr id="40" name="Text 37"/>
+          <p:cNvSpPr/>
+          <p:nvPr/>
+        </p:nvSpPr>
+        <p:spPr>
+          <a:xfrm>
+            <a:off x="5687568" y="4206240"/>
             <a:ext cx="3108960" cy="228600"/>
           </a:xfrm>
           <a:prstGeom prst="rect">
@@ -14156,7 +13614,7 @@
                 <a:ea typeface="Consolas" pitchFamily="34" charset="-122"/>
                 <a:cs typeface="Consolas" pitchFamily="34" charset="-120"/>
               </a:rPr>
-              <a:t>observability</a:t>
+              <a:t>sdk-api</a:t>
             </a:r>
             <a:endParaRPr lang="en-US" sz="950" dirty="0"/>
           </a:p>
@@ -14164,13 +13622,13 @@
       </p:sp>
       <p:sp>
         <p:nvSpPr>
-          <p:cNvPr id="37" name="Shape 34"/>
-          <p:cNvSpPr/>
-          <p:nvPr/>
-        </p:nvSpPr>
-        <p:spPr>
-          <a:xfrm>
-            <a:off x="5687568" y="3803904"/>
+          <p:cNvPr id="41" name="Shape 38"/>
+          <p:cNvSpPr/>
+          <p:nvPr/>
+        </p:nvSpPr>
+        <p:spPr>
+          <a:xfrm>
+            <a:off x="5687568" y="4462272"/>
             <a:ext cx="2834640" cy="256032"/>
           </a:xfrm>
           <a:prstGeom prst="rect">
@@ -14189,14 +13647,14 @@
       </p:sp>
       <p:sp>
         <p:nvSpPr>
-          <p:cNvPr id="38" name="Shape 35"/>
-          <p:cNvSpPr/>
-          <p:nvPr/>
-        </p:nvSpPr>
-        <p:spPr>
-          <a:xfrm>
-            <a:off x="5687568" y="3803904"/>
-            <a:ext cx="589605" cy="256032"/>
+          <p:cNvPr id="42" name="Shape 39"/>
+          <p:cNvSpPr/>
+          <p:nvPr/>
+        </p:nvSpPr>
+        <p:spPr>
+          <a:xfrm>
+            <a:off x="5687568" y="4462272"/>
+            <a:ext cx="1927555" cy="256032"/>
           </a:xfrm>
           <a:prstGeom prst="rect">
             <a:avLst/>
@@ -14214,13 +13672,13 @@
       </p:sp>
       <p:sp>
         <p:nvSpPr>
-          <p:cNvPr id="39" name="Text 36"/>
-          <p:cNvSpPr/>
-          <p:nvPr/>
-        </p:nvSpPr>
-        <p:spPr>
-          <a:xfrm>
-            <a:off x="8595360" y="3803904"/>
+          <p:cNvPr id="43" name="Text 40"/>
+          <p:cNvSpPr/>
+          <p:nvPr/>
+        </p:nvSpPr>
+        <p:spPr>
+          <a:xfrm>
+            <a:off x="8595360" y="4462272"/>
             <a:ext cx="502920" cy="256032"/>
           </a:xfrm>
           <a:prstGeom prst="rect">
@@ -14245,135 +13703,7 @@
                 <a:ea typeface="Calibri" pitchFamily="34" charset="-122"/>
                 <a:cs typeface="Calibri" pitchFamily="34" charset="-120"/>
               </a:rPr>
-              <a:t>0.802 —</a:t>
-            </a:r>
-            <a:endParaRPr lang="en-US" sz="900" dirty="0"/>
-          </a:p>
-        </p:txBody>
-      </p:sp>
-      <p:sp>
-        <p:nvSpPr>
-          <p:cNvPr id="40" name="Text 37"/>
-          <p:cNvSpPr/>
-          <p:nvPr/>
-        </p:nvSpPr>
-        <p:spPr>
-          <a:xfrm>
-            <a:off x="5687568" y="4206240"/>
-            <a:ext cx="3108960" cy="228600"/>
-          </a:xfrm>
-          <a:prstGeom prst="rect">
-            <a:avLst/>
-          </a:prstGeom>
-          <a:noFill/>
-          <a:ln/>
-        </p:spPr>
-        <p:txBody>
-          <a:bodyPr wrap="square" lIns="0" tIns="0" rIns="0" bIns="0" rtlCol="0" anchor="ctr"/>
-          <a:lstStyle/>
-          <a:p>
-            <a:pPr indent="0" marL="0">
-              <a:buNone/>
-            </a:pPr>
-            <a:r>
-              <a:rPr lang="en-US" sz="950" dirty="0">
-                <a:solidFill>
-                  <a:srgbClr val="B8DADD"/>
-                </a:solidFill>
-                <a:latin typeface="Consolas" pitchFamily="34" charset="0"/>
-                <a:ea typeface="Consolas" pitchFamily="34" charset="-122"/>
-                <a:cs typeface="Consolas" pitchFamily="34" charset="-120"/>
-              </a:rPr>
-              <a:t>sdk-api</a:t>
-            </a:r>
-            <a:endParaRPr lang="en-US" sz="950" dirty="0"/>
-          </a:p>
-        </p:txBody>
-      </p:sp>
-      <p:sp>
-        <p:nvSpPr>
-          <p:cNvPr id="41" name="Shape 38"/>
-          <p:cNvSpPr/>
-          <p:nvPr/>
-        </p:nvSpPr>
-        <p:spPr>
-          <a:xfrm>
-            <a:off x="5687568" y="4462272"/>
-            <a:ext cx="2834640" cy="256032"/>
-          </a:xfrm>
-          <a:prstGeom prst="rect">
-            <a:avLst/>
-          </a:prstGeom>
-          <a:solidFill>
-            <a:srgbClr val="022C33"/>
-          </a:solidFill>
-          <a:ln w="12700">
-            <a:solidFill>
-              <a:srgbClr val="028090"/>
-            </a:solidFill>
-            <a:prstDash val="solid"/>
-          </a:ln>
-        </p:spPr>
-      </p:sp>
-      <p:sp>
-        <p:nvSpPr>
-          <p:cNvPr id="42" name="Shape 39"/>
-          <p:cNvSpPr/>
-          <p:nvPr/>
-        </p:nvSpPr>
-        <p:spPr>
-          <a:xfrm>
-            <a:off x="5687568" y="4462272"/>
-            <a:ext cx="2233696" cy="256032"/>
-          </a:xfrm>
-          <a:prstGeom prst="rect">
-            <a:avLst/>
-          </a:prstGeom>
-          <a:solidFill>
-            <a:srgbClr val="5A8087"/>
-          </a:solidFill>
-          <a:ln w="12700">
-            <a:solidFill>
-              <a:srgbClr val="5A8087"/>
-            </a:solidFill>
-            <a:prstDash val="solid"/>
-          </a:ln>
-        </p:spPr>
-      </p:sp>
-      <p:sp>
-        <p:nvSpPr>
-          <p:cNvPr id="43" name="Text 40"/>
-          <p:cNvSpPr/>
-          <p:nvPr/>
-        </p:nvSpPr>
-        <p:spPr>
-          <a:xfrm>
-            <a:off x="8595360" y="4462272"/>
-            <a:ext cx="502920" cy="256032"/>
-          </a:xfrm>
-          <a:prstGeom prst="rect">
-            <a:avLst/>
-          </a:prstGeom>
-          <a:noFill/>
-          <a:ln/>
-        </p:spPr>
-        <p:txBody>
-          <a:bodyPr wrap="square" lIns="0" tIns="0" rIns="0" bIns="0" rtlCol="0" anchor="ctr"/>
-          <a:lstStyle/>
-          <a:p>
-            <a:pPr indent="0" marL="0">
-              <a:buNone/>
-            </a:pPr>
-            <a:r>
-              <a:rPr lang="en-US" sz="900" dirty="0">
-                <a:solidFill>
-                  <a:srgbClr val="5A8087"/>
-                </a:solidFill>
-                <a:latin typeface="Calibri" pitchFamily="34" charset="0"/>
-                <a:ea typeface="Calibri" pitchFamily="34" charset="-122"/>
-                <a:cs typeface="Calibri" pitchFamily="34" charset="-120"/>
-              </a:rPr>
-              <a:t>0.947 —</a:t>
+              <a:t>0.92 —</a:t>
             </a:r>
             <a:endParaRPr lang="en-US" sz="900" dirty="0"/>
           </a:p>
@@ -14441,7 +13771,7 @@
                 <a:ea typeface="Calibri" pitchFamily="34" charset="-122"/>
                 <a:cs typeface="Calibri" pitchFamily="34" charset="-120"/>
               </a:rPr>
-              <a:t>docs-vnext leads in agent-development (0.971) and getting-started (0.887) — areas benefiting most from Mintlify MDX enhancements</a:t>
+              <a:t>docs-vnext leads in getting-started (0.857) and infra-security (0.947) — observability remains the improvement opportunity (0.767)</a:t>
             </a:r>
             <a:endParaRPr lang="en-US" sz="1050" dirty="0"/>
           </a:p>

</xml_diff>